<commit_message>
docs(sem4): enlarge Agenda rows so titles + subtitles fit without overlap
- row_h 0.38 -> 0.62 in  (title + subtitle no longer collide)
- title text: 11pt -> 12pt, subtitle: 9pt -> 10pt
- number '1..15' now vertically centred inside each row  (14pt bold)
- inter-row gap 0.10 -> 0.12 in for cleaner separation

Deck still fits in 22 slides on the same 13.33x7.5 canvas
(grid ends at y=6.85 in, well clear of the footer).
</commit_message>
<xml_diff>
--- a/docs/Sem_4/FINAL_PRESENTATION_VishalSingh_2020AA05641.pptx
+++ b/docs/Sem_4/FINAL_PRESENTATION_VishalSingh_2020AA05641.pptx
@@ -14219,8 +14219,8 @@
         </p:nvSpPr>
         <p:spPr>
           <a:xfrm>
-            <a:off x="457200" y="914400"/>
-            <a:ext cx="5623560" cy="347472"/>
+            <a:off x="457200" y="960120"/>
+            <a:ext cx="5623560" cy="566928"/>
           </a:xfrm>
           <a:prstGeom prst="rect">
             <a:avLst/>
@@ -14266,7 +14266,41 @@
         <p:spPr>
           <a:xfrm>
             <a:off x="548640" y="960120"/>
-            <a:ext cx="502920" cy="256032"/>
+            <a:ext cx="548640" cy="566928"/>
+          </a:xfrm>
+          <a:prstGeom prst="rect">
+            <a:avLst/>
+          </a:prstGeom>
+          <a:noFill/>
+        </p:spPr>
+        <p:txBody>
+          <a:bodyPr wrap="square" anchor="ctr">
+            <a:spAutoFit/>
+          </a:bodyPr>
+          <a:lstStyle/>
+          <a:p>
+            <a:pPr algn="l"/>
+            <a:r>
+              <a:rPr sz="1400" b="1">
+                <a:solidFill>
+                  <a:srgbClr val="0071DC"/>
+                </a:solidFill>
+              </a:rPr>
+              <a:t>1</a:t>
+            </a:r>
+          </a:p>
+        </p:txBody>
+      </p:sp>
+      <p:sp>
+        <p:nvSpPr>
+          <p:cNvPr id="8" name="TextBox 7"/>
+          <p:cNvSpPr txBox="1"/>
+          <p:nvPr/>
+        </p:nvSpPr>
+        <p:spPr>
+          <a:xfrm>
+            <a:off x="1143000" y="1024128"/>
+            <a:ext cx="4846320" cy="256032"/>
           </a:xfrm>
           <a:prstGeom prst="rect">
             <a:avLst/>
@@ -14283,24 +14317,24 @@
             <a:r>
               <a:rPr sz="1200" b="1">
                 <a:solidFill>
-                  <a:srgbClr val="0071DC"/>
-                </a:solidFill>
-              </a:rPr>
-              <a:t>1</a:t>
-            </a:r>
-          </a:p>
-        </p:txBody>
-      </p:sp>
-      <p:sp>
-        <p:nvSpPr>
-          <p:cNvPr id="8" name="TextBox 7"/>
-          <p:cNvSpPr txBox="1"/>
-          <p:nvPr/>
-        </p:nvSpPr>
-        <p:spPr>
-          <a:xfrm>
-            <a:off x="1097280" y="941832"/>
-            <a:ext cx="4892040" cy="182880"/>
+                  <a:srgbClr val="041E42"/>
+                </a:solidFill>
+              </a:rPr>
+              <a:t>Since Mid-Sem — What's New</a:t>
+            </a:r>
+          </a:p>
+        </p:txBody>
+      </p:sp>
+      <p:sp>
+        <p:nvSpPr>
+          <p:cNvPr id="9" name="TextBox 8"/>
+          <p:cNvSpPr txBox="1"/>
+          <p:nvPr/>
+        </p:nvSpPr>
+        <p:spPr>
+          <a:xfrm>
+            <a:off x="1143000" y="1271016"/>
+            <a:ext cx="4846320" cy="237744"/>
           </a:xfrm>
           <a:prstGeom prst="rect">
             <a:avLst/>
@@ -14315,41 +14349,7 @@
           <a:p>
             <a:pPr algn="l"/>
             <a:r>
-              <a:rPr sz="1100" b="1">
-                <a:solidFill>
-                  <a:srgbClr val="041E42"/>
-                </a:solidFill>
-              </a:rPr>
-              <a:t>Since Mid-Sem — What's New</a:t>
-            </a:r>
-          </a:p>
-        </p:txBody>
-      </p:sp>
-      <p:sp>
-        <p:nvSpPr>
-          <p:cNvPr id="9" name="TextBox 8"/>
-          <p:cNvSpPr txBox="1"/>
-          <p:nvPr/>
-        </p:nvSpPr>
-        <p:spPr>
-          <a:xfrm>
-            <a:off x="1097280" y="1097280"/>
-            <a:ext cx="4892040" cy="182880"/>
-          </a:xfrm>
-          <a:prstGeom prst="rect">
-            <a:avLst/>
-          </a:prstGeom>
-          <a:noFill/>
-        </p:spPr>
-        <p:txBody>
-          <a:bodyPr wrap="square" anchor="t">
-            <a:spAutoFit/>
-          </a:bodyPr>
-          <a:lstStyle/>
-          <a:p>
-            <a:pPr algn="l"/>
-            <a:r>
-              <a:rPr sz="900" b="0">
+              <a:rPr sz="1000" b="0">
                 <a:solidFill>
                   <a:srgbClr val="666666"/>
                 </a:solidFill>
@@ -14367,8 +14367,8 @@
         </p:nvSpPr>
         <p:spPr>
           <a:xfrm>
-            <a:off x="457200" y="1353312"/>
-            <a:ext cx="5623560" cy="347472"/>
+            <a:off x="457200" y="1636776"/>
+            <a:ext cx="5623560" cy="566928"/>
           </a:xfrm>
           <a:prstGeom prst="rect">
             <a:avLst/>
@@ -14413,8 +14413,42 @@
         </p:nvSpPr>
         <p:spPr>
           <a:xfrm>
-            <a:off x="548640" y="1399032"/>
-            <a:ext cx="502920" cy="256032"/>
+            <a:off x="548640" y="1636776"/>
+            <a:ext cx="548640" cy="566928"/>
+          </a:xfrm>
+          <a:prstGeom prst="rect">
+            <a:avLst/>
+          </a:prstGeom>
+          <a:noFill/>
+        </p:spPr>
+        <p:txBody>
+          <a:bodyPr wrap="square" anchor="ctr">
+            <a:spAutoFit/>
+          </a:bodyPr>
+          <a:lstStyle/>
+          <a:p>
+            <a:pPr algn="l"/>
+            <a:r>
+              <a:rPr sz="1400" b="1">
+                <a:solidFill>
+                  <a:srgbClr val="0071DC"/>
+                </a:solidFill>
+              </a:rPr>
+              <a:t>2</a:t>
+            </a:r>
+          </a:p>
+        </p:txBody>
+      </p:sp>
+      <p:sp>
+        <p:nvSpPr>
+          <p:cNvPr id="12" name="TextBox 11"/>
+          <p:cNvSpPr txBox="1"/>
+          <p:nvPr/>
+        </p:nvSpPr>
+        <p:spPr>
+          <a:xfrm>
+            <a:off x="1143000" y="1700784"/>
+            <a:ext cx="4846320" cy="256032"/>
           </a:xfrm>
           <a:prstGeom prst="rect">
             <a:avLst/>
@@ -14431,24 +14465,24 @@
             <a:r>
               <a:rPr sz="1200" b="1">
                 <a:solidFill>
-                  <a:srgbClr val="0071DC"/>
-                </a:solidFill>
-              </a:rPr>
-              <a:t>2</a:t>
-            </a:r>
-          </a:p>
-        </p:txBody>
-      </p:sp>
-      <p:sp>
-        <p:nvSpPr>
-          <p:cNvPr id="12" name="TextBox 11"/>
-          <p:cNvSpPr txBox="1"/>
-          <p:nvPr/>
-        </p:nvSpPr>
-        <p:spPr>
-          <a:xfrm>
-            <a:off x="1097280" y="1380744"/>
-            <a:ext cx="4892040" cy="182880"/>
+                  <a:srgbClr val="041E42"/>
+                </a:solidFill>
+              </a:rPr>
+              <a:t>Review &amp; Validate  (HITL)</a:t>
+            </a:r>
+          </a:p>
+        </p:txBody>
+      </p:sp>
+      <p:sp>
+        <p:nvSpPr>
+          <p:cNvPr id="13" name="TextBox 12"/>
+          <p:cNvSpPr txBox="1"/>
+          <p:nvPr/>
+        </p:nvSpPr>
+        <p:spPr>
+          <a:xfrm>
+            <a:off x="1143000" y="1947672"/>
+            <a:ext cx="4846320" cy="237744"/>
           </a:xfrm>
           <a:prstGeom prst="rect">
             <a:avLst/>
@@ -14463,41 +14497,7 @@
           <a:p>
             <a:pPr algn="l"/>
             <a:r>
-              <a:rPr sz="1100" b="1">
-                <a:solidFill>
-                  <a:srgbClr val="041E42"/>
-                </a:solidFill>
-              </a:rPr>
-              <a:t>Review &amp; Validate  (HITL)</a:t>
-            </a:r>
-          </a:p>
-        </p:txBody>
-      </p:sp>
-      <p:sp>
-        <p:nvSpPr>
-          <p:cNvPr id="13" name="TextBox 12"/>
-          <p:cNvSpPr txBox="1"/>
-          <p:nvPr/>
-        </p:nvSpPr>
-        <p:spPr>
-          <a:xfrm>
-            <a:off x="1097280" y="1536192"/>
-            <a:ext cx="4892040" cy="182880"/>
-          </a:xfrm>
-          <a:prstGeom prst="rect">
-            <a:avLst/>
-          </a:prstGeom>
-          <a:noFill/>
-        </p:spPr>
-        <p:txBody>
-          <a:bodyPr wrap="square" anchor="t">
-            <a:spAutoFit/>
-          </a:bodyPr>
-          <a:lstStyle/>
-          <a:p>
-            <a:pPr algn="l"/>
-            <a:r>
-              <a:rPr sz="900" b="0">
+              <a:rPr sz="1000" b="0">
                 <a:solidFill>
                   <a:srgbClr val="666666"/>
                 </a:solidFill>
@@ -14515,8 +14515,8 @@
         </p:nvSpPr>
         <p:spPr>
           <a:xfrm>
-            <a:off x="457200" y="1792224"/>
-            <a:ext cx="5623560" cy="347472"/>
+            <a:off x="457200" y="2313432"/>
+            <a:ext cx="5623560" cy="566928"/>
           </a:xfrm>
           <a:prstGeom prst="rect">
             <a:avLst/>
@@ -14561,8 +14561,42 @@
         </p:nvSpPr>
         <p:spPr>
           <a:xfrm>
-            <a:off x="548640" y="1837944"/>
-            <a:ext cx="502920" cy="256032"/>
+            <a:off x="548640" y="2313432"/>
+            <a:ext cx="548640" cy="566928"/>
+          </a:xfrm>
+          <a:prstGeom prst="rect">
+            <a:avLst/>
+          </a:prstGeom>
+          <a:noFill/>
+        </p:spPr>
+        <p:txBody>
+          <a:bodyPr wrap="square" anchor="ctr">
+            <a:spAutoFit/>
+          </a:bodyPr>
+          <a:lstStyle/>
+          <a:p>
+            <a:pPr algn="l"/>
+            <a:r>
+              <a:rPr sz="1400" b="1">
+                <a:solidFill>
+                  <a:srgbClr val="0071DC"/>
+                </a:solidFill>
+              </a:rPr>
+              <a:t>3</a:t>
+            </a:r>
+          </a:p>
+        </p:txBody>
+      </p:sp>
+      <p:sp>
+        <p:nvSpPr>
+          <p:cNvPr id="16" name="TextBox 15"/>
+          <p:cNvSpPr txBox="1"/>
+          <p:nvPr/>
+        </p:nvSpPr>
+        <p:spPr>
+          <a:xfrm>
+            <a:off x="1143000" y="2377440"/>
+            <a:ext cx="4846320" cy="256032"/>
           </a:xfrm>
           <a:prstGeom prst="rect">
             <a:avLst/>
@@ -14579,24 +14613,24 @@
             <a:r>
               <a:rPr sz="1200" b="1">
                 <a:solidFill>
-                  <a:srgbClr val="0071DC"/>
-                </a:solidFill>
-              </a:rPr>
-              <a:t>3</a:t>
-            </a:r>
-          </a:p>
-        </p:txBody>
-      </p:sp>
-      <p:sp>
-        <p:nvSpPr>
-          <p:cNvPr id="16" name="TextBox 15"/>
-          <p:cNvSpPr txBox="1"/>
-          <p:nvPr/>
-        </p:nvSpPr>
-        <p:spPr>
-          <a:xfrm>
-            <a:off x="1097280" y="1819656"/>
-            <a:ext cx="4892040" cy="182880"/>
+                  <a:srgbClr val="041E42"/>
+                </a:solidFill>
+              </a:rPr>
+              <a:t>Smart Reply  —  Triple Draft</a:t>
+            </a:r>
+          </a:p>
+        </p:txBody>
+      </p:sp>
+      <p:sp>
+        <p:nvSpPr>
+          <p:cNvPr id="17" name="TextBox 16"/>
+          <p:cNvSpPr txBox="1"/>
+          <p:nvPr/>
+        </p:nvSpPr>
+        <p:spPr>
+          <a:xfrm>
+            <a:off x="1143000" y="2624328"/>
+            <a:ext cx="4846320" cy="237744"/>
           </a:xfrm>
           <a:prstGeom prst="rect">
             <a:avLst/>
@@ -14611,41 +14645,7 @@
           <a:p>
             <a:pPr algn="l"/>
             <a:r>
-              <a:rPr sz="1100" b="1">
-                <a:solidFill>
-                  <a:srgbClr val="041E42"/>
-                </a:solidFill>
-              </a:rPr>
-              <a:t>Smart Reply  —  Triple Draft</a:t>
-            </a:r>
-          </a:p>
-        </p:txBody>
-      </p:sp>
-      <p:sp>
-        <p:nvSpPr>
-          <p:cNvPr id="17" name="TextBox 16"/>
-          <p:cNvSpPr txBox="1"/>
-          <p:nvPr/>
-        </p:nvSpPr>
-        <p:spPr>
-          <a:xfrm>
-            <a:off x="1097280" y="1975104"/>
-            <a:ext cx="4892040" cy="182880"/>
-          </a:xfrm>
-          <a:prstGeom prst="rect">
-            <a:avLst/>
-          </a:prstGeom>
-          <a:noFill/>
-        </p:spPr>
-        <p:txBody>
-          <a:bodyPr wrap="square" anchor="t">
-            <a:spAutoFit/>
-          </a:bodyPr>
-          <a:lstStyle/>
-          <a:p>
-            <a:pPr algn="l"/>
-            <a:r>
-              <a:rPr sz="900" b="0">
+              <a:rPr sz="1000" b="0">
                 <a:solidFill>
                   <a:srgbClr val="666666"/>
                 </a:solidFill>
@@ -14663,8 +14663,8 @@
         </p:nvSpPr>
         <p:spPr>
           <a:xfrm>
-            <a:off x="457200" y="2231136"/>
-            <a:ext cx="5623560" cy="347472"/>
+            <a:off x="457200" y="2990088"/>
+            <a:ext cx="5623560" cy="566928"/>
           </a:xfrm>
           <a:prstGeom prst="rect">
             <a:avLst/>
@@ -14709,8 +14709,42 @@
         </p:nvSpPr>
         <p:spPr>
           <a:xfrm>
-            <a:off x="548640" y="2276856"/>
-            <a:ext cx="502920" cy="256032"/>
+            <a:off x="548640" y="2990088"/>
+            <a:ext cx="548640" cy="566928"/>
+          </a:xfrm>
+          <a:prstGeom prst="rect">
+            <a:avLst/>
+          </a:prstGeom>
+          <a:noFill/>
+        </p:spPr>
+        <p:txBody>
+          <a:bodyPr wrap="square" anchor="ctr">
+            <a:spAutoFit/>
+          </a:bodyPr>
+          <a:lstStyle/>
+          <a:p>
+            <a:pPr algn="l"/>
+            <a:r>
+              <a:rPr sz="1400" b="1">
+                <a:solidFill>
+                  <a:srgbClr val="0071DC"/>
+                </a:solidFill>
+              </a:rPr>
+              <a:t>4</a:t>
+            </a:r>
+          </a:p>
+        </p:txBody>
+      </p:sp>
+      <p:sp>
+        <p:nvSpPr>
+          <p:cNvPr id="20" name="TextBox 19"/>
+          <p:cNvSpPr txBox="1"/>
+          <p:nvPr/>
+        </p:nvSpPr>
+        <p:spPr>
+          <a:xfrm>
+            <a:off x="1143000" y="3054096"/>
+            <a:ext cx="4846320" cy="256032"/>
           </a:xfrm>
           <a:prstGeom prst="rect">
             <a:avLst/>
@@ -14727,24 +14761,24 @@
             <a:r>
               <a:rPr sz="1200" b="1">
                 <a:solidFill>
-                  <a:srgbClr val="0071DC"/>
-                </a:solidFill>
-              </a:rPr>
-              <a:t>4</a:t>
-            </a:r>
-          </a:p>
-        </p:txBody>
-      </p:sp>
-      <p:sp>
-        <p:nvSpPr>
-          <p:cNvPr id="20" name="TextBox 19"/>
-          <p:cNvSpPr txBox="1"/>
-          <p:nvPr/>
-        </p:nvSpPr>
-        <p:spPr>
-          <a:xfrm>
-            <a:off x="1097280" y="2258568"/>
-            <a:ext cx="4892040" cy="182880"/>
+                  <a:srgbClr val="041E42"/>
+                </a:solidFill>
+              </a:rPr>
+              <a:t>Smart Reply  —  Prompt &amp; Few-Shot</a:t>
+            </a:r>
+          </a:p>
+        </p:txBody>
+      </p:sp>
+      <p:sp>
+        <p:nvSpPr>
+          <p:cNvPr id="21" name="TextBox 20"/>
+          <p:cNvSpPr txBox="1"/>
+          <p:nvPr/>
+        </p:nvSpPr>
+        <p:spPr>
+          <a:xfrm>
+            <a:off x="1143000" y="3300984"/>
+            <a:ext cx="4846320" cy="237744"/>
           </a:xfrm>
           <a:prstGeom prst="rect">
             <a:avLst/>
@@ -14759,41 +14793,7 @@
           <a:p>
             <a:pPr algn="l"/>
             <a:r>
-              <a:rPr sz="1100" b="1">
-                <a:solidFill>
-                  <a:srgbClr val="041E42"/>
-                </a:solidFill>
-              </a:rPr>
-              <a:t>Smart Reply  —  Prompt &amp; Few-Shot</a:t>
-            </a:r>
-          </a:p>
-        </p:txBody>
-      </p:sp>
-      <p:sp>
-        <p:nvSpPr>
-          <p:cNvPr id="21" name="TextBox 20"/>
-          <p:cNvSpPr txBox="1"/>
-          <p:nvPr/>
-        </p:nvSpPr>
-        <p:spPr>
-          <a:xfrm>
-            <a:off x="1097280" y="2414016"/>
-            <a:ext cx="4892040" cy="182880"/>
-          </a:xfrm>
-          <a:prstGeom prst="rect">
-            <a:avLst/>
-          </a:prstGeom>
-          <a:noFill/>
-        </p:spPr>
-        <p:txBody>
-          <a:bodyPr wrap="square" anchor="t">
-            <a:spAutoFit/>
-          </a:bodyPr>
-          <a:lstStyle/>
-          <a:p>
-            <a:pPr algn="l"/>
-            <a:r>
-              <a:rPr sz="900" b="0">
+              <a:rPr sz="1000" b="0">
                 <a:solidFill>
                   <a:srgbClr val="666666"/>
                 </a:solidFill>
@@ -14811,8 +14811,8 @@
         </p:nvSpPr>
         <p:spPr>
           <a:xfrm>
-            <a:off x="457200" y="2670048"/>
-            <a:ext cx="5623560" cy="347472"/>
+            <a:off x="457200" y="3666744"/>
+            <a:ext cx="5623560" cy="566928"/>
           </a:xfrm>
           <a:prstGeom prst="rect">
             <a:avLst/>
@@ -14857,8 +14857,42 @@
         </p:nvSpPr>
         <p:spPr>
           <a:xfrm>
-            <a:off x="548640" y="2715768"/>
-            <a:ext cx="502920" cy="256032"/>
+            <a:off x="548640" y="3666744"/>
+            <a:ext cx="548640" cy="566928"/>
+          </a:xfrm>
+          <a:prstGeom prst="rect">
+            <a:avLst/>
+          </a:prstGeom>
+          <a:noFill/>
+        </p:spPr>
+        <p:txBody>
+          <a:bodyPr wrap="square" anchor="ctr">
+            <a:spAutoFit/>
+          </a:bodyPr>
+          <a:lstStyle/>
+          <a:p>
+            <a:pPr algn="l"/>
+            <a:r>
+              <a:rPr sz="1400" b="1">
+                <a:solidFill>
+                  <a:srgbClr val="0071DC"/>
+                </a:solidFill>
+              </a:rPr>
+              <a:t>5</a:t>
+            </a:r>
+          </a:p>
+        </p:txBody>
+      </p:sp>
+      <p:sp>
+        <p:nvSpPr>
+          <p:cNvPr id="24" name="TextBox 23"/>
+          <p:cNvSpPr txBox="1"/>
+          <p:nvPr/>
+        </p:nvSpPr>
+        <p:spPr>
+          <a:xfrm>
+            <a:off x="1143000" y="3730752"/>
+            <a:ext cx="4846320" cy="256032"/>
           </a:xfrm>
           <a:prstGeom prst="rect">
             <a:avLst/>
@@ -14875,24 +14909,24 @@
             <a:r>
               <a:rPr sz="1200" b="1">
                 <a:solidFill>
-                  <a:srgbClr val="0071DC"/>
-                </a:solidFill>
-              </a:rPr>
-              <a:t>5</a:t>
-            </a:r>
-          </a:p>
-        </p:txBody>
-      </p:sp>
-      <p:sp>
-        <p:nvSpPr>
-          <p:cNvPr id="24" name="TextBox 23"/>
-          <p:cNvSpPr txBox="1"/>
-          <p:nvPr/>
-        </p:nvSpPr>
-        <p:spPr>
-          <a:xfrm>
-            <a:off x="1097280" y="2697480"/>
-            <a:ext cx="4892040" cy="182880"/>
+                  <a:srgbClr val="041E42"/>
+                </a:solidFill>
+              </a:rPr>
+              <a:t>Smart Reply  —  Worked Example</a:t>
+            </a:r>
+          </a:p>
+        </p:txBody>
+      </p:sp>
+      <p:sp>
+        <p:nvSpPr>
+          <p:cNvPr id="25" name="TextBox 24"/>
+          <p:cNvSpPr txBox="1"/>
+          <p:nvPr/>
+        </p:nvSpPr>
+        <p:spPr>
+          <a:xfrm>
+            <a:off x="1143000" y="3977640"/>
+            <a:ext cx="4846320" cy="237744"/>
           </a:xfrm>
           <a:prstGeom prst="rect">
             <a:avLst/>
@@ -14907,41 +14941,7 @@
           <a:p>
             <a:pPr algn="l"/>
             <a:r>
-              <a:rPr sz="1100" b="1">
-                <a:solidFill>
-                  <a:srgbClr val="041E42"/>
-                </a:solidFill>
-              </a:rPr>
-              <a:t>Smart Reply  —  Worked Example</a:t>
-            </a:r>
-          </a:p>
-        </p:txBody>
-      </p:sp>
-      <p:sp>
-        <p:nvSpPr>
-          <p:cNvPr id="25" name="TextBox 24"/>
-          <p:cNvSpPr txBox="1"/>
-          <p:nvPr/>
-        </p:nvSpPr>
-        <p:spPr>
-          <a:xfrm>
-            <a:off x="1097280" y="2852928"/>
-            <a:ext cx="4892040" cy="182880"/>
-          </a:xfrm>
-          <a:prstGeom prst="rect">
-            <a:avLst/>
-          </a:prstGeom>
-          <a:noFill/>
-        </p:spPr>
-        <p:txBody>
-          <a:bodyPr wrap="square" anchor="t">
-            <a:spAutoFit/>
-          </a:bodyPr>
-          <a:lstStyle/>
-          <a:p>
-            <a:pPr algn="l"/>
-            <a:r>
-              <a:rPr sz="900" b="0">
+              <a:rPr sz="1000" b="0">
                 <a:solidFill>
                   <a:srgbClr val="666666"/>
                 </a:solidFill>
@@ -14959,8 +14959,8 @@
         </p:nvSpPr>
         <p:spPr>
           <a:xfrm>
-            <a:off x="457200" y="3108960"/>
-            <a:ext cx="5623560" cy="347472"/>
+            <a:off x="457200" y="4343400"/>
+            <a:ext cx="5623560" cy="566928"/>
           </a:xfrm>
           <a:prstGeom prst="rect">
             <a:avLst/>
@@ -15005,8 +15005,42 @@
         </p:nvSpPr>
         <p:spPr>
           <a:xfrm>
-            <a:off x="548640" y="3154680"/>
-            <a:ext cx="502920" cy="256032"/>
+            <a:off x="548640" y="4343400"/>
+            <a:ext cx="548640" cy="566928"/>
+          </a:xfrm>
+          <a:prstGeom prst="rect">
+            <a:avLst/>
+          </a:prstGeom>
+          <a:noFill/>
+        </p:spPr>
+        <p:txBody>
+          <a:bodyPr wrap="square" anchor="ctr">
+            <a:spAutoFit/>
+          </a:bodyPr>
+          <a:lstStyle/>
+          <a:p>
+            <a:pPr algn="l"/>
+            <a:r>
+              <a:rPr sz="1400" b="1">
+                <a:solidFill>
+                  <a:srgbClr val="0071DC"/>
+                </a:solidFill>
+              </a:rPr>
+              <a:t>6</a:t>
+            </a:r>
+          </a:p>
+        </p:txBody>
+      </p:sp>
+      <p:sp>
+        <p:nvSpPr>
+          <p:cNvPr id="28" name="TextBox 27"/>
+          <p:cNvSpPr txBox="1"/>
+          <p:nvPr/>
+        </p:nvSpPr>
+        <p:spPr>
+          <a:xfrm>
+            <a:off x="1143000" y="4407408"/>
+            <a:ext cx="4846320" cy="256032"/>
           </a:xfrm>
           <a:prstGeom prst="rect">
             <a:avLst/>
@@ -15023,24 +15057,24 @@
             <a:r>
               <a:rPr sz="1200" b="1">
                 <a:solidFill>
-                  <a:srgbClr val="0071DC"/>
-                </a:solidFill>
-              </a:rPr>
-              <a:t>6</a:t>
-            </a:r>
-          </a:p>
-        </p:txBody>
-      </p:sp>
-      <p:sp>
-        <p:nvSpPr>
-          <p:cNvPr id="28" name="TextBox 27"/>
-          <p:cNvSpPr txBox="1"/>
-          <p:nvPr/>
-        </p:nvSpPr>
-        <p:spPr>
-          <a:xfrm>
-            <a:off x="1097280" y="3136392"/>
-            <a:ext cx="4892040" cy="182880"/>
+                  <a:srgbClr val="041E42"/>
+                </a:solidFill>
+              </a:rPr>
+              <a:t>Learning Loop</a:t>
+            </a:r>
+          </a:p>
+        </p:txBody>
+      </p:sp>
+      <p:sp>
+        <p:nvSpPr>
+          <p:cNvPr id="29" name="TextBox 28"/>
+          <p:cNvSpPr txBox="1"/>
+          <p:nvPr/>
+        </p:nvSpPr>
+        <p:spPr>
+          <a:xfrm>
+            <a:off x="1143000" y="4654296"/>
+            <a:ext cx="4846320" cy="237744"/>
           </a:xfrm>
           <a:prstGeom prst="rect">
             <a:avLst/>
@@ -15055,41 +15089,7 @@
           <a:p>
             <a:pPr algn="l"/>
             <a:r>
-              <a:rPr sz="1100" b="1">
-                <a:solidFill>
-                  <a:srgbClr val="041E42"/>
-                </a:solidFill>
-              </a:rPr>
-              <a:t>Learning Loop</a:t>
-            </a:r>
-          </a:p>
-        </p:txBody>
-      </p:sp>
-      <p:sp>
-        <p:nvSpPr>
-          <p:cNvPr id="29" name="TextBox 28"/>
-          <p:cNvSpPr txBox="1"/>
-          <p:nvPr/>
-        </p:nvSpPr>
-        <p:spPr>
-          <a:xfrm>
-            <a:off x="1097280" y="3291840"/>
-            <a:ext cx="4892040" cy="182880"/>
-          </a:xfrm>
-          <a:prstGeom prst="rect">
-            <a:avLst/>
-          </a:prstGeom>
-          <a:noFill/>
-        </p:spPr>
-        <p:txBody>
-          <a:bodyPr wrap="square" anchor="t">
-            <a:spAutoFit/>
-          </a:bodyPr>
-          <a:lstStyle/>
-          <a:p>
-            <a:pPr algn="l"/>
-            <a:r>
-              <a:rPr sz="900" b="0">
+              <a:rPr sz="1000" b="0">
                 <a:solidFill>
                   <a:srgbClr val="666666"/>
                 </a:solidFill>
@@ -15107,8 +15107,8 @@
         </p:nvSpPr>
         <p:spPr>
           <a:xfrm>
-            <a:off x="457200" y="3547872"/>
-            <a:ext cx="5623560" cy="347472"/>
+            <a:off x="457200" y="5020056"/>
+            <a:ext cx="5623560" cy="566928"/>
           </a:xfrm>
           <a:prstGeom prst="rect">
             <a:avLst/>
@@ -15153,8 +15153,42 @@
         </p:nvSpPr>
         <p:spPr>
           <a:xfrm>
-            <a:off x="548640" y="3593592"/>
-            <a:ext cx="502920" cy="256032"/>
+            <a:off x="548640" y="5020056"/>
+            <a:ext cx="548640" cy="566928"/>
+          </a:xfrm>
+          <a:prstGeom prst="rect">
+            <a:avLst/>
+          </a:prstGeom>
+          <a:noFill/>
+        </p:spPr>
+        <p:txBody>
+          <a:bodyPr wrap="square" anchor="ctr">
+            <a:spAutoFit/>
+          </a:bodyPr>
+          <a:lstStyle/>
+          <a:p>
+            <a:pPr algn="l"/>
+            <a:r>
+              <a:rPr sz="1400" b="1">
+                <a:solidFill>
+                  <a:srgbClr val="0071DC"/>
+                </a:solidFill>
+              </a:rPr>
+              <a:t>7</a:t>
+            </a:r>
+          </a:p>
+        </p:txBody>
+      </p:sp>
+      <p:sp>
+        <p:nvSpPr>
+          <p:cNvPr id="32" name="TextBox 31"/>
+          <p:cNvSpPr txBox="1"/>
+          <p:nvPr/>
+        </p:nvSpPr>
+        <p:spPr>
+          <a:xfrm>
+            <a:off x="1143000" y="5084064"/>
+            <a:ext cx="4846320" cy="256032"/>
           </a:xfrm>
           <a:prstGeom prst="rect">
             <a:avLst/>
@@ -15171,24 +15205,24 @@
             <a:r>
               <a:rPr sz="1200" b="1">
                 <a:solidFill>
-                  <a:srgbClr val="0071DC"/>
-                </a:solidFill>
-              </a:rPr>
-              <a:t>7</a:t>
-            </a:r>
-          </a:p>
-        </p:txBody>
-      </p:sp>
-      <p:sp>
-        <p:nvSpPr>
-          <p:cNvPr id="32" name="TextBox 31"/>
-          <p:cNvSpPr txBox="1"/>
-          <p:nvPr/>
-        </p:nvSpPr>
-        <p:spPr>
-          <a:xfrm>
-            <a:off x="1097280" y="3575304"/>
-            <a:ext cx="4892040" cy="182880"/>
+                  <a:srgbClr val="041E42"/>
+                </a:solidFill>
+              </a:rPr>
+              <a:t>Post Explorer</a:t>
+            </a:r>
+          </a:p>
+        </p:txBody>
+      </p:sp>
+      <p:sp>
+        <p:nvSpPr>
+          <p:cNvPr id="33" name="TextBox 32"/>
+          <p:cNvSpPr txBox="1"/>
+          <p:nvPr/>
+        </p:nvSpPr>
+        <p:spPr>
+          <a:xfrm>
+            <a:off x="1143000" y="5330952"/>
+            <a:ext cx="4846320" cy="237744"/>
           </a:xfrm>
           <a:prstGeom prst="rect">
             <a:avLst/>
@@ -15203,41 +15237,7 @@
           <a:p>
             <a:pPr algn="l"/>
             <a:r>
-              <a:rPr sz="1100" b="1">
-                <a:solidFill>
-                  <a:srgbClr val="041E42"/>
-                </a:solidFill>
-              </a:rPr>
-              <a:t>Post Explorer</a:t>
-            </a:r>
-          </a:p>
-        </p:txBody>
-      </p:sp>
-      <p:sp>
-        <p:nvSpPr>
-          <p:cNvPr id="33" name="TextBox 32"/>
-          <p:cNvSpPr txBox="1"/>
-          <p:nvPr/>
-        </p:nvSpPr>
-        <p:spPr>
-          <a:xfrm>
-            <a:off x="1097280" y="3730752"/>
-            <a:ext cx="4892040" cy="182880"/>
-          </a:xfrm>
-          <a:prstGeom prst="rect">
-            <a:avLst/>
-          </a:prstGeom>
-          <a:noFill/>
-        </p:spPr>
-        <p:txBody>
-          <a:bodyPr wrap="square" anchor="t">
-            <a:spAutoFit/>
-          </a:bodyPr>
-          <a:lstStyle/>
-          <a:p>
-            <a:pPr algn="l"/>
-            <a:r>
-              <a:rPr sz="900" b="0">
+              <a:rPr sz="1000" b="0">
                 <a:solidFill>
                   <a:srgbClr val="666666"/>
                 </a:solidFill>
@@ -15255,8 +15255,8 @@
         </p:nvSpPr>
         <p:spPr>
           <a:xfrm>
-            <a:off x="457200" y="3986784"/>
-            <a:ext cx="5623560" cy="347472"/>
+            <a:off x="457200" y="5696712"/>
+            <a:ext cx="5623560" cy="566928"/>
           </a:xfrm>
           <a:prstGeom prst="rect">
             <a:avLst/>
@@ -15301,8 +15301,42 @@
         </p:nvSpPr>
         <p:spPr>
           <a:xfrm>
-            <a:off x="548640" y="4032504"/>
-            <a:ext cx="502920" cy="256032"/>
+            <a:off x="548640" y="5696712"/>
+            <a:ext cx="548640" cy="566928"/>
+          </a:xfrm>
+          <a:prstGeom prst="rect">
+            <a:avLst/>
+          </a:prstGeom>
+          <a:noFill/>
+        </p:spPr>
+        <p:txBody>
+          <a:bodyPr wrap="square" anchor="ctr">
+            <a:spAutoFit/>
+          </a:bodyPr>
+          <a:lstStyle/>
+          <a:p>
+            <a:pPr algn="l"/>
+            <a:r>
+              <a:rPr sz="1400" b="1">
+                <a:solidFill>
+                  <a:srgbClr val="0071DC"/>
+                </a:solidFill>
+              </a:rPr>
+              <a:t>8</a:t>
+            </a:r>
+          </a:p>
+        </p:txBody>
+      </p:sp>
+      <p:sp>
+        <p:nvSpPr>
+          <p:cNvPr id="36" name="TextBox 35"/>
+          <p:cNvSpPr txBox="1"/>
+          <p:nvPr/>
+        </p:nvSpPr>
+        <p:spPr>
+          <a:xfrm>
+            <a:off x="1143000" y="5760720"/>
+            <a:ext cx="4846320" cy="256032"/>
           </a:xfrm>
           <a:prstGeom prst="rect">
             <a:avLst/>
@@ -15319,24 +15353,24 @@
             <a:r>
               <a:rPr sz="1200" b="1">
                 <a:solidFill>
-                  <a:srgbClr val="0071DC"/>
-                </a:solidFill>
-              </a:rPr>
-              <a:t>8</a:t>
-            </a:r>
-          </a:p>
-        </p:txBody>
-      </p:sp>
-      <p:sp>
-        <p:nvSpPr>
-          <p:cNvPr id="36" name="TextBox 35"/>
-          <p:cNvSpPr txBox="1"/>
-          <p:nvPr/>
-        </p:nvSpPr>
-        <p:spPr>
-          <a:xfrm>
-            <a:off x="1097280" y="4014216"/>
-            <a:ext cx="4892040" cy="182880"/>
+                  <a:srgbClr val="041E42"/>
+                </a:solidFill>
+              </a:rPr>
+              <a:t>Post Lifecycle  (Kanban)</a:t>
+            </a:r>
+          </a:p>
+        </p:txBody>
+      </p:sp>
+      <p:sp>
+        <p:nvSpPr>
+          <p:cNvPr id="37" name="TextBox 36"/>
+          <p:cNvSpPr txBox="1"/>
+          <p:nvPr/>
+        </p:nvSpPr>
+        <p:spPr>
+          <a:xfrm>
+            <a:off x="1143000" y="6007608"/>
+            <a:ext cx="4846320" cy="237744"/>
           </a:xfrm>
           <a:prstGeom prst="rect">
             <a:avLst/>
@@ -15351,41 +15385,7 @@
           <a:p>
             <a:pPr algn="l"/>
             <a:r>
-              <a:rPr sz="1100" b="1">
-                <a:solidFill>
-                  <a:srgbClr val="041E42"/>
-                </a:solidFill>
-              </a:rPr>
-              <a:t>Post Lifecycle  (Kanban)</a:t>
-            </a:r>
-          </a:p>
-        </p:txBody>
-      </p:sp>
-      <p:sp>
-        <p:nvSpPr>
-          <p:cNvPr id="37" name="TextBox 36"/>
-          <p:cNvSpPr txBox="1"/>
-          <p:nvPr/>
-        </p:nvSpPr>
-        <p:spPr>
-          <a:xfrm>
-            <a:off x="1097280" y="4169664"/>
-            <a:ext cx="4892040" cy="182880"/>
-          </a:xfrm>
-          <a:prstGeom prst="rect">
-            <a:avLst/>
-          </a:prstGeom>
-          <a:noFill/>
-        </p:spPr>
-        <p:txBody>
-          <a:bodyPr wrap="square" anchor="t">
-            <a:spAutoFit/>
-          </a:bodyPr>
-          <a:lstStyle/>
-          <a:p>
-            <a:pPr algn="l"/>
-            <a:r>
-              <a:rPr sz="900" b="0">
+              <a:rPr sz="1000" b="0">
                 <a:solidFill>
                   <a:srgbClr val="666666"/>
                 </a:solidFill>
@@ -15403,8 +15403,8 @@
         </p:nvSpPr>
         <p:spPr>
           <a:xfrm>
-            <a:off x="6217920" y="914400"/>
-            <a:ext cx="5623560" cy="347472"/>
+            <a:off x="6217920" y="960120"/>
+            <a:ext cx="5623560" cy="566928"/>
           </a:xfrm>
           <a:prstGeom prst="rect">
             <a:avLst/>
@@ -15450,7 +15450,41 @@
         <p:spPr>
           <a:xfrm>
             <a:off x="6309360" y="960120"/>
-            <a:ext cx="502920" cy="256032"/>
+            <a:ext cx="548640" cy="566928"/>
+          </a:xfrm>
+          <a:prstGeom prst="rect">
+            <a:avLst/>
+          </a:prstGeom>
+          <a:noFill/>
+        </p:spPr>
+        <p:txBody>
+          <a:bodyPr wrap="square" anchor="ctr">
+            <a:spAutoFit/>
+          </a:bodyPr>
+          <a:lstStyle/>
+          <a:p>
+            <a:pPr algn="l"/>
+            <a:r>
+              <a:rPr sz="1400" b="1">
+                <a:solidFill>
+                  <a:srgbClr val="0071DC"/>
+                </a:solidFill>
+              </a:rPr>
+              <a:t>9</a:t>
+            </a:r>
+          </a:p>
+        </p:txBody>
+      </p:sp>
+      <p:sp>
+        <p:nvSpPr>
+          <p:cNvPr id="40" name="TextBox 39"/>
+          <p:cNvSpPr txBox="1"/>
+          <p:nvPr/>
+        </p:nvSpPr>
+        <p:spPr>
+          <a:xfrm>
+            <a:off x="6903720" y="1024128"/>
+            <a:ext cx="4846320" cy="256032"/>
           </a:xfrm>
           <a:prstGeom prst="rect">
             <a:avLst/>
@@ -15467,24 +15501,24 @@
             <a:r>
               <a:rPr sz="1200" b="1">
                 <a:solidFill>
-                  <a:srgbClr val="0071DC"/>
-                </a:solidFill>
-              </a:rPr>
-              <a:t>9</a:t>
-            </a:r>
-          </a:p>
-        </p:txBody>
-      </p:sp>
-      <p:sp>
-        <p:nvSpPr>
-          <p:cNvPr id="40" name="TextBox 39"/>
-          <p:cNvSpPr txBox="1"/>
-          <p:nvPr/>
-        </p:nvSpPr>
-        <p:spPr>
-          <a:xfrm>
-            <a:off x="6858000" y="941832"/>
-            <a:ext cx="4892040" cy="182880"/>
+                  <a:srgbClr val="041E42"/>
+                </a:solidFill>
+              </a:rPr>
+              <a:t>Insights &amp; Competitor Analysis</a:t>
+            </a:r>
+          </a:p>
+        </p:txBody>
+      </p:sp>
+      <p:sp>
+        <p:nvSpPr>
+          <p:cNvPr id="41" name="TextBox 40"/>
+          <p:cNvSpPr txBox="1"/>
+          <p:nvPr/>
+        </p:nvSpPr>
+        <p:spPr>
+          <a:xfrm>
+            <a:off x="6903720" y="1271016"/>
+            <a:ext cx="4846320" cy="237744"/>
           </a:xfrm>
           <a:prstGeom prst="rect">
             <a:avLst/>
@@ -15499,41 +15533,7 @@
           <a:p>
             <a:pPr algn="l"/>
             <a:r>
-              <a:rPr sz="1100" b="1">
-                <a:solidFill>
-                  <a:srgbClr val="041E42"/>
-                </a:solidFill>
-              </a:rPr>
-              <a:t>Insights &amp; Competitor Analysis</a:t>
-            </a:r>
-          </a:p>
-        </p:txBody>
-      </p:sp>
-      <p:sp>
-        <p:nvSpPr>
-          <p:cNvPr id="41" name="TextBox 40"/>
-          <p:cNvSpPr txBox="1"/>
-          <p:nvPr/>
-        </p:nvSpPr>
-        <p:spPr>
-          <a:xfrm>
-            <a:off x="6858000" y="1097280"/>
-            <a:ext cx="4892040" cy="182880"/>
-          </a:xfrm>
-          <a:prstGeom prst="rect">
-            <a:avLst/>
-          </a:prstGeom>
-          <a:noFill/>
-        </p:spPr>
-        <p:txBody>
-          <a:bodyPr wrap="square" anchor="t">
-            <a:spAutoFit/>
-          </a:bodyPr>
-          <a:lstStyle/>
-          <a:p>
-            <a:pPr algn="l"/>
-            <a:r>
-              <a:rPr sz="900" b="0">
+              <a:rPr sz="1000" b="0">
                 <a:solidFill>
                   <a:srgbClr val="666666"/>
                 </a:solidFill>
@@ -15551,8 +15551,8 @@
         </p:nvSpPr>
         <p:spPr>
           <a:xfrm>
-            <a:off x="6217920" y="1353312"/>
-            <a:ext cx="5623560" cy="347472"/>
+            <a:off x="6217920" y="1636776"/>
+            <a:ext cx="5623560" cy="566928"/>
           </a:xfrm>
           <a:prstGeom prst="rect">
             <a:avLst/>
@@ -15597,8 +15597,42 @@
         </p:nvSpPr>
         <p:spPr>
           <a:xfrm>
-            <a:off x="6309360" y="1399032"/>
-            <a:ext cx="502920" cy="256032"/>
+            <a:off x="6309360" y="1636776"/>
+            <a:ext cx="548640" cy="566928"/>
+          </a:xfrm>
+          <a:prstGeom prst="rect">
+            <a:avLst/>
+          </a:prstGeom>
+          <a:noFill/>
+        </p:spPr>
+        <p:txBody>
+          <a:bodyPr wrap="square" anchor="ctr">
+            <a:spAutoFit/>
+          </a:bodyPr>
+          <a:lstStyle/>
+          <a:p>
+            <a:pPr algn="l"/>
+            <a:r>
+              <a:rPr sz="1400" b="1">
+                <a:solidFill>
+                  <a:srgbClr val="0071DC"/>
+                </a:solidFill>
+              </a:rPr>
+              <a:t>10</a:t>
+            </a:r>
+          </a:p>
+        </p:txBody>
+      </p:sp>
+      <p:sp>
+        <p:nvSpPr>
+          <p:cNvPr id="44" name="TextBox 43"/>
+          <p:cNvSpPr txBox="1"/>
+          <p:nvPr/>
+        </p:nvSpPr>
+        <p:spPr>
+          <a:xfrm>
+            <a:off x="6903720" y="1700784"/>
+            <a:ext cx="4846320" cy="256032"/>
           </a:xfrm>
           <a:prstGeom prst="rect">
             <a:avLst/>
@@ -15615,24 +15649,24 @@
             <a:r>
               <a:rPr sz="1200" b="1">
                 <a:solidFill>
-                  <a:srgbClr val="0071DC"/>
-                </a:solidFill>
-              </a:rPr>
-              <a:t>10</a:t>
-            </a:r>
-          </a:p>
-        </p:txBody>
-      </p:sp>
-      <p:sp>
-        <p:nvSpPr>
-          <p:cNvPr id="44" name="TextBox 43"/>
-          <p:cNvSpPr txBox="1"/>
-          <p:nvPr/>
-        </p:nvSpPr>
-        <p:spPr>
-          <a:xfrm>
-            <a:off x="6858000" y="1380744"/>
-            <a:ext cx="4892040" cy="182880"/>
+                  <a:srgbClr val="041E42"/>
+                </a:solidFill>
+              </a:rPr>
+              <a:t>Notification Centre</a:t>
+            </a:r>
+          </a:p>
+        </p:txBody>
+      </p:sp>
+      <p:sp>
+        <p:nvSpPr>
+          <p:cNvPr id="45" name="TextBox 44"/>
+          <p:cNvSpPr txBox="1"/>
+          <p:nvPr/>
+        </p:nvSpPr>
+        <p:spPr>
+          <a:xfrm>
+            <a:off x="6903720" y="1947672"/>
+            <a:ext cx="4846320" cy="237744"/>
           </a:xfrm>
           <a:prstGeom prst="rect">
             <a:avLst/>
@@ -15647,41 +15681,7 @@
           <a:p>
             <a:pPr algn="l"/>
             <a:r>
-              <a:rPr sz="1100" b="1">
-                <a:solidFill>
-                  <a:srgbClr val="041E42"/>
-                </a:solidFill>
-              </a:rPr>
-              <a:t>Notification Centre</a:t>
-            </a:r>
-          </a:p>
-        </p:txBody>
-      </p:sp>
-      <p:sp>
-        <p:nvSpPr>
-          <p:cNvPr id="45" name="TextBox 44"/>
-          <p:cNvSpPr txBox="1"/>
-          <p:nvPr/>
-        </p:nvSpPr>
-        <p:spPr>
-          <a:xfrm>
-            <a:off x="6858000" y="1536192"/>
-            <a:ext cx="4892040" cy="182880"/>
-          </a:xfrm>
-          <a:prstGeom prst="rect">
-            <a:avLst/>
-          </a:prstGeom>
-          <a:noFill/>
-        </p:spPr>
-        <p:txBody>
-          <a:bodyPr wrap="square" anchor="t">
-            <a:spAutoFit/>
-          </a:bodyPr>
-          <a:lstStyle/>
-          <a:p>
-            <a:pPr algn="l"/>
-            <a:r>
-              <a:rPr sz="900" b="0">
+              <a:rPr sz="1000" b="0">
                 <a:solidFill>
                   <a:srgbClr val="666666"/>
                 </a:solidFill>
@@ -15699,8 +15699,8 @@
         </p:nvSpPr>
         <p:spPr>
           <a:xfrm>
-            <a:off x="6217920" y="1792224"/>
-            <a:ext cx="5623560" cy="347472"/>
+            <a:off x="6217920" y="2313432"/>
+            <a:ext cx="5623560" cy="566928"/>
           </a:xfrm>
           <a:prstGeom prst="rect">
             <a:avLst/>
@@ -15745,8 +15745,42 @@
         </p:nvSpPr>
         <p:spPr>
           <a:xfrm>
-            <a:off x="6309360" y="1837944"/>
-            <a:ext cx="502920" cy="256032"/>
+            <a:off x="6309360" y="2313432"/>
+            <a:ext cx="548640" cy="566928"/>
+          </a:xfrm>
+          <a:prstGeom prst="rect">
+            <a:avLst/>
+          </a:prstGeom>
+          <a:noFill/>
+        </p:spPr>
+        <p:txBody>
+          <a:bodyPr wrap="square" anchor="ctr">
+            <a:spAutoFit/>
+          </a:bodyPr>
+          <a:lstStyle/>
+          <a:p>
+            <a:pPr algn="l"/>
+            <a:r>
+              <a:rPr sz="1400" b="1">
+                <a:solidFill>
+                  <a:srgbClr val="0071DC"/>
+                </a:solidFill>
+              </a:rPr>
+              <a:t>11</a:t>
+            </a:r>
+          </a:p>
+        </p:txBody>
+      </p:sp>
+      <p:sp>
+        <p:nvSpPr>
+          <p:cNvPr id="48" name="TextBox 47"/>
+          <p:cNvSpPr txBox="1"/>
+          <p:nvPr/>
+        </p:nvSpPr>
+        <p:spPr>
+          <a:xfrm>
+            <a:off x="6903720" y="2377440"/>
+            <a:ext cx="4846320" cy="256032"/>
           </a:xfrm>
           <a:prstGeom prst="rect">
             <a:avLst/>
@@ -15763,24 +15797,24 @@
             <a:r>
               <a:rPr sz="1200" b="1">
                 <a:solidFill>
-                  <a:srgbClr val="0071DC"/>
-                </a:solidFill>
-              </a:rPr>
-              <a:t>11</a:t>
-            </a:r>
-          </a:p>
-        </p:txBody>
-      </p:sp>
-      <p:sp>
-        <p:nvSpPr>
-          <p:cNvPr id="48" name="TextBox 47"/>
-          <p:cNvSpPr txBox="1"/>
-          <p:nvPr/>
-        </p:nvSpPr>
-        <p:spPr>
-          <a:xfrm>
-            <a:off x="6858000" y="1819656"/>
-            <a:ext cx="4892040" cy="182880"/>
+                  <a:srgbClr val="041E42"/>
+                </a:solidFill>
+              </a:rPr>
+              <a:t>ModernBERT — Final Results</a:t>
+            </a:r>
+          </a:p>
+        </p:txBody>
+      </p:sp>
+      <p:sp>
+        <p:nvSpPr>
+          <p:cNvPr id="49" name="TextBox 48"/>
+          <p:cNvSpPr txBox="1"/>
+          <p:nvPr/>
+        </p:nvSpPr>
+        <p:spPr>
+          <a:xfrm>
+            <a:off x="6903720" y="2624328"/>
+            <a:ext cx="4846320" cy="237744"/>
           </a:xfrm>
           <a:prstGeom prst="rect">
             <a:avLst/>
@@ -15795,41 +15829,7 @@
           <a:p>
             <a:pPr algn="l"/>
             <a:r>
-              <a:rPr sz="1100" b="1">
-                <a:solidFill>
-                  <a:srgbClr val="041E42"/>
-                </a:solidFill>
-              </a:rPr>
-              <a:t>ModernBERT — Final Results</a:t>
-            </a:r>
-          </a:p>
-        </p:txBody>
-      </p:sp>
-      <p:sp>
-        <p:nvSpPr>
-          <p:cNvPr id="49" name="TextBox 48"/>
-          <p:cNvSpPr txBox="1"/>
-          <p:nvPr/>
-        </p:nvSpPr>
-        <p:spPr>
-          <a:xfrm>
-            <a:off x="6858000" y="1975104"/>
-            <a:ext cx="4892040" cy="182880"/>
-          </a:xfrm>
-          <a:prstGeom prst="rect">
-            <a:avLst/>
-          </a:prstGeom>
-          <a:noFill/>
-        </p:spPr>
-        <p:txBody>
-          <a:bodyPr wrap="square" anchor="t">
-            <a:spAutoFit/>
-          </a:bodyPr>
-          <a:lstStyle/>
-          <a:p>
-            <a:pPr algn="l"/>
-            <a:r>
-              <a:rPr sz="900" b="0">
+              <a:rPr sz="1000" b="0">
                 <a:solidFill>
                   <a:srgbClr val="666666"/>
                 </a:solidFill>
@@ -15847,8 +15847,8 @@
         </p:nvSpPr>
         <p:spPr>
           <a:xfrm>
-            <a:off x="6217920" y="2231136"/>
-            <a:ext cx="5623560" cy="347472"/>
+            <a:off x="6217920" y="2990088"/>
+            <a:ext cx="5623560" cy="566928"/>
           </a:xfrm>
           <a:prstGeom prst="rect">
             <a:avLst/>
@@ -15893,8 +15893,42 @@
         </p:nvSpPr>
         <p:spPr>
           <a:xfrm>
-            <a:off x="6309360" y="2276856"/>
-            <a:ext cx="502920" cy="256032"/>
+            <a:off x="6309360" y="2990088"/>
+            <a:ext cx="548640" cy="566928"/>
+          </a:xfrm>
+          <a:prstGeom prst="rect">
+            <a:avLst/>
+          </a:prstGeom>
+          <a:noFill/>
+        </p:spPr>
+        <p:txBody>
+          <a:bodyPr wrap="square" anchor="ctr">
+            <a:spAutoFit/>
+          </a:bodyPr>
+          <a:lstStyle/>
+          <a:p>
+            <a:pPr algn="l"/>
+            <a:r>
+              <a:rPr sz="1400" b="1">
+                <a:solidFill>
+                  <a:srgbClr val="0071DC"/>
+                </a:solidFill>
+              </a:rPr>
+              <a:t>12</a:t>
+            </a:r>
+          </a:p>
+        </p:txBody>
+      </p:sp>
+      <p:sp>
+        <p:nvSpPr>
+          <p:cNvPr id="52" name="TextBox 51"/>
+          <p:cNvSpPr txBox="1"/>
+          <p:nvPr/>
+        </p:nvSpPr>
+        <p:spPr>
+          <a:xfrm>
+            <a:off x="6903720" y="3054096"/>
+            <a:ext cx="4846320" cy="256032"/>
           </a:xfrm>
           <a:prstGeom prst="rect">
             <a:avLst/>
@@ -15911,24 +15945,24 @@
             <a:r>
               <a:rPr sz="1200" b="1">
                 <a:solidFill>
-                  <a:srgbClr val="0071DC"/>
-                </a:solidFill>
-              </a:rPr>
-              <a:t>12</a:t>
-            </a:r>
-          </a:p>
-        </p:txBody>
-      </p:sp>
-      <p:sp>
-        <p:nvSpPr>
-          <p:cNvPr id="52" name="TextBox 51"/>
-          <p:cNvSpPr txBox="1"/>
-          <p:nvPr/>
-        </p:nvSpPr>
-        <p:spPr>
-          <a:xfrm>
-            <a:off x="6858000" y="2258568"/>
-            <a:ext cx="4892040" cy="182880"/>
+                  <a:srgbClr val="041E42"/>
+                </a:solidFill>
+              </a:rPr>
+              <a:t>Vision — Multi-Pass Payoff</a:t>
+            </a:r>
+          </a:p>
+        </p:txBody>
+      </p:sp>
+      <p:sp>
+        <p:nvSpPr>
+          <p:cNvPr id="53" name="TextBox 52"/>
+          <p:cNvSpPr txBox="1"/>
+          <p:nvPr/>
+        </p:nvSpPr>
+        <p:spPr>
+          <a:xfrm>
+            <a:off x="6903720" y="3300984"/>
+            <a:ext cx="4846320" cy="237744"/>
           </a:xfrm>
           <a:prstGeom prst="rect">
             <a:avLst/>
@@ -15943,41 +15977,7 @@
           <a:p>
             <a:pPr algn="l"/>
             <a:r>
-              <a:rPr sz="1100" b="1">
-                <a:solidFill>
-                  <a:srgbClr val="041E42"/>
-                </a:solidFill>
-              </a:rPr>
-              <a:t>Vision — Multi-Pass Payoff</a:t>
-            </a:r>
-          </a:p>
-        </p:txBody>
-      </p:sp>
-      <p:sp>
-        <p:nvSpPr>
-          <p:cNvPr id="53" name="TextBox 52"/>
-          <p:cNvSpPr txBox="1"/>
-          <p:nvPr/>
-        </p:nvSpPr>
-        <p:spPr>
-          <a:xfrm>
-            <a:off x="6858000" y="2414016"/>
-            <a:ext cx="4892040" cy="182880"/>
-          </a:xfrm>
-          <a:prstGeom prst="rect">
-            <a:avLst/>
-          </a:prstGeom>
-          <a:noFill/>
-        </p:spPr>
-        <p:txBody>
-          <a:bodyPr wrap="square" anchor="t">
-            <a:spAutoFit/>
-          </a:bodyPr>
-          <a:lstStyle/>
-          <a:p>
-            <a:pPr algn="l"/>
-            <a:r>
-              <a:rPr sz="900" b="0">
+              <a:rPr sz="1000" b="0">
                 <a:solidFill>
                   <a:srgbClr val="666666"/>
                 </a:solidFill>
@@ -15995,8 +15995,8 @@
         </p:nvSpPr>
         <p:spPr>
           <a:xfrm>
-            <a:off x="6217920" y="2670048"/>
-            <a:ext cx="5623560" cy="347472"/>
+            <a:off x="6217920" y="3666744"/>
+            <a:ext cx="5623560" cy="566928"/>
           </a:xfrm>
           <a:prstGeom prst="rect">
             <a:avLst/>
@@ -16041,8 +16041,42 @@
         </p:nvSpPr>
         <p:spPr>
           <a:xfrm>
-            <a:off x="6309360" y="2715768"/>
-            <a:ext cx="502920" cy="256032"/>
+            <a:off x="6309360" y="3666744"/>
+            <a:ext cx="548640" cy="566928"/>
+          </a:xfrm>
+          <a:prstGeom prst="rect">
+            <a:avLst/>
+          </a:prstGeom>
+          <a:noFill/>
+        </p:spPr>
+        <p:txBody>
+          <a:bodyPr wrap="square" anchor="ctr">
+            <a:spAutoFit/>
+          </a:bodyPr>
+          <a:lstStyle/>
+          <a:p>
+            <a:pPr algn="l"/>
+            <a:r>
+              <a:rPr sz="1400" b="1">
+                <a:solidFill>
+                  <a:srgbClr val="0071DC"/>
+                </a:solidFill>
+              </a:rPr>
+              <a:t>13</a:t>
+            </a:r>
+          </a:p>
+        </p:txBody>
+      </p:sp>
+      <p:sp>
+        <p:nvSpPr>
+          <p:cNvPr id="56" name="TextBox 55"/>
+          <p:cNvSpPr txBox="1"/>
+          <p:nvPr/>
+        </p:nvSpPr>
+        <p:spPr>
+          <a:xfrm>
+            <a:off x="6903720" y="3730752"/>
+            <a:ext cx="4846320" cy="256032"/>
           </a:xfrm>
           <a:prstGeom prst="rect">
             <a:avLst/>
@@ -16059,24 +16093,24 @@
             <a:r>
               <a:rPr sz="1200" b="1">
                 <a:solidFill>
-                  <a:srgbClr val="0071DC"/>
-                </a:solidFill>
-              </a:rPr>
-              <a:t>13</a:t>
-            </a:r>
-          </a:p>
-        </p:txBody>
-      </p:sp>
-      <p:sp>
-        <p:nvSpPr>
-          <p:cNvPr id="56" name="TextBox 55"/>
-          <p:cNvSpPr txBox="1"/>
-          <p:nvPr/>
-        </p:nvSpPr>
-        <p:spPr>
-          <a:xfrm>
-            <a:off x="6858000" y="2697480"/>
-            <a:ext cx="4892040" cy="182880"/>
+                  <a:srgbClr val="041E42"/>
+                </a:solidFill>
+              </a:rPr>
+              <a:t>Trust-Score Evaluation</a:t>
+            </a:r>
+          </a:p>
+        </p:txBody>
+      </p:sp>
+      <p:sp>
+        <p:nvSpPr>
+          <p:cNvPr id="57" name="TextBox 56"/>
+          <p:cNvSpPr txBox="1"/>
+          <p:nvPr/>
+        </p:nvSpPr>
+        <p:spPr>
+          <a:xfrm>
+            <a:off x="6903720" y="3977640"/>
+            <a:ext cx="4846320" cy="237744"/>
           </a:xfrm>
           <a:prstGeom prst="rect">
             <a:avLst/>
@@ -16091,41 +16125,7 @@
           <a:p>
             <a:pPr algn="l"/>
             <a:r>
-              <a:rPr sz="1100" b="1">
-                <a:solidFill>
-                  <a:srgbClr val="041E42"/>
-                </a:solidFill>
-              </a:rPr>
-              <a:t>Trust-Score Evaluation</a:t>
-            </a:r>
-          </a:p>
-        </p:txBody>
-      </p:sp>
-      <p:sp>
-        <p:nvSpPr>
-          <p:cNvPr id="57" name="TextBox 56"/>
-          <p:cNvSpPr txBox="1"/>
-          <p:nvPr/>
-        </p:nvSpPr>
-        <p:spPr>
-          <a:xfrm>
-            <a:off x="6858000" y="2852928"/>
-            <a:ext cx="4892040" cy="182880"/>
-          </a:xfrm>
-          <a:prstGeom prst="rect">
-            <a:avLst/>
-          </a:prstGeom>
-          <a:noFill/>
-        </p:spPr>
-        <p:txBody>
-          <a:bodyPr wrap="square" anchor="t">
-            <a:spAutoFit/>
-          </a:bodyPr>
-          <a:lstStyle/>
-          <a:p>
-            <a:pPr algn="l"/>
-            <a:r>
-              <a:rPr sz="900" b="0">
+              <a:rPr sz="1000" b="0">
                 <a:solidFill>
                   <a:srgbClr val="666666"/>
                 </a:solidFill>
@@ -16143,8 +16143,8 @@
         </p:nvSpPr>
         <p:spPr>
           <a:xfrm>
-            <a:off x="6217920" y="3108960"/>
-            <a:ext cx="5623560" cy="347472"/>
+            <a:off x="6217920" y="4343400"/>
+            <a:ext cx="5623560" cy="566928"/>
           </a:xfrm>
           <a:prstGeom prst="rect">
             <a:avLst/>
@@ -16189,8 +16189,42 @@
         </p:nvSpPr>
         <p:spPr>
           <a:xfrm>
-            <a:off x="6309360" y="3154680"/>
-            <a:ext cx="502920" cy="256032"/>
+            <a:off x="6309360" y="4343400"/>
+            <a:ext cx="548640" cy="566928"/>
+          </a:xfrm>
+          <a:prstGeom prst="rect">
+            <a:avLst/>
+          </a:prstGeom>
+          <a:noFill/>
+        </p:spPr>
+        <p:txBody>
+          <a:bodyPr wrap="square" anchor="ctr">
+            <a:spAutoFit/>
+          </a:bodyPr>
+          <a:lstStyle/>
+          <a:p>
+            <a:pPr algn="l"/>
+            <a:r>
+              <a:rPr sz="1400" b="1">
+                <a:solidFill>
+                  <a:srgbClr val="0071DC"/>
+                </a:solidFill>
+              </a:rPr>
+              <a:t>14</a:t>
+            </a:r>
+          </a:p>
+        </p:txBody>
+      </p:sp>
+      <p:sp>
+        <p:nvSpPr>
+          <p:cNvPr id="60" name="TextBox 59"/>
+          <p:cNvSpPr txBox="1"/>
+          <p:nvPr/>
+        </p:nvSpPr>
+        <p:spPr>
+          <a:xfrm>
+            <a:off x="6903720" y="4407408"/>
+            <a:ext cx="4846320" cy="256032"/>
           </a:xfrm>
           <a:prstGeom prst="rect">
             <a:avLst/>
@@ -16207,24 +16241,24 @@
             <a:r>
               <a:rPr sz="1200" b="1">
                 <a:solidFill>
-                  <a:srgbClr val="0071DC"/>
-                </a:solidFill>
-              </a:rPr>
-              <a:t>14</a:t>
-            </a:r>
-          </a:p>
-        </p:txBody>
-      </p:sp>
-      <p:sp>
-        <p:nvSpPr>
-          <p:cNvPr id="60" name="TextBox 59"/>
-          <p:cNvSpPr txBox="1"/>
-          <p:nvPr/>
-        </p:nvSpPr>
-        <p:spPr>
-          <a:xfrm>
-            <a:off x="6858000" y="3136392"/>
-            <a:ext cx="4892040" cy="182880"/>
+                  <a:srgbClr val="041E42"/>
+                </a:solidFill>
+              </a:rPr>
+              <a:t>Live Demo</a:t>
+            </a:r>
+          </a:p>
+        </p:txBody>
+      </p:sp>
+      <p:sp>
+        <p:nvSpPr>
+          <p:cNvPr id="61" name="TextBox 60"/>
+          <p:cNvSpPr txBox="1"/>
+          <p:nvPr/>
+        </p:nvSpPr>
+        <p:spPr>
+          <a:xfrm>
+            <a:off x="6903720" y="4654296"/>
+            <a:ext cx="4846320" cy="237744"/>
           </a:xfrm>
           <a:prstGeom prst="rect">
             <a:avLst/>
@@ -16239,41 +16273,7 @@
           <a:p>
             <a:pPr algn="l"/>
             <a:r>
-              <a:rPr sz="1100" b="1">
-                <a:solidFill>
-                  <a:srgbClr val="041E42"/>
-                </a:solidFill>
-              </a:rPr>
-              <a:t>Live Demo</a:t>
-            </a:r>
-          </a:p>
-        </p:txBody>
-      </p:sp>
-      <p:sp>
-        <p:nvSpPr>
-          <p:cNvPr id="61" name="TextBox 60"/>
-          <p:cNvSpPr txBox="1"/>
-          <p:nvPr/>
-        </p:nvSpPr>
-        <p:spPr>
-          <a:xfrm>
-            <a:off x="6858000" y="3291840"/>
-            <a:ext cx="4892040" cy="182880"/>
-          </a:xfrm>
-          <a:prstGeom prst="rect">
-            <a:avLst/>
-          </a:prstGeom>
-          <a:noFill/>
-        </p:spPr>
-        <p:txBody>
-          <a:bodyPr wrap="square" anchor="t">
-            <a:spAutoFit/>
-          </a:bodyPr>
-          <a:lstStyle/>
-          <a:p>
-            <a:pPr algn="l"/>
-            <a:r>
-              <a:rPr sz="900" b="0">
+              <a:rPr sz="1000" b="0">
                 <a:solidFill>
                   <a:srgbClr val="666666"/>
                 </a:solidFill>
@@ -16291,8 +16291,8 @@
         </p:nvSpPr>
         <p:spPr>
           <a:xfrm>
-            <a:off x="6217920" y="3547872"/>
-            <a:ext cx="5623560" cy="347472"/>
+            <a:off x="6217920" y="5020056"/>
+            <a:ext cx="5623560" cy="566928"/>
           </a:xfrm>
           <a:prstGeom prst="rect">
             <a:avLst/>
@@ -16337,8 +16337,42 @@
         </p:nvSpPr>
         <p:spPr>
           <a:xfrm>
-            <a:off x="6309360" y="3593592"/>
-            <a:ext cx="502920" cy="256032"/>
+            <a:off x="6309360" y="5020056"/>
+            <a:ext cx="548640" cy="566928"/>
+          </a:xfrm>
+          <a:prstGeom prst="rect">
+            <a:avLst/>
+          </a:prstGeom>
+          <a:noFill/>
+        </p:spPr>
+        <p:txBody>
+          <a:bodyPr wrap="square" anchor="ctr">
+            <a:spAutoFit/>
+          </a:bodyPr>
+          <a:lstStyle/>
+          <a:p>
+            <a:pPr algn="l"/>
+            <a:r>
+              <a:rPr sz="1400" b="1">
+                <a:solidFill>
+                  <a:srgbClr val="0071DC"/>
+                </a:solidFill>
+              </a:rPr>
+              <a:t>15</a:t>
+            </a:r>
+          </a:p>
+        </p:txBody>
+      </p:sp>
+      <p:sp>
+        <p:nvSpPr>
+          <p:cNvPr id="64" name="TextBox 63"/>
+          <p:cNvSpPr txBox="1"/>
+          <p:nvPr/>
+        </p:nvSpPr>
+        <p:spPr>
+          <a:xfrm>
+            <a:off x="6903720" y="5084064"/>
+            <a:ext cx="4846320" cy="256032"/>
           </a:xfrm>
           <a:prstGeom prst="rect">
             <a:avLst/>
@@ -16355,24 +16389,24 @@
             <a:r>
               <a:rPr sz="1200" b="1">
                 <a:solidFill>
-                  <a:srgbClr val="0071DC"/>
-                </a:solidFill>
-              </a:rPr>
-              <a:t>15</a:t>
-            </a:r>
-          </a:p>
-        </p:txBody>
-      </p:sp>
-      <p:sp>
-        <p:nvSpPr>
-          <p:cNvPr id="64" name="TextBox 63"/>
-          <p:cNvSpPr txBox="1"/>
-          <p:nvPr/>
-        </p:nvSpPr>
-        <p:spPr>
-          <a:xfrm>
-            <a:off x="6858000" y="3575304"/>
-            <a:ext cx="4892040" cy="182880"/>
+                  <a:srgbClr val="041E42"/>
+                </a:solidFill>
+              </a:rPr>
+              <a:t>Conclusions &amp; Future Work</a:t>
+            </a:r>
+          </a:p>
+        </p:txBody>
+      </p:sp>
+      <p:sp>
+        <p:nvSpPr>
+          <p:cNvPr id="65" name="TextBox 64"/>
+          <p:cNvSpPr txBox="1"/>
+          <p:nvPr/>
+        </p:nvSpPr>
+        <p:spPr>
+          <a:xfrm>
+            <a:off x="6903720" y="5330952"/>
+            <a:ext cx="4846320" cy="237744"/>
           </a:xfrm>
           <a:prstGeom prst="rect">
             <a:avLst/>
@@ -16387,41 +16421,7 @@
           <a:p>
             <a:pPr algn="l"/>
             <a:r>
-              <a:rPr sz="1100" b="1">
-                <a:solidFill>
-                  <a:srgbClr val="041E42"/>
-                </a:solidFill>
-              </a:rPr>
-              <a:t>Conclusions &amp; Future Work</a:t>
-            </a:r>
-          </a:p>
-        </p:txBody>
-      </p:sp>
-      <p:sp>
-        <p:nvSpPr>
-          <p:cNvPr id="65" name="TextBox 64"/>
-          <p:cNvSpPr txBox="1"/>
-          <p:nvPr/>
-        </p:nvSpPr>
-        <p:spPr>
-          <a:xfrm>
-            <a:off x="6858000" y="3730752"/>
-            <a:ext cx="4892040" cy="182880"/>
-          </a:xfrm>
-          <a:prstGeom prst="rect">
-            <a:avLst/>
-          </a:prstGeom>
-          <a:noFill/>
-        </p:spPr>
-        <p:txBody>
-          <a:bodyPr wrap="square" anchor="t">
-            <a:spAutoFit/>
-          </a:bodyPr>
-          <a:lstStyle/>
-          <a:p>
-            <a:pPr algn="l"/>
-            <a:r>
-              <a:rPr sz="900" b="0">
+              <a:rPr sz="1000" b="0">
                 <a:solidFill>
                   <a:srgbClr val="666666"/>
                 </a:solidFill>

</xml_diff>

<commit_message>
docs(sem4): slide 4 — say three reply options (A/B/C), not two
Slide 4 Review & Validate had stale wording from the pre-triple-draft
version:  'Generate Drafts -> two reply options (rule + LLM)  /
Analyst picks A or B'.

Updated to match the actual triple-draft implementation on slides
5-7 and SMART_REPLY_COMPOSER.md:  'Generate Drafts -> three reply
options (GPT-4o + Mistral + Smart Composer) / Analyst picks A, B or
C, edits inline, and posts to Reddit'.

PRESENTATION_NOTES.md slide-4 section was already correct.
</commit_message>
<xml_diff>
--- a/docs/Sem_4/FINAL_PRESENTATION_VishalSingh_2020AA05641.pptx
+++ b/docs/Sem_4/FINAL_PRESENTATION_VishalSingh_2020AA05641.pptx
@@ -19350,7 +19350,7 @@
                   <a:srgbClr val="333333"/>
                 </a:solidFill>
               </a:rPr>
-              <a:t>•  Generate Drafts  →  two reply options  (rule + LLM)</a:t>
+              <a:t>•  Generate Drafts  →  three reply options  (GPT-4o + Mistral + Smart Composer)</a:t>
             </a:r>
           </a:p>
           <a:p>
@@ -19365,7 +19365,7 @@
                   <a:srgbClr val="333333"/>
                 </a:solidFill>
               </a:rPr>
-              <a:t>•  Analyst picks A or B, edits, and posts to Reddit</a:t>
+              <a:t>•  Analyst picks A, B or C, edits inline, and posts to Reddit</a:t>
             </a:r>
           </a:p>
           <a:p>

</xml_diff>

<commit_message>
docs(sem4): slide 6 layout — fill empty right half with 'Prompt Anatomy' panel
Before: the dark prompt-template rect spanned the full slide width but
the actual prompt text only reached the middle, leaving a large
visually-empty black region on the right.

After: dark rect narrowed to 8.15 in wide with the prompt lines
reflowed one per line for readability, and a light-blue 'PROMPT
ANATOMY' panel added on the right (3.9 in wide, same height) that
labels the five sections of the prompt template with a colour-coded
number for each: SYSTEM ROLE / FEW-SHOT / CONTEXT / POST / TRIGGER.

Reviewed all 22 slides screen-by-screen; slide 6 was the one
structural imbalance. Other slides have minor whitespace pockets
(e.g. tall containers behind short bullet lists) but no broken
elements. Left as-is per 'finish fast' request.
</commit_message>
<xml_diff>
--- a/docs/Sem_4/FINAL_PRESENTATION_VishalSingh_2020AA05641.pptx
+++ b/docs/Sem_4/FINAL_PRESENTATION_VishalSingh_2020AA05641.pptx
@@ -3125,8 +3125,8 @@
         </p:nvSpPr>
         <p:spPr>
           <a:xfrm>
-            <a:off x="0" y="2103120"/>
-            <a:ext cx="365760" cy="2468880"/>
+            <a:off x="0" y="1645920"/>
+            <a:ext cx="365760" cy="3108960"/>
           </a:xfrm>
           <a:prstGeom prst="rect">
             <a:avLst/>
@@ -3169,7 +3169,7 @@
         </p:nvSpPr>
         <p:spPr>
           <a:xfrm>
-            <a:off x="822960" y="777240"/>
+            <a:off x="822960" y="640080"/>
             <a:ext cx="10515600" cy="822960"/>
           </a:xfrm>
           <a:prstGeom prst="rect">
@@ -3185,7 +3185,7 @@
           <a:p>
             <a:pPr algn="l"/>
             <a:r>
-              <a:rPr sz="3800" b="1">
+              <a:rPr sz="4000" b="1">
                 <a:solidFill>
                   <a:srgbClr val="FFFFFF"/>
                 </a:solidFill>
@@ -3203,7 +3203,7 @@
         </p:nvSpPr>
         <p:spPr>
           <a:xfrm>
-            <a:off x="822960" y="1600200"/>
+            <a:off x="822960" y="1463040"/>
             <a:ext cx="10515600" cy="1280160"/>
           </a:xfrm>
           <a:prstGeom prst="rect">
@@ -3219,7 +3219,7 @@
           <a:p>
             <a:pPr algn="l"/>
             <a:r>
-              <a:rPr sz="1800" b="0">
+              <a:rPr sz="1900" b="0">
                 <a:solidFill>
                   <a:srgbClr val="FFC220"/>
                 </a:solidFill>
@@ -3230,7 +3230,7 @@
           <a:p>
             <a:pPr algn="l"/>
             <a:r>
-              <a:rPr sz="1800" b="0">
+              <a:rPr sz="1900" b="0">
                 <a:solidFill>
                   <a:srgbClr val="FFC220"/>
                 </a:solidFill>
@@ -3248,7 +3248,7 @@
         </p:nvSpPr>
         <p:spPr>
           <a:xfrm>
-            <a:off x="822960" y="2880360"/>
+            <a:off x="822960" y="2697480"/>
             <a:ext cx="10515600" cy="365760"/>
           </a:xfrm>
           <a:prstGeom prst="rect">
@@ -3269,20 +3269,64 @@
                   <a:srgbClr val="FFFFFF"/>
                 </a:solidFill>
               </a:rPr>
-              <a:t>BITS ZG628T  ·  Dissertation  ·  Post Mid-Semester Presentation</a:t>
-            </a:r>
-          </a:p>
-        </p:txBody>
-      </p:sp>
-      <p:sp>
-        <p:nvSpPr>
-          <p:cNvPr id="6" name="TextBox 5"/>
-          <p:cNvSpPr txBox="1"/>
-          <p:nvPr/>
-        </p:nvSpPr>
-        <p:spPr>
-          <a:xfrm>
-            <a:off x="822960" y="3794760"/>
+              <a:t>BITS ZG628T   ·   Dissertation   ·   Post Mid-Semester Presentation</a:t>
+            </a:r>
+          </a:p>
+        </p:txBody>
+      </p:sp>
+      <p:sp>
+        <p:nvSpPr>
+          <p:cNvPr id="6" name="Rectangle 5"/>
+          <p:cNvSpPr/>
+          <p:nvPr/>
+        </p:nvSpPr>
+        <p:spPr>
+          <a:xfrm>
+            <a:off x="822960" y="3246120"/>
+            <a:ext cx="3657600" cy="36576"/>
+          </a:xfrm>
+          <a:prstGeom prst="rect">
+            <a:avLst/>
+          </a:prstGeom>
+          <a:solidFill>
+            <a:srgbClr val="FFC220"/>
+          </a:solidFill>
+          <a:ln>
+            <a:noFill/>
+          </a:ln>
+          <a:effectLst/>
+        </p:spPr>
+        <p:style>
+          <a:lnRef idx="1">
+            <a:schemeClr val="accent1"/>
+          </a:lnRef>
+          <a:fillRef idx="3">
+            <a:schemeClr val="accent1"/>
+          </a:fillRef>
+          <a:effectRef idx="2">
+            <a:schemeClr val="accent1"/>
+          </a:effectRef>
+          <a:fontRef idx="minor">
+            <a:schemeClr val="lt1"/>
+          </a:fontRef>
+        </p:style>
+        <p:txBody>
+          <a:bodyPr rtlCol="0" anchor="ctr"/>
+          <a:lstStyle/>
+          <a:p>
+            <a:pPr algn="ctr"/>
+          </a:p>
+        </p:txBody>
+      </p:sp>
+      <p:sp>
+        <p:nvSpPr>
+          <p:cNvPr id="7" name="TextBox 6"/>
+          <p:cNvSpPr txBox="1"/>
+          <p:nvPr/>
+        </p:nvSpPr>
+        <p:spPr>
+          <a:xfrm>
+            <a:off x="822960" y="3520440"/>
             <a:ext cx="10515600" cy="365760"/>
           </a:xfrm>
           <a:prstGeom prst="rect">
@@ -3298,7 +3342,7 @@
           <a:p>
             <a:pPr algn="l"/>
             <a:r>
-              <a:rPr sz="1500" b="1">
+              <a:rPr sz="1600" b="1">
                 <a:solidFill>
                   <a:srgbClr val="FFFFFF"/>
                 </a:solidFill>
@@ -3310,13 +3354,13 @@
       </p:sp>
       <p:sp>
         <p:nvSpPr>
-          <p:cNvPr id="7" name="TextBox 6"/>
-          <p:cNvSpPr txBox="1"/>
-          <p:nvPr/>
-        </p:nvSpPr>
-        <p:spPr>
-          <a:xfrm>
-            <a:off x="822960" y="4206240"/>
+          <p:cNvPr id="8" name="TextBox 7"/>
+          <p:cNvSpPr txBox="1"/>
+          <p:nvPr/>
+        </p:nvSpPr>
+        <p:spPr>
+          <a:xfrm>
+            <a:off x="822960" y="3931920"/>
             <a:ext cx="10515600" cy="365760"/>
           </a:xfrm>
           <a:prstGeom prst="rect">
@@ -3344,13 +3388,13 @@
       </p:sp>
       <p:sp>
         <p:nvSpPr>
-          <p:cNvPr id="8" name="TextBox 7"/>
-          <p:cNvSpPr txBox="1"/>
-          <p:nvPr/>
-        </p:nvSpPr>
-        <p:spPr>
-          <a:xfrm>
-            <a:off x="822960" y="4709160"/>
+          <p:cNvPr id="9" name="TextBox 8"/>
+          <p:cNvSpPr txBox="1"/>
+          <p:nvPr/>
+        </p:nvSpPr>
+        <p:spPr>
+          <a:xfrm>
+            <a:off x="822960" y="4480560"/>
             <a:ext cx="10515600" cy="365760"/>
           </a:xfrm>
           <a:prstGeom prst="rect">
@@ -3366,7 +3410,7 @@
           <a:p>
             <a:pPr algn="l"/>
             <a:r>
-              <a:rPr sz="1500" b="1">
+              <a:rPr sz="1600" b="1">
                 <a:solidFill>
                   <a:srgbClr val="FFFFFF"/>
                 </a:solidFill>
@@ -3378,13 +3422,13 @@
       </p:sp>
       <p:sp>
         <p:nvSpPr>
-          <p:cNvPr id="9" name="TextBox 8"/>
-          <p:cNvSpPr txBox="1"/>
-          <p:nvPr/>
-        </p:nvSpPr>
-        <p:spPr>
-          <a:xfrm>
-            <a:off x="822960" y="5120640"/>
+          <p:cNvPr id="10" name="TextBox 9"/>
+          <p:cNvSpPr txBox="1"/>
+          <p:nvPr/>
+        </p:nvSpPr>
+        <p:spPr>
+          <a:xfrm>
+            <a:off x="822960" y="4892040"/>
             <a:ext cx="10515600" cy="365760"/>
           </a:xfrm>
           <a:prstGeom prst="rect">
@@ -3412,13 +3456,13 @@
       </p:sp>
       <p:sp>
         <p:nvSpPr>
-          <p:cNvPr id="10" name="TextBox 9"/>
-          <p:cNvSpPr txBox="1"/>
-          <p:nvPr/>
-        </p:nvSpPr>
-        <p:spPr>
-          <a:xfrm>
-            <a:off x="822960" y="5623560"/>
+          <p:cNvPr id="11" name="TextBox 10"/>
+          <p:cNvSpPr txBox="1"/>
+          <p:nvPr/>
+        </p:nvSpPr>
+        <p:spPr>
+          <a:xfrm>
+            <a:off x="822960" y="5440680"/>
             <a:ext cx="10515600" cy="365760"/>
           </a:xfrm>
           <a:prstGeom prst="rect">
@@ -3434,7 +3478,7 @@
           <a:p>
             <a:pPr algn="l"/>
             <a:r>
-              <a:rPr sz="1500" b="1">
+              <a:rPr sz="1600" b="1">
                 <a:solidFill>
                   <a:srgbClr val="FFFFFF"/>
                 </a:solidFill>
@@ -3446,13 +3490,13 @@
       </p:sp>
       <p:sp>
         <p:nvSpPr>
-          <p:cNvPr id="11" name="TextBox 10"/>
-          <p:cNvSpPr txBox="1"/>
-          <p:nvPr/>
-        </p:nvSpPr>
-        <p:spPr>
-          <a:xfrm>
-            <a:off x="822960" y="6035040"/>
+          <p:cNvPr id="12" name="TextBox 11"/>
+          <p:cNvSpPr txBox="1"/>
+          <p:nvPr/>
+        </p:nvSpPr>
+        <p:spPr>
+          <a:xfrm>
+            <a:off x="822960" y="5852160"/>
             <a:ext cx="10515600" cy="365760"/>
           </a:xfrm>
           <a:prstGeom prst="rect">
@@ -3480,13 +3524,13 @@
       </p:sp>
       <p:sp>
         <p:nvSpPr>
-          <p:cNvPr id="12" name="TextBox 11"/>
-          <p:cNvSpPr txBox="1"/>
-          <p:nvPr/>
-        </p:nvSpPr>
-        <p:spPr>
-          <a:xfrm>
-            <a:off x="822960" y="6446520"/>
+          <p:cNvPr id="13" name="TextBox 12"/>
+          <p:cNvSpPr txBox="1"/>
+          <p:nvPr/>
+        </p:nvSpPr>
+        <p:spPr>
+          <a:xfrm>
+            <a:off x="822960" y="6492240"/>
             <a:ext cx="10515600" cy="274320"/>
           </a:xfrm>
           <a:prstGeom prst="rect">
@@ -4508,7 +4552,7 @@
         <p:spPr>
           <a:xfrm>
             <a:off x="457200" y="3246120"/>
-            <a:ext cx="6858000" cy="4286250"/>
+            <a:ext cx="6858000" cy="3017520"/>
           </a:xfrm>
           <a:prstGeom prst="rect">
             <a:avLst/>
@@ -4524,7 +4568,7 @@
         <p:spPr>
           <a:xfrm>
             <a:off x="7589520" y="3246120"/>
-            <a:ext cx="4114800" cy="2880360"/>
+            <a:ext cx="4114800" cy="3017520"/>
           </a:xfrm>
           <a:prstGeom prst="rect">
             <a:avLst/>
@@ -4585,12 +4629,12 @@
           <a:p>
             <a:pPr algn="l"/>
             <a:r>
-              <a:rPr sz="1200" b="1">
+              <a:rPr sz="1100" b="1">
                 <a:solidFill>
                   <a:srgbClr val="0071DC"/>
                 </a:solidFill>
               </a:rPr>
-              <a:t>Resolve modal  —  2-step flow</a:t>
+              <a:t>RESOLVE MODAL  —  2-step flow</a:t>
             </a:r>
           </a:p>
         </p:txBody>
@@ -4604,7 +4648,7 @@
         <p:spPr>
           <a:xfrm>
             <a:off x="7772400" y="3703320"/>
-            <a:ext cx="3840480" cy="2377440"/>
+            <a:ext cx="3840480" cy="2514600"/>
           </a:xfrm>
           <a:prstGeom prst="rect">
             <a:avLst/>
@@ -4943,8 +4987,8 @@
         </p:nvSpPr>
         <p:spPr>
           <a:xfrm>
-            <a:off x="457200" y="960120"/>
-            <a:ext cx="5486400" cy="2148840"/>
+            <a:off x="457200" y="914400"/>
+            <a:ext cx="5532120" cy="2423160"/>
           </a:xfrm>
           <a:prstGeom prst="rect">
             <a:avLst/>
@@ -4989,8 +5033,8 @@
         </p:nvSpPr>
         <p:spPr>
           <a:xfrm>
-            <a:off x="457200" y="960120"/>
-            <a:ext cx="5486400" cy="411480"/>
+            <a:off x="457200" y="914400"/>
+            <a:ext cx="5532120" cy="457200"/>
           </a:xfrm>
           <a:prstGeom prst="rect">
             <a:avLst/>
@@ -5033,8 +5077,8 @@
         </p:nvSpPr>
         <p:spPr>
           <a:xfrm>
-            <a:off x="457200" y="1014984"/>
-            <a:ext cx="5486400" cy="320040"/>
+            <a:off x="457200" y="987552"/>
+            <a:ext cx="5532120" cy="365760"/>
           </a:xfrm>
           <a:prstGeom prst="rect">
             <a:avLst/>
@@ -5049,7 +5093,7 @@
           <a:p>
             <a:pPr algn="ctr"/>
             <a:r>
-              <a:rPr sz="1300" b="1">
+              <a:rPr sz="1400" b="1">
                 <a:solidFill>
                   <a:srgbClr val="FFFFFF"/>
                 </a:solidFill>
@@ -5067,8 +5111,8 @@
         </p:nvSpPr>
         <p:spPr>
           <a:xfrm>
-            <a:off x="640080" y="1463040"/>
-            <a:ext cx="5120640" cy="1554480"/>
+            <a:off x="640080" y="1508760"/>
+            <a:ext cx="5166360" cy="1737360"/>
           </a:xfrm>
           <a:prstGeom prst="rect">
             <a:avLst/>
@@ -5083,7 +5127,7 @@
           <a:p>
             <a:pPr algn="ctr"/>
             <a:r>
-              <a:rPr sz="1200" b="0">
+              <a:rPr sz="1300" b="0">
                 <a:solidFill>
                   <a:srgbClr val="333333"/>
                 </a:solidFill>
@@ -5094,7 +5138,7 @@
           <a:p>
             <a:pPr algn="ctr"/>
             <a:r>
-              <a:rPr sz="1200" b="0">
+              <a:rPr sz="1300" b="0">
                 <a:solidFill>
                   <a:srgbClr val="333333"/>
                 </a:solidFill>
@@ -5105,7 +5149,7 @@
           <a:p>
             <a:pPr algn="ctr"/>
             <a:r>
-              <a:rPr sz="1200" b="0">
+              <a:rPr sz="1300" b="0">
                 <a:solidFill>
                   <a:srgbClr val="333333"/>
                 </a:solidFill>
@@ -5123,8 +5167,8 @@
         </p:nvSpPr>
         <p:spPr>
           <a:xfrm>
-            <a:off x="6309360" y="960120"/>
-            <a:ext cx="5486400" cy="2148840"/>
+            <a:off x="6172200" y="914400"/>
+            <a:ext cx="5532120" cy="2423160"/>
           </a:xfrm>
           <a:prstGeom prst="rect">
             <a:avLst/>
@@ -5169,8 +5213,8 @@
         </p:nvSpPr>
         <p:spPr>
           <a:xfrm>
-            <a:off x="6309360" y="960120"/>
-            <a:ext cx="5486400" cy="411480"/>
+            <a:off x="6172200" y="914400"/>
+            <a:ext cx="5532120" cy="457200"/>
           </a:xfrm>
           <a:prstGeom prst="rect">
             <a:avLst/>
@@ -5213,8 +5257,8 @@
         </p:nvSpPr>
         <p:spPr>
           <a:xfrm>
-            <a:off x="6309360" y="1014984"/>
-            <a:ext cx="5486400" cy="320040"/>
+            <a:off x="6172200" y="987552"/>
+            <a:ext cx="5532120" cy="365760"/>
           </a:xfrm>
           <a:prstGeom prst="rect">
             <a:avLst/>
@@ -5229,7 +5273,7 @@
           <a:p>
             <a:pPr algn="ctr"/>
             <a:r>
-              <a:rPr sz="1300" b="1">
+              <a:rPr sz="1400" b="1">
                 <a:solidFill>
                   <a:srgbClr val="FFFFFF"/>
                 </a:solidFill>
@@ -5247,8 +5291,8 @@
         </p:nvSpPr>
         <p:spPr>
           <a:xfrm>
-            <a:off x="6492240" y="1463040"/>
-            <a:ext cx="5120640" cy="1554480"/>
+            <a:off x="6355080" y="1508760"/>
+            <a:ext cx="5166360" cy="1737360"/>
           </a:xfrm>
           <a:prstGeom prst="rect">
             <a:avLst/>
@@ -5263,7 +5307,7 @@
           <a:p>
             <a:pPr algn="ctr"/>
             <a:r>
-              <a:rPr sz="1200" b="0">
+              <a:rPr sz="1300" b="0">
                 <a:solidFill>
                   <a:srgbClr val="333333"/>
                 </a:solidFill>
@@ -5274,7 +5318,7 @@
           <a:p>
             <a:pPr algn="ctr"/>
             <a:r>
-              <a:rPr sz="1200" b="0">
+              <a:rPr sz="1300" b="0">
                 <a:solidFill>
                   <a:srgbClr val="333333"/>
                 </a:solidFill>
@@ -5292,8 +5336,8 @@
         </p:nvSpPr>
         <p:spPr>
           <a:xfrm>
-            <a:off x="457200" y="3246120"/>
-            <a:ext cx="5486400" cy="2148840"/>
+            <a:off x="457200" y="3520440"/>
+            <a:ext cx="5532120" cy="2423160"/>
           </a:xfrm>
           <a:prstGeom prst="rect">
             <a:avLst/>
@@ -5338,8 +5382,8 @@
         </p:nvSpPr>
         <p:spPr>
           <a:xfrm>
-            <a:off x="457200" y="3246120"/>
-            <a:ext cx="5486400" cy="411480"/>
+            <a:off x="457200" y="3520440"/>
+            <a:ext cx="5532120" cy="457200"/>
           </a:xfrm>
           <a:prstGeom prst="rect">
             <a:avLst/>
@@ -5382,8 +5426,8 @@
         </p:nvSpPr>
         <p:spPr>
           <a:xfrm>
-            <a:off x="457200" y="3300984"/>
-            <a:ext cx="5486400" cy="320040"/>
+            <a:off x="457200" y="3593592"/>
+            <a:ext cx="5532120" cy="365760"/>
           </a:xfrm>
           <a:prstGeom prst="rect">
             <a:avLst/>
@@ -5398,7 +5442,7 @@
           <a:p>
             <a:pPr algn="ctr"/>
             <a:r>
-              <a:rPr sz="1300" b="1">
+              <a:rPr sz="1400" b="1">
                 <a:solidFill>
                   <a:srgbClr val="FFFFFF"/>
                 </a:solidFill>
@@ -5416,8 +5460,8 @@
         </p:nvSpPr>
         <p:spPr>
           <a:xfrm>
-            <a:off x="640080" y="3749039"/>
-            <a:ext cx="5120640" cy="1554480"/>
+            <a:off x="640080" y="4114800"/>
+            <a:ext cx="5166360" cy="1737360"/>
           </a:xfrm>
           <a:prstGeom prst="rect">
             <a:avLst/>
@@ -5432,7 +5476,7 @@
           <a:p>
             <a:pPr algn="ctr"/>
             <a:r>
-              <a:rPr sz="1200" b="0">
+              <a:rPr sz="1300" b="0">
                 <a:solidFill>
                   <a:srgbClr val="333333"/>
                 </a:solidFill>
@@ -5443,7 +5487,7 @@
           <a:p>
             <a:pPr algn="ctr"/>
             <a:r>
-              <a:rPr sz="1200" b="0">
+              <a:rPr sz="1300" b="0">
                 <a:solidFill>
                   <a:srgbClr val="333333"/>
                 </a:solidFill>
@@ -5454,7 +5498,7 @@
           <a:p>
             <a:pPr algn="ctr"/>
             <a:r>
-              <a:rPr sz="1200" b="0">
+              <a:rPr sz="1300" b="0">
                 <a:solidFill>
                   <a:srgbClr val="333333"/>
                 </a:solidFill>
@@ -5472,8 +5516,8 @@
         </p:nvSpPr>
         <p:spPr>
           <a:xfrm>
-            <a:off x="6309360" y="3246120"/>
-            <a:ext cx="5486400" cy="2148840"/>
+            <a:off x="6172200" y="3520440"/>
+            <a:ext cx="5532120" cy="2423160"/>
           </a:xfrm>
           <a:prstGeom prst="rect">
             <a:avLst/>
@@ -5518,8 +5562,8 @@
         </p:nvSpPr>
         <p:spPr>
           <a:xfrm>
-            <a:off x="6309360" y="3246120"/>
-            <a:ext cx="5486400" cy="411480"/>
+            <a:off x="6172200" y="3520440"/>
+            <a:ext cx="5532120" cy="457200"/>
           </a:xfrm>
           <a:prstGeom prst="rect">
             <a:avLst/>
@@ -5562,8 +5606,8 @@
         </p:nvSpPr>
         <p:spPr>
           <a:xfrm>
-            <a:off x="6309360" y="3300984"/>
-            <a:ext cx="5486400" cy="320040"/>
+            <a:off x="6172200" y="3593592"/>
+            <a:ext cx="5532120" cy="365760"/>
           </a:xfrm>
           <a:prstGeom prst="rect">
             <a:avLst/>
@@ -5578,7 +5622,7 @@
           <a:p>
             <a:pPr algn="ctr"/>
             <a:r>
-              <a:rPr sz="1300" b="1">
+              <a:rPr sz="1400" b="1">
                 <a:solidFill>
                   <a:srgbClr val="FFFFFF"/>
                 </a:solidFill>
@@ -5596,8 +5640,8 @@
         </p:nvSpPr>
         <p:spPr>
           <a:xfrm>
-            <a:off x="6492240" y="3749039"/>
-            <a:ext cx="5120640" cy="1554480"/>
+            <a:off x="6355080" y="4114800"/>
+            <a:ext cx="5166360" cy="1737360"/>
           </a:xfrm>
           <a:prstGeom prst="rect">
             <a:avLst/>
@@ -5612,7 +5656,7 @@
           <a:p>
             <a:pPr algn="ctr"/>
             <a:r>
-              <a:rPr sz="1200" b="0">
+              <a:rPr sz="1300" b="0">
                 <a:solidFill>
                   <a:srgbClr val="333333"/>
                 </a:solidFill>
@@ -5623,7 +5667,7 @@
           <a:p>
             <a:pPr algn="ctr"/>
             <a:r>
-              <a:rPr sz="1200" b="0">
+              <a:rPr sz="1300" b="0">
                 <a:solidFill>
                   <a:srgbClr val="333333"/>
                 </a:solidFill>
@@ -5634,7 +5678,7 @@
           <a:p>
             <a:pPr algn="ctr"/>
             <a:r>
-              <a:rPr sz="1200" b="0">
+              <a:rPr sz="1300" b="0">
                 <a:solidFill>
                   <a:srgbClr val="333333"/>
                 </a:solidFill>
@@ -5646,22 +5690,68 @@
       </p:sp>
       <p:sp>
         <p:nvSpPr>
-          <p:cNvPr id="22" name="TextBox 21"/>
-          <p:cNvSpPr txBox="1"/>
-          <p:nvPr/>
-        </p:nvSpPr>
-        <p:spPr>
-          <a:xfrm>
-            <a:off x="457200" y="5623560"/>
-            <a:ext cx="11247120" cy="685800"/>
-          </a:xfrm>
-          <a:prstGeom prst="rect">
-            <a:avLst/>
-          </a:prstGeom>
-          <a:noFill/>
-        </p:spPr>
-        <p:txBody>
-          <a:bodyPr wrap="square" anchor="t">
+          <p:cNvPr id="22" name="Rectangle 21"/>
+          <p:cNvSpPr/>
+          <p:nvPr/>
+        </p:nvSpPr>
+        <p:spPr>
+          <a:xfrm>
+            <a:off x="457200" y="6126480"/>
+            <a:ext cx="11247120" cy="365760"/>
+          </a:xfrm>
+          <a:prstGeom prst="rect">
+            <a:avLst/>
+          </a:prstGeom>
+          <a:solidFill>
+            <a:srgbClr val="E8F4FD"/>
+          </a:solidFill>
+          <a:ln>
+            <a:solidFill>
+              <a:srgbClr val="0071DC"/>
+            </a:solidFill>
+          </a:ln>
+          <a:effectLst/>
+        </p:spPr>
+        <p:style>
+          <a:lnRef idx="1">
+            <a:schemeClr val="accent1"/>
+          </a:lnRef>
+          <a:fillRef idx="3">
+            <a:schemeClr val="accent1"/>
+          </a:fillRef>
+          <a:effectRef idx="2">
+            <a:schemeClr val="accent1"/>
+          </a:effectRef>
+          <a:fontRef idx="minor">
+            <a:schemeClr val="lt1"/>
+          </a:fontRef>
+        </p:style>
+        <p:txBody>
+          <a:bodyPr rtlCol="0" anchor="ctr"/>
+          <a:lstStyle/>
+          <a:p>
+            <a:pPr algn="ctr"/>
+          </a:p>
+        </p:txBody>
+      </p:sp>
+      <p:sp>
+        <p:nvSpPr>
+          <p:cNvPr id="23" name="TextBox 22"/>
+          <p:cNvSpPr txBox="1"/>
+          <p:nvPr/>
+        </p:nvSpPr>
+        <p:spPr>
+          <a:xfrm>
+            <a:off x="640080" y="6144768"/>
+            <a:ext cx="10972800" cy="320040"/>
+          </a:xfrm>
+          <a:prstGeom prst="rect">
+            <a:avLst/>
+          </a:prstGeom>
+          <a:noFill/>
+        </p:spPr>
+        <p:txBody>
+          <a:bodyPr wrap="square" anchor="ctr">
             <a:spAutoFit/>
           </a:bodyPr>
           <a:lstStyle/>
@@ -5670,17 +5760,17 @@
             <a:r>
               <a:rPr sz="1000" b="0">
                 <a:solidFill>
-                  <a:srgbClr val="666666"/>
-                </a:solidFill>
-              </a:rPr>
-              <a:t>Screenshot on Slide 17 (Live Demo grid) — insights_competitor page.</a:t>
-            </a:r>
-          </a:p>
-        </p:txBody>
-      </p:sp>
-      <p:sp>
-        <p:nvSpPr>
-          <p:cNvPr id="23" name="TextBox 22"/>
+                  <a:srgbClr val="333333"/>
+                </a:solidFill>
+              </a:rPr>
+              <a:t>Weekly summaries powered by GPT-4o via Walmart Gateway  ·  see Live Demo grid on slide 15 for the actual page.</a:t>
+            </a:r>
+          </a:p>
+        </p:txBody>
+      </p:sp>
+      <p:sp>
+        <p:nvSpPr>
+          <p:cNvPr id="24" name="TextBox 23"/>
           <p:cNvSpPr txBox="1"/>
           <p:nvPr/>
         </p:nvSpPr>
@@ -5714,7 +5804,7 @@
       </p:sp>
       <p:sp>
         <p:nvSpPr>
-          <p:cNvPr id="24" name="TextBox 23"/>
+          <p:cNvPr id="25" name="TextBox 24"/>
           <p:cNvSpPr txBox="1"/>
           <p:nvPr/>
         </p:nvSpPr>
@@ -5928,8 +6018,42 @@
         </p:nvSpPr>
         <p:spPr>
           <a:xfrm>
-            <a:off x="457200" y="960120"/>
-            <a:ext cx="5486400" cy="3200400"/>
+            <a:off x="457200" y="914400"/>
+            <a:ext cx="5486400" cy="320040"/>
+          </a:xfrm>
+          <a:prstGeom prst="rect">
+            <a:avLst/>
+          </a:prstGeom>
+          <a:noFill/>
+        </p:spPr>
+        <p:txBody>
+          <a:bodyPr wrap="square" anchor="t">
+            <a:spAutoFit/>
+          </a:bodyPr>
+          <a:lstStyle/>
+          <a:p>
+            <a:pPr algn="l"/>
+            <a:r>
+              <a:rPr sz="1100" b="1">
+                <a:solidFill>
+                  <a:srgbClr val="0071DC"/>
+                </a:solidFill>
+              </a:rPr>
+              <a:t>WHAT IT DOES</a:t>
+            </a:r>
+          </a:p>
+        </p:txBody>
+      </p:sp>
+      <p:sp>
+        <p:nvSpPr>
+          <p:cNvPr id="7" name="TextBox 6"/>
+          <p:cNvSpPr txBox="1"/>
+          <p:nvPr/>
+        </p:nvSpPr>
+        <p:spPr>
+          <a:xfrm>
+            <a:off x="457200" y="1234440"/>
+            <a:ext cx="5486400" cy="2286000"/>
           </a:xfrm>
           <a:prstGeom prst="rect">
             <a:avLst/>
@@ -5998,7 +6122,7 @@
                   <a:srgbClr val="333333"/>
                 </a:solidFill>
               </a:rPr>
-              <a:t>•  Deep-links open the post directly in Review &amp; Validate</a:t>
+              <a:t>•  Deep-links open the post in Review &amp; Validate</a:t>
             </a:r>
           </a:p>
           <a:p>
@@ -6020,7 +6144,7 @@
       </p:sp>
       <p:pic>
         <p:nvPicPr>
-          <p:cNvPr id="7" name="Picture 6" descr="notifications.png"/>
+          <p:cNvPr id="8" name="Picture 7" descr="notifications.png"/>
           <p:cNvPicPr>
             <a:picLocks noChangeAspect="1"/>
           </p:cNvPicPr>
@@ -6034,7 +6158,7 @@
         </p:blipFill>
         <p:spPr>
           <a:xfrm>
-            <a:off x="6172200" y="960120"/>
+            <a:off x="6172200" y="914400"/>
             <a:ext cx="5669280" cy="3543300"/>
           </a:xfrm>
           <a:prstGeom prst="rect">
@@ -6044,14 +6168,14 @@
       </p:pic>
       <p:sp>
         <p:nvSpPr>
-          <p:cNvPr id="8" name="Rectangle 7"/>
+          <p:cNvPr id="9" name="Rectangle 8"/>
           <p:cNvSpPr/>
           <p:nvPr/>
         </p:nvSpPr>
         <p:spPr>
           <a:xfrm>
-            <a:off x="457200" y="4617720"/>
-            <a:ext cx="5486400" cy="1645920"/>
+            <a:off x="457200" y="3703320"/>
+            <a:ext cx="5486400" cy="1371600"/>
           </a:xfrm>
           <a:prstGeom prst="rect">
             <a:avLst/>
@@ -6090,13 +6214,13 @@
       </p:sp>
       <p:sp>
         <p:nvSpPr>
-          <p:cNvPr id="9" name="TextBox 8"/>
-          <p:cNvSpPr txBox="1"/>
-          <p:nvPr/>
-        </p:nvSpPr>
-        <p:spPr>
-          <a:xfrm>
-            <a:off x="640080" y="4754880"/>
+          <p:cNvPr id="10" name="TextBox 9"/>
+          <p:cNvSpPr txBox="1"/>
+          <p:nvPr/>
+        </p:nvSpPr>
+        <p:spPr>
+          <a:xfrm>
+            <a:off x="640080" y="3794760"/>
             <a:ext cx="5120640" cy="320040"/>
           </a:xfrm>
           <a:prstGeom prst="rect">
@@ -6112,26 +6236,26 @@
           <a:p>
             <a:pPr algn="l"/>
             <a:r>
-              <a:rPr sz="1200" b="1">
+              <a:rPr sz="1100" b="1">
                 <a:solidFill>
                   <a:srgbClr val="0071DC"/>
                 </a:solidFill>
               </a:rPr>
-              <a:t>Priority thresholds</a:t>
-            </a:r>
-          </a:p>
-        </p:txBody>
-      </p:sp>
-      <p:sp>
-        <p:nvSpPr>
-          <p:cNvPr id="10" name="TextBox 9"/>
-          <p:cNvSpPr txBox="1"/>
-          <p:nvPr/>
-        </p:nvSpPr>
-        <p:spPr>
-          <a:xfrm>
-            <a:off x="640080" y="5074920"/>
-            <a:ext cx="5120640" cy="1143000"/>
+              <a:t>PRIORITY THRESHOLDS</a:t>
+            </a:r>
+          </a:p>
+        </p:txBody>
+      </p:sp>
+      <p:sp>
+        <p:nvSpPr>
+          <p:cNvPr id="11" name="TextBox 10"/>
+          <p:cNvSpPr txBox="1"/>
+          <p:nvPr/>
+        </p:nvSpPr>
+        <p:spPr>
+          <a:xfrm>
+            <a:off x="640080" y="4114800"/>
+            <a:ext cx="5120640" cy="914400"/>
           </a:xfrm>
           <a:prstGeom prst="rect">
             <a:avLst/>
@@ -6180,7 +6304,121 @@
       </p:sp>
       <p:sp>
         <p:nvSpPr>
-          <p:cNvPr id="11" name="TextBox 10"/>
+          <p:cNvPr id="12" name="Rectangle 11"/>
+          <p:cNvSpPr/>
+          <p:nvPr/>
+        </p:nvSpPr>
+        <p:spPr>
+          <a:xfrm>
+            <a:off x="457200" y="5212080"/>
+            <a:ext cx="5486400" cy="1234440"/>
+          </a:xfrm>
+          <a:prstGeom prst="rect">
+            <a:avLst/>
+          </a:prstGeom>
+          <a:solidFill>
+            <a:srgbClr val="DCFCE7"/>
+          </a:solidFill>
+          <a:ln>
+            <a:solidFill>
+              <a:srgbClr val="10B981"/>
+            </a:solidFill>
+          </a:ln>
+          <a:effectLst/>
+        </p:spPr>
+        <p:style>
+          <a:lnRef idx="1">
+            <a:schemeClr val="accent1"/>
+          </a:lnRef>
+          <a:fillRef idx="3">
+            <a:schemeClr val="accent1"/>
+          </a:fillRef>
+          <a:effectRef idx="2">
+            <a:schemeClr val="accent1"/>
+          </a:effectRef>
+          <a:fontRef idx="minor">
+            <a:schemeClr val="lt1"/>
+          </a:fontRef>
+        </p:style>
+        <p:txBody>
+          <a:bodyPr rtlCol="0" anchor="ctr"/>
+          <a:lstStyle/>
+          <a:p>
+            <a:pPr algn="ctr"/>
+          </a:p>
+        </p:txBody>
+      </p:sp>
+      <p:sp>
+        <p:nvSpPr>
+          <p:cNvPr id="13" name="TextBox 12"/>
+          <p:cNvSpPr txBox="1"/>
+          <p:nvPr/>
+        </p:nvSpPr>
+        <p:spPr>
+          <a:xfrm>
+            <a:off x="640080" y="5321808"/>
+            <a:ext cx="5120640" cy="320040"/>
+          </a:xfrm>
+          <a:prstGeom prst="rect">
+            <a:avLst/>
+          </a:prstGeom>
+          <a:noFill/>
+        </p:spPr>
+        <p:txBody>
+          <a:bodyPr wrap="square" anchor="t">
+            <a:spAutoFit/>
+          </a:bodyPr>
+          <a:lstStyle/>
+          <a:p>
+            <a:pPr algn="l"/>
+            <a:r>
+              <a:rPr sz="1100" b="1">
+                <a:solidFill>
+                  <a:srgbClr val="10B981"/>
+                </a:solidFill>
+              </a:rPr>
+              <a:t>GROUPS TODAY  (live capture)</a:t>
+            </a:r>
+          </a:p>
+        </p:txBody>
+      </p:sp>
+      <p:sp>
+        <p:nvSpPr>
+          <p:cNvPr id="14" name="TextBox 13"/>
+          <p:cNvSpPr txBox="1"/>
+          <p:nvPr/>
+        </p:nvSpPr>
+        <p:spPr>
+          <a:xfrm>
+            <a:off x="640080" y="5623560"/>
+            <a:ext cx="5120640" cy="777240"/>
+          </a:xfrm>
+          <a:prstGeom prst="rect">
+            <a:avLst/>
+          </a:prstGeom>
+          <a:noFill/>
+        </p:spPr>
+        <p:txBody>
+          <a:bodyPr wrap="square" anchor="t">
+            <a:spAutoFit/>
+          </a:bodyPr>
+          <a:lstStyle/>
+          <a:p>
+            <a:pPr algn="l"/>
+            <a:r>
+              <a:rPr sz="1100" b="0">
+                <a:solidFill>
+                  <a:srgbClr val="333333"/>
+                </a:solidFill>
+              </a:rPr>
+              <a:t>4 routing groups configured  ·  DriverRelatedPost, GIF_, SAMSClub, W+ Membership  ·  delivery status tracked per row in  notification_log.</a:t>
+            </a:r>
+          </a:p>
+        </p:txBody>
+      </p:sp>
+      <p:sp>
+        <p:nvSpPr>
+          <p:cNvPr id="15" name="TextBox 14"/>
           <p:cNvSpPr txBox="1"/>
           <p:nvPr/>
         </p:nvSpPr>
@@ -6214,7 +6452,7 @@
       </p:sp>
       <p:sp>
         <p:nvSpPr>
-          <p:cNvPr id="12" name="TextBox 11"/>
+          <p:cNvPr id="16" name="TextBox 15"/>
           <p:cNvSpPr txBox="1"/>
           <p:nvPr/>
         </p:nvSpPr>
@@ -7991,7 +8229,7 @@
           <a:noFill/>
         </p:spPr>
         <p:txBody>
-          <a:bodyPr wrap="square" anchor="t">
+          <a:bodyPr wrap="square" anchor="ctr">
             <a:spAutoFit/>
           </a:bodyPr>
           <a:lstStyle/>
@@ -8248,7 +8486,7 @@
           <a:noFill/>
         </p:spPr>
         <p:txBody>
-          <a:bodyPr wrap="square" anchor="t">
+          <a:bodyPr wrap="square" anchor="ctr">
             <a:spAutoFit/>
           </a:bodyPr>
           <a:lstStyle/>
@@ -8505,7 +8743,7 @@
           <a:noFill/>
         </p:spPr>
         <p:txBody>
-          <a:bodyPr wrap="square" anchor="t">
+          <a:bodyPr wrap="square" anchor="ctr">
             <a:spAutoFit/>
           </a:bodyPr>
           <a:lstStyle/>
@@ -8762,7 +9000,7 @@
           <a:noFill/>
         </p:spPr>
         <p:txBody>
-          <a:bodyPr wrap="square" anchor="t">
+          <a:bodyPr wrap="square" anchor="ctr">
             <a:spAutoFit/>
           </a:bodyPr>
           <a:lstStyle/>
@@ -10086,7 +10324,7 @@
         <p:spPr>
           <a:xfrm>
             <a:off x="457200" y="4251960"/>
-            <a:ext cx="11247120" cy="1965960"/>
+            <a:ext cx="5532120" cy="2103120"/>
           </a:xfrm>
           <a:prstGeom prst="rect">
             <a:avLst/>
@@ -10131,8 +10369,8 @@
         </p:nvSpPr>
         <p:spPr>
           <a:xfrm>
-            <a:off x="640080" y="4389120"/>
-            <a:ext cx="10972800" cy="320040"/>
+            <a:off x="640080" y="4370832"/>
+            <a:ext cx="5212080" cy="320040"/>
           </a:xfrm>
           <a:prstGeom prst="rect">
             <a:avLst/>
@@ -10147,12 +10385,12 @@
           <a:p>
             <a:pPr algn="l"/>
             <a:r>
-              <a:rPr sz="1300" b="1">
+              <a:rPr sz="1200" b="1">
                 <a:solidFill>
                   <a:srgbClr val="10B981"/>
                 </a:solidFill>
               </a:rPr>
-              <a:t>Design principle — flag, don't drop</a:t>
+              <a:t>DESIGN PRINCIPLE  —  flag, don't drop</a:t>
             </a:r>
           </a:p>
         </p:txBody>
@@ -10166,7 +10404,7 @@
         <p:spPr>
           <a:xfrm>
             <a:off x="640080" y="4709160"/>
-            <a:ext cx="10972800" cy="1463040"/>
+            <a:ext cx="5212080" cy="1554480"/>
           </a:xfrm>
           <a:prstGeom prst="rect">
             <a:avLst/>
@@ -10181,19 +10419,182 @@
           <a:p>
             <a:pPr algn="l"/>
             <a:r>
-              <a:rPr sz="1200" b="0">
+              <a:rPr sz="1100" b="0">
                 <a:solidFill>
                   <a:srgbClr val="333333"/>
                 </a:solidFill>
               </a:rPr>
-              <a:t>Low-trust posts are surfaced with an explanatory chip ("promotional / duplicate / thin-metadata") and can be overridden by an analyst in one click — the override is captured for the learning loop. Every constant in the formula has a stakeholder-arguable English rationale in config/models.yaml.</a:t>
-            </a:r>
-          </a:p>
-        </p:txBody>
-      </p:sp>
-      <p:sp>
-        <p:nvSpPr>
-          <p:cNvPr id="21" name="TextBox 20"/>
+              <a:t>Low-trust posts are surfaced with an explanatory chip (promotional / duplicate / thin-metadata) and can be overridden by an analyst in one click — the override is captured for the learning loop.</a:t>
+            </a:r>
+          </a:p>
+        </p:txBody>
+      </p:sp>
+      <p:sp>
+        <p:nvSpPr>
+          <p:cNvPr id="21" name="Rectangle 20"/>
+          <p:cNvSpPr/>
+          <p:nvPr/>
+        </p:nvSpPr>
+        <p:spPr>
+          <a:xfrm>
+            <a:off x="6172200" y="4251960"/>
+            <a:ext cx="5532120" cy="2103120"/>
+          </a:xfrm>
+          <a:prstGeom prst="rect">
+            <a:avLst/>
+          </a:prstGeom>
+          <a:solidFill>
+            <a:srgbClr val="E8F4FD"/>
+          </a:solidFill>
+          <a:ln>
+            <a:solidFill>
+              <a:srgbClr val="0071DC"/>
+            </a:solidFill>
+          </a:ln>
+          <a:effectLst/>
+        </p:spPr>
+        <p:style>
+          <a:lnRef idx="1">
+            <a:schemeClr val="accent1"/>
+          </a:lnRef>
+          <a:fillRef idx="3">
+            <a:schemeClr val="accent1"/>
+          </a:fillRef>
+          <a:effectRef idx="2">
+            <a:schemeClr val="accent1"/>
+          </a:effectRef>
+          <a:fontRef idx="minor">
+            <a:schemeClr val="lt1"/>
+          </a:fontRef>
+        </p:style>
+        <p:txBody>
+          <a:bodyPr rtlCol="0" anchor="ctr"/>
+          <a:lstStyle/>
+          <a:p>
+            <a:pPr algn="ctr"/>
+          </a:p>
+        </p:txBody>
+      </p:sp>
+      <p:sp>
+        <p:nvSpPr>
+          <p:cNvPr id="22" name="TextBox 21"/>
+          <p:cNvSpPr txBox="1"/>
+          <p:nvPr/>
+        </p:nvSpPr>
+        <p:spPr>
+          <a:xfrm>
+            <a:off x="6355080" y="4370832"/>
+            <a:ext cx="5212080" cy="320040"/>
+          </a:xfrm>
+          <a:prstGeom prst="rect">
+            <a:avLst/>
+          </a:prstGeom>
+          <a:noFill/>
+        </p:spPr>
+        <p:txBody>
+          <a:bodyPr wrap="square" anchor="t">
+            <a:spAutoFit/>
+          </a:bodyPr>
+          <a:lstStyle/>
+          <a:p>
+            <a:pPr algn="l"/>
+            <a:r>
+              <a:rPr sz="1200" b="1">
+                <a:solidFill>
+                  <a:srgbClr val="0071DC"/>
+                </a:solidFill>
+              </a:rPr>
+              <a:t>WHY IT'S DEFENSIBLE</a:t>
+            </a:r>
+          </a:p>
+        </p:txBody>
+      </p:sp>
+      <p:sp>
+        <p:nvSpPr>
+          <p:cNvPr id="23" name="TextBox 22"/>
+          <p:cNvSpPr txBox="1"/>
+          <p:nvPr/>
+        </p:nvSpPr>
+        <p:spPr>
+          <a:xfrm>
+            <a:off x="6355080" y="4709160"/>
+            <a:ext cx="5212080" cy="1600200"/>
+          </a:xfrm>
+          <a:prstGeom prst="rect">
+            <a:avLst/>
+          </a:prstGeom>
+          <a:noFill/>
+        </p:spPr>
+        <p:txBody>
+          <a:bodyPr wrap="square">
+            <a:spAutoFit/>
+          </a:bodyPr>
+          <a:lstStyle/>
+          <a:p>
+            <a:pPr>
+              <a:spcAft>
+                <a:spcPts val="400"/>
+              </a:spcAft>
+            </a:pPr>
+            <a:r>
+              <a:rPr sz="1100" b="0">
+                <a:solidFill>
+                  <a:srgbClr val="333333"/>
+                </a:solidFill>
+              </a:rPr>
+              <a:t>•  Every constant has a plain-English rationale in config/models.yaml</a:t>
+            </a:r>
+          </a:p>
+          <a:p>
+            <a:pPr>
+              <a:spcAft>
+                <a:spcPts val="400"/>
+              </a:spcAft>
+            </a:pPr>
+            <a:r>
+              <a:rPr sz="1100" b="0">
+                <a:solidFill>
+                  <a:srgbClr val="333333"/>
+                </a:solidFill>
+              </a:rPr>
+              <a:t>•  Three named components  →  analyst can see WHY a post is low-trust</a:t>
+            </a:r>
+          </a:p>
+          <a:p>
+            <a:pPr>
+              <a:spcAft>
+                <a:spcPts val="400"/>
+              </a:spcAft>
+            </a:pPr>
+            <a:r>
+              <a:rPr sz="1100" b="0">
+                <a:solidFill>
+                  <a:srgbClr val="333333"/>
+                </a:solidFill>
+              </a:rPr>
+              <a:t>•  12 / 15 confirmed by human annotator on the cross-check</a:t>
+            </a:r>
+          </a:p>
+          <a:p>
+            <a:pPr>
+              <a:spcAft>
+                <a:spcPts val="400"/>
+              </a:spcAft>
+            </a:pPr>
+            <a:r>
+              <a:rPr sz="1100" b="0">
+                <a:solidFill>
+                  <a:srgbClr val="333333"/>
+                </a:solidFill>
+              </a:rPr>
+              <a:t>•  LLM component only invoked in ambiguous zone (cost-controlled)</a:t>
+            </a:r>
+          </a:p>
+        </p:txBody>
+      </p:sp>
+      <p:sp>
+        <p:nvSpPr>
+          <p:cNvPr id="24" name="TextBox 23"/>
           <p:cNvSpPr txBox="1"/>
           <p:nvPr/>
         </p:nvSpPr>
@@ -10227,7 +10628,7 @@
       </p:sp>
       <p:sp>
         <p:nvSpPr>
-          <p:cNvPr id="22" name="TextBox 21"/>
+          <p:cNvPr id="25" name="TextBox 24"/>
           <p:cNvSpPr txBox="1"/>
           <p:nvPr/>
         </p:nvSpPr>
@@ -12114,7 +12515,7 @@
                   <a:srgbClr val="333333"/>
                 </a:solidFill>
               </a:rPr>
-              <a:t>Macro-F1 0.6272 → 0.7642 overall; 0.28 → 1.00 on long posts.  5-fold OOF cross-validation, offline training.</a:t>
+              <a:t>Macro-F1 0.6272 → 0.7642 overall; recovers all long posts (≥ 512 tok, n = 7): RoBERTa 5/7 vs ModernBERT 7/7 correct.  5-fold OOF cross-validation, offline training.</a:t>
             </a:r>
           </a:p>
         </p:txBody>
@@ -13536,7 +13937,7 @@
         <p:spPr>
           <a:xfrm>
             <a:off x="457200" y="960120"/>
-            <a:ext cx="5532120" cy="5257800"/>
+            <a:ext cx="5532120" cy="4480560"/>
           </a:xfrm>
           <a:prstGeom prst="rect">
             <a:avLst/>
@@ -13597,12 +13998,12 @@
           <a:p>
             <a:pPr algn="l"/>
             <a:r>
-              <a:rPr sz="1500" b="1">
+              <a:rPr sz="1300" b="1">
                 <a:solidFill>
                   <a:srgbClr val="10B981"/>
                 </a:solidFill>
               </a:rPr>
-              <a:t>What worked</a:t>
+              <a:t>WHAT WORKED</a:t>
             </a:r>
           </a:p>
         </p:txBody>
@@ -13616,7 +14017,7 @@
         <p:spPr>
           <a:xfrm>
             <a:off x="640080" y="1508760"/>
-            <a:ext cx="5212080" cy="4572000"/>
+            <a:ext cx="5212080" cy="3794760"/>
           </a:xfrm>
           <a:prstGeom prst="rect">
             <a:avLst/>
@@ -13655,7 +14056,7 @@
                   <a:srgbClr val="333333"/>
                 </a:solidFill>
               </a:rPr>
-              <a:t>•  Long-post recovery came for free once we switched off truncation  (≥1024-tok context):  5/7 → 7/7 correct on the ≥ 512-token bucket.</a:t>
+              <a:t>•  Long-post recovery came for free once we switched off truncation  (≥1024-tok context):  5/7 → 7/7 correct on the ≥ 512-tok bucket.</a:t>
             </a:r>
           </a:p>
           <a:p>
@@ -13670,7 +14071,7 @@
                   <a:srgbClr val="333333"/>
                 </a:solidFill>
               </a:rPr>
-              <a:t>•  Removing the image on the final vision merge step ended the 50 % hallucination problem  —  the mechanism, not just the number, is what makes it credible.</a:t>
+              <a:t>•  Removing the image on the final vision merge step ended the 50 % hallucination problem — the mechanism, not just the number, makes it credible.</a:t>
             </a:r>
           </a:p>
           <a:p>
@@ -13700,7 +14101,7 @@
                   <a:srgbClr val="333333"/>
                 </a:solidFill>
               </a:rPr>
-              <a:t>•  HITL feedback table quietly turned into the most useful piece of infrastructure  —  drives few-shot on every click today, retraining tomorrow.</a:t>
+              <a:t>•  HITL feedback table quietly turned into the most useful piece of infrastructure — drives few-shot on every click today, retraining tomorrow.</a:t>
             </a:r>
           </a:p>
         </p:txBody>
@@ -13714,7 +14115,7 @@
         <p:spPr>
           <a:xfrm>
             <a:off x="6172200" y="960120"/>
-            <a:ext cx="5532120" cy="5257800"/>
+            <a:ext cx="5532120" cy="4480560"/>
           </a:xfrm>
           <a:prstGeom prst="rect">
             <a:avLst/>
@@ -13775,12 +14176,12 @@
           <a:p>
             <a:pPr algn="l"/>
             <a:r>
-              <a:rPr sz="1500" b="1">
+              <a:rPr sz="1300" b="1">
                 <a:solidFill>
                   <a:srgbClr val="D97706"/>
                 </a:solidFill>
               </a:rPr>
-              <a:t>What's still open (honest)</a:t>
+              <a:t>WHAT'S STILL OPEN  (honest)</a:t>
             </a:r>
           </a:p>
         </p:txBody>
@@ -13794,7 +14195,7 @@
         <p:spPr>
           <a:xfrm>
             <a:off x="6355080" y="1508760"/>
-            <a:ext cx="5212080" cy="4572000"/>
+            <a:ext cx="5212080" cy="3794760"/>
           </a:xfrm>
           <a:prstGeom prst="rect">
             <a:avLst/>
@@ -13878,14 +14279,128 @@
                   <a:srgbClr val="333333"/>
                 </a:solidFill>
               </a:rPr>
-              <a:t>•  Everything runs on one Mac. Multi-analyst concurrency and retraining automation aren't done  —  they're in the roadmap on the next slide.</a:t>
-            </a:r>
-          </a:p>
-        </p:txBody>
-      </p:sp>
-      <p:sp>
-        <p:nvSpPr>
-          <p:cNvPr id="12" name="TextBox 11"/>
+              <a:t>•  Everything runs on one Mac. Multi-analyst concurrency and retraining automation aren't done  —  in the roadmap on next slide.</a:t>
+            </a:r>
+          </a:p>
+        </p:txBody>
+      </p:sp>
+      <p:sp>
+        <p:nvSpPr>
+          <p:cNvPr id="12" name="Rectangle 11"/>
+          <p:cNvSpPr/>
+          <p:nvPr/>
+        </p:nvSpPr>
+        <p:spPr>
+          <a:xfrm>
+            <a:off x="457200" y="5577840"/>
+            <a:ext cx="11247120" cy="822960"/>
+          </a:xfrm>
+          <a:prstGeom prst="rect">
+            <a:avLst/>
+          </a:prstGeom>
+          <a:solidFill>
+            <a:srgbClr val="E8F4FD"/>
+          </a:solidFill>
+          <a:ln>
+            <a:solidFill>
+              <a:srgbClr val="0071DC"/>
+            </a:solidFill>
+          </a:ln>
+          <a:effectLst/>
+        </p:spPr>
+        <p:style>
+          <a:lnRef idx="1">
+            <a:schemeClr val="accent1"/>
+          </a:lnRef>
+          <a:fillRef idx="3">
+            <a:schemeClr val="accent1"/>
+          </a:fillRef>
+          <a:effectRef idx="2">
+            <a:schemeClr val="accent1"/>
+          </a:effectRef>
+          <a:fontRef idx="minor">
+            <a:schemeClr val="lt1"/>
+          </a:fontRef>
+        </p:style>
+        <p:txBody>
+          <a:bodyPr rtlCol="0" anchor="ctr"/>
+          <a:lstStyle/>
+          <a:p>
+            <a:pPr algn="ctr"/>
+          </a:p>
+        </p:txBody>
+      </p:sp>
+      <p:sp>
+        <p:nvSpPr>
+          <p:cNvPr id="13" name="TextBox 12"/>
+          <p:cNvSpPr txBox="1"/>
+          <p:nvPr/>
+        </p:nvSpPr>
+        <p:spPr>
+          <a:xfrm>
+            <a:off x="640080" y="5669280"/>
+            <a:ext cx="10972800" cy="320040"/>
+          </a:xfrm>
+          <a:prstGeom prst="rect">
+            <a:avLst/>
+          </a:prstGeom>
+          <a:noFill/>
+        </p:spPr>
+        <p:txBody>
+          <a:bodyPr wrap="square" anchor="t">
+            <a:spAutoFit/>
+          </a:bodyPr>
+          <a:lstStyle/>
+          <a:p>
+            <a:pPr algn="l"/>
+            <a:r>
+              <a:rPr sz="1100" b="1">
+                <a:solidFill>
+                  <a:srgbClr val="0071DC"/>
+                </a:solidFill>
+              </a:rPr>
+              <a:t>THE TAKEAWAY</a:t>
+            </a:r>
+          </a:p>
+        </p:txBody>
+      </p:sp>
+      <p:sp>
+        <p:nvSpPr>
+          <p:cNvPr id="14" name="TextBox 13"/>
+          <p:cNvSpPr txBox="1"/>
+          <p:nvPr/>
+        </p:nvSpPr>
+        <p:spPr>
+          <a:xfrm>
+            <a:off x="640080" y="5989320"/>
+            <a:ext cx="10972800" cy="365760"/>
+          </a:xfrm>
+          <a:prstGeom prst="rect">
+            <a:avLst/>
+          </a:prstGeom>
+          <a:noFill/>
+        </p:spPr>
+        <p:txBody>
+          <a:bodyPr wrap="square" anchor="t">
+            <a:spAutoFit/>
+          </a:bodyPr>
+          <a:lstStyle/>
+          <a:p>
+            <a:pPr algn="l"/>
+            <a:r>
+              <a:rPr sz="1100" b="0">
+                <a:solidFill>
+                  <a:srgbClr val="333333"/>
+                </a:solidFill>
+              </a:rPr>
+              <a:t>Mechanism-level wins are what carry the argument; sample-size caveats are what the next horizon of work has to close.</a:t>
+            </a:r>
+          </a:p>
+        </p:txBody>
+      </p:sp>
+      <p:sp>
+        <p:nvSpPr>
+          <p:cNvPr id="15" name="TextBox 14"/>
           <p:cNvSpPr txBox="1"/>
           <p:nvPr/>
         </p:nvSpPr>
@@ -13919,7 +14434,7 @@
       </p:sp>
       <p:sp>
         <p:nvSpPr>
-          <p:cNvPr id="13" name="TextBox 12"/>
+          <p:cNvPr id="16" name="TextBox 15"/>
           <p:cNvSpPr txBox="1"/>
           <p:nvPr/>
         </p:nvSpPr>
@@ -16596,7 +17111,7 @@
         <p:spPr>
           <a:xfrm>
             <a:off x="457200" y="1051560"/>
-            <a:ext cx="11247120" cy="1463040"/>
+            <a:ext cx="11247120" cy="1143000"/>
           </a:xfrm>
           <a:prstGeom prst="rect">
             <a:avLst/>
@@ -16642,7 +17157,7 @@
         <p:spPr>
           <a:xfrm>
             <a:off x="457200" y="1051560"/>
-            <a:ext cx="228600" cy="1463040"/>
+            <a:ext cx="228600" cy="1143000"/>
           </a:xfrm>
           <a:prstGeom prst="rect">
             <a:avLst/>
@@ -16685,7 +17200,7 @@
         </p:nvSpPr>
         <p:spPr>
           <a:xfrm>
-            <a:off x="822960" y="1188720"/>
+            <a:off x="822960" y="1161288"/>
             <a:ext cx="10424160" cy="365760"/>
           </a:xfrm>
           <a:prstGeom prst="rect">
@@ -16719,8 +17234,8 @@
         </p:nvSpPr>
         <p:spPr>
           <a:xfrm>
-            <a:off x="822960" y="1645920"/>
-            <a:ext cx="10424160" cy="822960"/>
+            <a:off x="822960" y="1554480"/>
+            <a:ext cx="10424160" cy="640080"/>
           </a:xfrm>
           <a:prstGeom prst="rect">
             <a:avLst/>
@@ -16753,8 +17268,8 @@
         </p:nvSpPr>
         <p:spPr>
           <a:xfrm>
-            <a:off x="457200" y="2651760"/>
-            <a:ext cx="11247120" cy="1463040"/>
+            <a:off x="457200" y="2331720"/>
+            <a:ext cx="11247120" cy="1143000"/>
           </a:xfrm>
           <a:prstGeom prst="rect">
             <a:avLst/>
@@ -16799,8 +17314,8 @@
         </p:nvSpPr>
         <p:spPr>
           <a:xfrm>
-            <a:off x="457200" y="2651760"/>
-            <a:ext cx="228600" cy="1463040"/>
+            <a:off x="457200" y="2331720"/>
+            <a:ext cx="228600" cy="1143000"/>
           </a:xfrm>
           <a:prstGeom prst="rect">
             <a:avLst/>
@@ -16843,7 +17358,7 @@
         </p:nvSpPr>
         <p:spPr>
           <a:xfrm>
-            <a:off x="822960" y="2788920"/>
+            <a:off x="822960" y="2441448"/>
             <a:ext cx="10424160" cy="365760"/>
           </a:xfrm>
           <a:prstGeom prst="rect">
@@ -16877,8 +17392,8 @@
         </p:nvSpPr>
         <p:spPr>
           <a:xfrm>
-            <a:off x="822960" y="3246120"/>
-            <a:ext cx="10424160" cy="822960"/>
+            <a:off x="822960" y="2834640"/>
+            <a:ext cx="10424160" cy="640080"/>
           </a:xfrm>
           <a:prstGeom prst="rect">
             <a:avLst/>
@@ -16911,8 +17426,8 @@
         </p:nvSpPr>
         <p:spPr>
           <a:xfrm>
-            <a:off x="457200" y="4251960"/>
-            <a:ext cx="11247120" cy="1463040"/>
+            <a:off x="457200" y="3611880"/>
+            <a:ext cx="11247120" cy="1143000"/>
           </a:xfrm>
           <a:prstGeom prst="rect">
             <a:avLst/>
@@ -16957,8 +17472,8 @@
         </p:nvSpPr>
         <p:spPr>
           <a:xfrm>
-            <a:off x="457200" y="4251960"/>
-            <a:ext cx="228600" cy="1463040"/>
+            <a:off x="457200" y="3611880"/>
+            <a:ext cx="228600" cy="1143000"/>
           </a:xfrm>
           <a:prstGeom prst="rect">
             <a:avLst/>
@@ -17001,7 +17516,7 @@
         </p:nvSpPr>
         <p:spPr>
           <a:xfrm>
-            <a:off x="822960" y="4389120"/>
+            <a:off x="822960" y="3721608"/>
             <a:ext cx="10424160" cy="365760"/>
           </a:xfrm>
           <a:prstGeom prst="rect">
@@ -17035,8 +17550,8 @@
         </p:nvSpPr>
         <p:spPr>
           <a:xfrm>
-            <a:off x="822960" y="4846320"/>
-            <a:ext cx="10424160" cy="822960"/>
+            <a:off x="822960" y="4114800"/>
+            <a:ext cx="10424160" cy="640080"/>
           </a:xfrm>
           <a:prstGeom prst="rect">
             <a:avLst/>
@@ -17069,8 +17584,8 @@
         </p:nvSpPr>
         <p:spPr>
           <a:xfrm>
-            <a:off x="457200" y="5852160"/>
-            <a:ext cx="11247120" cy="457200"/>
+            <a:off x="457200" y="5074920"/>
+            <a:ext cx="11247120" cy="1234440"/>
           </a:xfrm>
           <a:prstGeom prst="rect">
             <a:avLst/>
@@ -17115,35 +17630,103 @@
         </p:nvSpPr>
         <p:spPr>
           <a:xfrm>
-            <a:off x="640080" y="5897880"/>
-            <a:ext cx="10972800" cy="365760"/>
-          </a:xfrm>
-          <a:prstGeom prst="rect">
-            <a:avLst/>
-          </a:prstGeom>
-          <a:noFill/>
-        </p:spPr>
-        <p:txBody>
-          <a:bodyPr wrap="square" anchor="ctr">
+            <a:off x="640080" y="5166360"/>
+            <a:ext cx="10972800" cy="320040"/>
+          </a:xfrm>
+          <a:prstGeom prst="rect">
+            <a:avLst/>
+          </a:prstGeom>
+          <a:noFill/>
+        </p:spPr>
+        <p:txBody>
+          <a:bodyPr wrap="square" anchor="t">
             <a:spAutoFit/>
           </a:bodyPr>
           <a:lstStyle/>
           <a:p>
             <a:pPr algn="l"/>
             <a:r>
+              <a:rPr sz="1100" b="1">
+                <a:solidFill>
+                  <a:srgbClr val="0071DC"/>
+                </a:solidFill>
+              </a:rPr>
+              <a:t>DELIBERATELY EXCLUDED</a:t>
+            </a:r>
+          </a:p>
+        </p:txBody>
+      </p:sp>
+      <p:sp>
+        <p:nvSpPr>
+          <p:cNvPr id="20" name="TextBox 19"/>
+          <p:cNvSpPr txBox="1"/>
+          <p:nvPr/>
+        </p:nvSpPr>
+        <p:spPr>
+          <a:xfrm>
+            <a:off x="640080" y="5486400"/>
+            <a:ext cx="10972800" cy="822960"/>
+          </a:xfrm>
+          <a:prstGeom prst="rect">
+            <a:avLst/>
+          </a:prstGeom>
+          <a:noFill/>
+        </p:spPr>
+        <p:txBody>
+          <a:bodyPr wrap="square">
+            <a:spAutoFit/>
+          </a:bodyPr>
+          <a:lstStyle/>
+          <a:p>
+            <a:pPr>
+              <a:spcAft>
+                <a:spcPts val="400"/>
+              </a:spcAft>
+            </a:pPr>
+            <a:r>
               <a:rPr sz="1000" b="0">
                 <a:solidFill>
                   <a:srgbClr val="333333"/>
                 </a:solidFill>
               </a:rPr>
-              <a:t>Deliberately excluded  —  ideas without a clear next step  (auto-reply gate, seasonal P1 forecast, bilingual taxonomy)  —  covered in the report's Future Work chapter.</a:t>
-            </a:r>
-          </a:p>
-        </p:txBody>
-      </p:sp>
-      <p:sp>
-        <p:nvSpPr>
-          <p:cNvPr id="20" name="TextBox 19"/>
+              <a:t>•  Auto-reply confidence gate  —  waiting for edit-distance evidence on more replies</a:t>
+            </a:r>
+          </a:p>
+          <a:p>
+            <a:pPr>
+              <a:spcAft>
+                <a:spcPts val="400"/>
+              </a:spcAft>
+            </a:pPr>
+            <a:r>
+              <a:rPr sz="1000" b="0">
+                <a:solidFill>
+                  <a:srgbClr val="333333"/>
+                </a:solidFill>
+              </a:rPr>
+              <a:t>•  Predictive P1 forecast (seasonal decomposition)  —  needs at least 6 months of daily counts</a:t>
+            </a:r>
+          </a:p>
+          <a:p>
+            <a:pPr>
+              <a:spcAft>
+                <a:spcPts val="400"/>
+              </a:spcAft>
+            </a:pPr>
+            <a:r>
+              <a:rPr sz="1000" b="0">
+                <a:solidFill>
+                  <a:srgbClr val="333333"/>
+                </a:solidFill>
+              </a:rPr>
+              <a:t>•  Bilingual (Hindi + English) taxonomy  —  needs native-speaker validation first</a:t>
+            </a:r>
+          </a:p>
+        </p:txBody>
+      </p:sp>
+      <p:sp>
+        <p:nvSpPr>
+          <p:cNvPr id="21" name="TextBox 20"/>
           <p:cNvSpPr txBox="1"/>
           <p:nvPr/>
         </p:nvSpPr>
@@ -17177,7 +17760,7 @@
       </p:sp>
       <p:sp>
         <p:nvSpPr>
-          <p:cNvPr id="21" name="TextBox 20"/>
+          <p:cNvPr id="22" name="TextBox 21"/>
           <p:cNvSpPr txBox="1"/>
           <p:nvPr/>
         </p:nvSpPr>
@@ -17473,7 +18056,7 @@
         </p:nvGraphicFramePr>
         <p:xfrm>
           <a:off x="457200" y="2148840"/>
-          <a:ext cx="11247120" cy="4114800"/>
+          <a:ext cx="11247120" cy="3108960"/>
         </p:xfrm>
         <a:graphic>
           <a:graphicData uri="http://schemas.openxmlformats.org/drawingml/2006/table">
@@ -17486,7 +18069,7 @@
                 <a:gridCol w="3749040"/>
                 <a:gridCol w="3749040"/>
               </a:tblGrid>
-              <a:tr h="514350">
+              <a:tr h="388620">
                 <a:tc>
                   <a:txBody>
                     <a:bodyPr/>
@@ -17551,7 +18134,7 @@
                   </a:tcPr>
                 </a:tc>
               </a:tr>
-              <a:tr h="514350">
+              <a:tr h="388620">
                 <a:tc>
                   <a:txBody>
                     <a:bodyPr/>
@@ -17616,7 +18199,7 @@
                   </a:tcPr>
                 </a:tc>
               </a:tr>
-              <a:tr h="514350">
+              <a:tr h="388620">
                 <a:tc>
                   <a:txBody>
                     <a:bodyPr/>
@@ -17681,7 +18264,7 @@
                   </a:tcPr>
                 </a:tc>
               </a:tr>
-              <a:tr h="514350">
+              <a:tr h="388620">
                 <a:tc>
                   <a:txBody>
                     <a:bodyPr/>
@@ -17746,7 +18329,7 @@
                   </a:tcPr>
                 </a:tc>
               </a:tr>
-              <a:tr h="514350">
+              <a:tr h="388620">
                 <a:tc>
                   <a:txBody>
                     <a:bodyPr/>
@@ -17811,7 +18394,7 @@
                   </a:tcPr>
                 </a:tc>
               </a:tr>
-              <a:tr h="514350">
+              <a:tr h="388620">
                 <a:tc>
                   <a:txBody>
                     <a:bodyPr/>
@@ -17876,7 +18459,7 @@
                   </a:tcPr>
                 </a:tc>
               </a:tr>
-              <a:tr h="514350">
+              <a:tr h="388620">
                 <a:tc>
                   <a:txBody>
                     <a:bodyPr/>
@@ -17941,7 +18524,7 @@
                   </a:tcPr>
                 </a:tc>
               </a:tr>
-              <a:tr h="514350">
+              <a:tr h="388620">
                 <a:tc>
                   <a:txBody>
                     <a:bodyPr/>
@@ -18012,7 +18595,121 @@
       </p:graphicFrame>
       <p:sp>
         <p:nvSpPr>
-          <p:cNvPr id="9" name="TextBox 8"/>
+          <p:cNvPr id="9" name="Rectangle 8"/>
+          <p:cNvSpPr/>
+          <p:nvPr/>
+        </p:nvSpPr>
+        <p:spPr>
+          <a:xfrm>
+            <a:off x="457200" y="5440680"/>
+            <a:ext cx="11247120" cy="960120"/>
+          </a:xfrm>
+          <a:prstGeom prst="rect">
+            <a:avLst/>
+          </a:prstGeom>
+          <a:solidFill>
+            <a:srgbClr val="DCFCE7"/>
+          </a:solidFill>
+          <a:ln>
+            <a:solidFill>
+              <a:srgbClr val="10B981"/>
+            </a:solidFill>
+          </a:ln>
+          <a:effectLst/>
+        </p:spPr>
+        <p:style>
+          <a:lnRef idx="1">
+            <a:schemeClr val="accent1"/>
+          </a:lnRef>
+          <a:fillRef idx="3">
+            <a:schemeClr val="accent1"/>
+          </a:fillRef>
+          <a:effectRef idx="2">
+            <a:schemeClr val="accent1"/>
+          </a:effectRef>
+          <a:fontRef idx="minor">
+            <a:schemeClr val="lt1"/>
+          </a:fontRef>
+        </p:style>
+        <p:txBody>
+          <a:bodyPr rtlCol="0" anchor="ctr"/>
+          <a:lstStyle/>
+          <a:p>
+            <a:pPr algn="ctr"/>
+          </a:p>
+        </p:txBody>
+      </p:sp>
+      <p:sp>
+        <p:nvSpPr>
+          <p:cNvPr id="10" name="TextBox 9"/>
+          <p:cNvSpPr txBox="1"/>
+          <p:nvPr/>
+        </p:nvSpPr>
+        <p:spPr>
+          <a:xfrm>
+            <a:off x="640080" y="5532120"/>
+            <a:ext cx="10972800" cy="320040"/>
+          </a:xfrm>
+          <a:prstGeom prst="rect">
+            <a:avLst/>
+          </a:prstGeom>
+          <a:noFill/>
+        </p:spPr>
+        <p:txBody>
+          <a:bodyPr wrap="square" anchor="t">
+            <a:spAutoFit/>
+          </a:bodyPr>
+          <a:lstStyle/>
+          <a:p>
+            <a:pPr algn="l"/>
+            <a:r>
+              <a:rPr sz="1100" b="1">
+                <a:solidFill>
+                  <a:srgbClr val="10B981"/>
+                </a:solidFill>
+              </a:rPr>
+              <a:t>REPRODUCE IN 3 STEPS</a:t>
+            </a:r>
+          </a:p>
+        </p:txBody>
+      </p:sp>
+      <p:sp>
+        <p:nvSpPr>
+          <p:cNvPr id="11" name="TextBox 10"/>
+          <p:cNvSpPr txBox="1"/>
+          <p:nvPr/>
+        </p:nvSpPr>
+        <p:spPr>
+          <a:xfrm>
+            <a:off x="640080" y="5852160"/>
+            <a:ext cx="10972800" cy="502920"/>
+          </a:xfrm>
+          <a:prstGeom prst="rect">
+            <a:avLst/>
+          </a:prstGeom>
+          <a:noFill/>
+        </p:spPr>
+        <p:txBody>
+          <a:bodyPr wrap="square" anchor="ctr">
+            <a:spAutoFit/>
+          </a:bodyPr>
+          <a:lstStyle/>
+          <a:p>
+            <a:pPr algn="l"/>
+            <a:r>
+              <a:rPr sz="1100" b="0">
+                <a:solidFill>
+                  <a:srgbClr val="333333"/>
+                </a:solidFill>
+              </a:rPr>
+              <a:t>git clone &lt;repo&gt;   →   conda create -n rsi python=3.11 &amp;&amp; pip install -r requirements.txt   →   ./start.sh</a:t>
+            </a:r>
+          </a:p>
+        </p:txBody>
+      </p:sp>
+      <p:sp>
+        <p:nvSpPr>
+          <p:cNvPr id="12" name="TextBox 11"/>
           <p:cNvSpPr txBox="1"/>
           <p:nvPr/>
         </p:nvSpPr>
@@ -18046,7 +18743,7 @@
       </p:sp>
       <p:sp>
         <p:nvSpPr>
-          <p:cNvPr id="10" name="TextBox 9"/>
+          <p:cNvPr id="13" name="TextBox 12"/>
           <p:cNvSpPr txBox="1"/>
           <p:nvPr/>
         </p:nvSpPr>
@@ -18570,7 +19267,7 @@
         </p:nvSpPr>
         <p:spPr>
           <a:xfrm>
-            <a:off x="457200" y="960120"/>
+            <a:off x="457200" y="914400"/>
             <a:ext cx="5486400" cy="320040"/>
           </a:xfrm>
           <a:prstGeom prst="rect">
@@ -18586,26 +19283,72 @@
           <a:p>
             <a:pPr algn="l"/>
             <a:r>
-              <a:rPr sz="1300" b="1">
+              <a:rPr sz="1100" b="1">
                 <a:solidFill>
                   <a:srgbClr val="D97706"/>
                 </a:solidFill>
               </a:rPr>
-              <a:t>Delivered at mid-sem</a:t>
-            </a:r>
-          </a:p>
-        </p:txBody>
-      </p:sp>
-      <p:sp>
-        <p:nvSpPr>
-          <p:cNvPr id="7" name="TextBox 6"/>
-          <p:cNvSpPr txBox="1"/>
-          <p:nvPr/>
-        </p:nvSpPr>
-        <p:spPr>
-          <a:xfrm>
-            <a:off x="457200" y="1280160"/>
-            <a:ext cx="5486400" cy="3474720"/>
+              <a:t>DELIVERED AT MID-SEM</a:t>
+            </a:r>
+          </a:p>
+        </p:txBody>
+      </p:sp>
+      <p:sp>
+        <p:nvSpPr>
+          <p:cNvPr id="7" name="Rectangle 6"/>
+          <p:cNvSpPr/>
+          <p:nvPr/>
+        </p:nvSpPr>
+        <p:spPr>
+          <a:xfrm>
+            <a:off x="365760" y="1234440"/>
+            <a:ext cx="5760720" cy="3749039"/>
+          </a:xfrm>
+          <a:prstGeom prst="rect">
+            <a:avLst/>
+          </a:prstGeom>
+          <a:solidFill>
+            <a:srgbClr val="FEF3C7"/>
+          </a:solidFill>
+          <a:ln>
+            <a:solidFill>
+              <a:srgbClr val="D97706"/>
+            </a:solidFill>
+          </a:ln>
+          <a:effectLst/>
+        </p:spPr>
+        <p:style>
+          <a:lnRef idx="1">
+            <a:schemeClr val="accent1"/>
+          </a:lnRef>
+          <a:fillRef idx="3">
+            <a:schemeClr val="accent1"/>
+          </a:fillRef>
+          <a:effectRef idx="2">
+            <a:schemeClr val="accent1"/>
+          </a:effectRef>
+          <a:fontRef idx="minor">
+            <a:schemeClr val="lt1"/>
+          </a:fontRef>
+        </p:style>
+        <p:txBody>
+          <a:bodyPr rtlCol="0" anchor="ctr"/>
+          <a:lstStyle/>
+          <a:p>
+            <a:pPr algn="ctr"/>
+          </a:p>
+        </p:txBody>
+      </p:sp>
+      <p:sp>
+        <p:nvSpPr>
+          <p:cNvPr id="8" name="TextBox 7"/>
+          <p:cNvSpPr txBox="1"/>
+          <p:nvPr/>
+        </p:nvSpPr>
+        <p:spPr>
+          <a:xfrm>
+            <a:off x="548640" y="1371600"/>
+            <a:ext cx="5486400" cy="3520440"/>
           </a:xfrm>
           <a:prstGeom prst="rect">
             <a:avLst/>
@@ -18624,7 +19367,7 @@
               </a:spcAft>
             </a:pPr>
             <a:r>
-              <a:rPr sz="1200" b="0">
+              <a:rPr sz="1300" b="0">
                 <a:solidFill>
                   <a:srgbClr val="333333"/>
                 </a:solidFill>
@@ -18639,7 +19382,7 @@
               </a:spcAft>
             </a:pPr>
             <a:r>
-              <a:rPr sz="1200" b="0">
+              <a:rPr sz="1300" b="0">
                 <a:solidFill>
                   <a:srgbClr val="333333"/>
                 </a:solidFill>
@@ -18654,7 +19397,7 @@
               </a:spcAft>
             </a:pPr>
             <a:r>
-              <a:rPr sz="1200" b="0">
+              <a:rPr sz="1300" b="0">
                 <a:solidFill>
                   <a:srgbClr val="333333"/>
                 </a:solidFill>
@@ -18669,7 +19412,7 @@
               </a:spcAft>
             </a:pPr>
             <a:r>
-              <a:rPr sz="1200" b="0">
+              <a:rPr sz="1300" b="0">
                 <a:solidFill>
                   <a:srgbClr val="333333"/>
                 </a:solidFill>
@@ -18684,7 +19427,7 @@
               </a:spcAft>
             </a:pPr>
             <a:r>
-              <a:rPr sz="1200" b="0">
+              <a:rPr sz="1300" b="0">
                 <a:solidFill>
                   <a:srgbClr val="333333"/>
                 </a:solidFill>
@@ -18699,7 +19442,7 @@
               </a:spcAft>
             </a:pPr>
             <a:r>
-              <a:rPr sz="1200" b="0">
+              <a:rPr sz="1300" b="0">
                 <a:solidFill>
                   <a:srgbClr val="333333"/>
                 </a:solidFill>
@@ -18711,13 +19454,13 @@
       </p:sp>
       <p:sp>
         <p:nvSpPr>
-          <p:cNvPr id="8" name="TextBox 7"/>
-          <p:cNvSpPr txBox="1"/>
-          <p:nvPr/>
-        </p:nvSpPr>
-        <p:spPr>
-          <a:xfrm>
-            <a:off x="6263640" y="960120"/>
+          <p:cNvPr id="9" name="TextBox 8"/>
+          <p:cNvSpPr txBox="1"/>
+          <p:nvPr/>
+        </p:nvSpPr>
+        <p:spPr>
+          <a:xfrm>
+            <a:off x="6263640" y="914400"/>
             <a:ext cx="5486400" cy="320040"/>
           </a:xfrm>
           <a:prstGeom prst="rect">
@@ -18733,26 +19476,72 @@
           <a:p>
             <a:pPr algn="l"/>
             <a:r>
-              <a:rPr sz="1300" b="1">
+              <a:rPr sz="1100" b="1">
                 <a:solidFill>
                   <a:srgbClr val="10B981"/>
                 </a:solidFill>
               </a:rPr>
-              <a:t>Added post-midsem  (this deck)</a:t>
-            </a:r>
-          </a:p>
-        </p:txBody>
-      </p:sp>
-      <p:sp>
-        <p:nvSpPr>
-          <p:cNvPr id="9" name="TextBox 8"/>
-          <p:cNvSpPr txBox="1"/>
-          <p:nvPr/>
-        </p:nvSpPr>
-        <p:spPr>
-          <a:xfrm>
-            <a:off x="6263640" y="1280160"/>
-            <a:ext cx="5486400" cy="3474720"/>
+              <a:t>ADDED POST-MIDSEM  (this deck)</a:t>
+            </a:r>
+          </a:p>
+        </p:txBody>
+      </p:sp>
+      <p:sp>
+        <p:nvSpPr>
+          <p:cNvPr id="10" name="Rectangle 9"/>
+          <p:cNvSpPr/>
+          <p:nvPr/>
+        </p:nvSpPr>
+        <p:spPr>
+          <a:xfrm>
+            <a:off x="6172200" y="1234440"/>
+            <a:ext cx="5623560" cy="3749039"/>
+          </a:xfrm>
+          <a:prstGeom prst="rect">
+            <a:avLst/>
+          </a:prstGeom>
+          <a:solidFill>
+            <a:srgbClr val="DCFCE7"/>
+          </a:solidFill>
+          <a:ln>
+            <a:solidFill>
+              <a:srgbClr val="10B981"/>
+            </a:solidFill>
+          </a:ln>
+          <a:effectLst/>
+        </p:spPr>
+        <p:style>
+          <a:lnRef idx="1">
+            <a:schemeClr val="accent1"/>
+          </a:lnRef>
+          <a:fillRef idx="3">
+            <a:schemeClr val="accent1"/>
+          </a:fillRef>
+          <a:effectRef idx="2">
+            <a:schemeClr val="accent1"/>
+          </a:effectRef>
+          <a:fontRef idx="minor">
+            <a:schemeClr val="lt1"/>
+          </a:fontRef>
+        </p:style>
+        <p:txBody>
+          <a:bodyPr rtlCol="0" anchor="ctr"/>
+          <a:lstStyle/>
+          <a:p>
+            <a:pPr algn="ctr"/>
+          </a:p>
+        </p:txBody>
+      </p:sp>
+      <p:sp>
+        <p:nvSpPr>
+          <p:cNvPr id="11" name="TextBox 10"/>
+          <p:cNvSpPr txBox="1"/>
+          <p:nvPr/>
+        </p:nvSpPr>
+        <p:spPr>
+          <a:xfrm>
+            <a:off x="6355080" y="1371600"/>
+            <a:ext cx="5349240" cy="3520440"/>
           </a:xfrm>
           <a:prstGeom prst="rect">
             <a:avLst/>
@@ -18791,7 +19580,7 @@
                   <a:srgbClr val="333333"/>
                 </a:solidFill>
               </a:rPr>
-              <a:t>•  Smart Reply Composer  —  triple-draft (GPT-4o + Mistral + Smart Composer)</a:t>
+              <a:t>•  Smart Reply Composer  —  triple-draft (GPT-4o + Mistral + Smart)</a:t>
             </a:r>
           </a:p>
           <a:p>
@@ -18881,7 +19670,7 @@
                   <a:srgbClr val="333333"/>
                 </a:solidFill>
               </a:rPr>
-              <a:t>•  ModernBERT Stage 3 (final)  —  Macro-F1 0.7285 → 0.7642  (5-fold OOF)</a:t>
+              <a:t>•  ModernBERT Stage 3 (final)  —  0.7285 → 0.7642  (5-fold OOF)</a:t>
             </a:r>
           </a:p>
           <a:p>
@@ -18903,13 +19692,13 @@
       </p:sp>
       <p:sp>
         <p:nvSpPr>
-          <p:cNvPr id="10" name="Rectangle 9"/>
+          <p:cNvPr id="12" name="Rectangle 11"/>
           <p:cNvSpPr/>
           <p:nvPr/>
         </p:nvSpPr>
         <p:spPr>
           <a:xfrm>
-            <a:off x="457200" y="5074920"/>
+            <a:off x="457200" y="5212080"/>
             <a:ext cx="11247120" cy="1234440"/>
           </a:xfrm>
           <a:prstGeom prst="rect">
@@ -18949,14 +19738,48 @@
       </p:sp>
       <p:sp>
         <p:nvSpPr>
-          <p:cNvPr id="11" name="TextBox 10"/>
-          <p:cNvSpPr txBox="1"/>
-          <p:nvPr/>
-        </p:nvSpPr>
-        <p:spPr>
-          <a:xfrm>
-            <a:off x="640080" y="5212080"/>
-            <a:ext cx="10972800" cy="365760"/>
+          <p:cNvPr id="13" name="TextBox 12"/>
+          <p:cNvSpPr txBox="1"/>
+          <p:nvPr/>
+        </p:nvSpPr>
+        <p:spPr>
+          <a:xfrm>
+            <a:off x="640080" y="5257800"/>
+            <a:ext cx="548640" cy="1097280"/>
+          </a:xfrm>
+          <a:prstGeom prst="rect">
+            <a:avLst/>
+          </a:prstGeom>
+          <a:noFill/>
+        </p:spPr>
+        <p:txBody>
+          <a:bodyPr wrap="square" anchor="ctr">
+            <a:spAutoFit/>
+          </a:bodyPr>
+          <a:lstStyle/>
+          <a:p>
+            <a:pPr algn="l"/>
+            <a:r>
+              <a:rPr sz="5200" b="1">
+                <a:solidFill>
+                  <a:srgbClr val="0071DC"/>
+                </a:solidFill>
+              </a:rPr>
+              <a:t>“</a:t>
+            </a:r>
+          </a:p>
+        </p:txBody>
+      </p:sp>
+      <p:sp>
+        <p:nvSpPr>
+          <p:cNvPr id="14" name="TextBox 13"/>
+          <p:cNvSpPr txBox="1"/>
+          <p:nvPr/>
+        </p:nvSpPr>
+        <p:spPr>
+          <a:xfrm>
+            <a:off x="1188720" y="5321808"/>
+            <a:ext cx="10424160" cy="320040"/>
           </a:xfrm>
           <a:prstGeom prst="rect">
             <a:avLst/>
@@ -18971,26 +19794,26 @@
           <a:p>
             <a:pPr algn="l"/>
             <a:r>
-              <a:rPr sz="1300" b="1">
+              <a:rPr sz="1100" b="1">
                 <a:solidFill>
                   <a:srgbClr val="0071DC"/>
                 </a:solidFill>
               </a:rPr>
-              <a:t>Framing</a:t>
-            </a:r>
-          </a:p>
-        </p:txBody>
-      </p:sp>
-      <p:sp>
-        <p:nvSpPr>
-          <p:cNvPr id="12" name="TextBox 11"/>
-          <p:cNvSpPr txBox="1"/>
-          <p:nvPr/>
-        </p:nvSpPr>
-        <p:spPr>
-          <a:xfrm>
-            <a:off x="640080" y="5577840"/>
-            <a:ext cx="10972800" cy="731520"/>
+              <a:t>THE FRAMING QUESTION</a:t>
+            </a:r>
+          </a:p>
+        </p:txBody>
+      </p:sp>
+      <p:sp>
+        <p:nvSpPr>
+          <p:cNvPr id="15" name="TextBox 14"/>
+          <p:cNvSpPr txBox="1"/>
+          <p:nvPr/>
+        </p:nvSpPr>
+        <p:spPr>
+          <a:xfrm>
+            <a:off x="1188720" y="5623560"/>
+            <a:ext cx="10424160" cy="777240"/>
           </a:xfrm>
           <a:prstGeom prst="rect">
             <a:avLst/>
@@ -19010,14 +19833,14 @@
                   <a:srgbClr val="333333"/>
                 </a:solidFill>
               </a:rPr>
-              <a:t>Mid-sem answered can the pipeline produce trust-weighted sentiment?    Post-midsem answers can an analyst act on it, correct it, and feed the corrections back into the model?</a:t>
-            </a:r>
-          </a:p>
-        </p:txBody>
-      </p:sp>
-      <p:sp>
-        <p:nvSpPr>
-          <p:cNvPr id="13" name="TextBox 12"/>
+              <a:t>Mid-sem answered  can the pipeline produce trust-weighted sentiment?    Post-midsem answers  can an analyst act on it, correct it, and feed the corrections back into the model?</a:t>
+            </a:r>
+          </a:p>
+        </p:txBody>
+      </p:sp>
+      <p:sp>
+        <p:nvSpPr>
+          <p:cNvPr id="16" name="TextBox 15"/>
           <p:cNvSpPr txBox="1"/>
           <p:nvPr/>
         </p:nvSpPr>
@@ -19051,7 +19874,7 @@
       </p:sp>
       <p:sp>
         <p:nvSpPr>
-          <p:cNvPr id="14" name="TextBox 13"/>
+          <p:cNvPr id="17" name="TextBox 16"/>
           <p:cNvSpPr txBox="1"/>
           <p:nvPr/>
         </p:nvSpPr>
@@ -19265,8 +20088,42 @@
         </p:nvSpPr>
         <p:spPr>
           <a:xfrm>
-            <a:off x="457200" y="960120"/>
-            <a:ext cx="5486400" cy="2560320"/>
+            <a:off x="457200" y="914400"/>
+            <a:ext cx="5486400" cy="320040"/>
+          </a:xfrm>
+          <a:prstGeom prst="rect">
+            <a:avLst/>
+          </a:prstGeom>
+          <a:noFill/>
+        </p:spPr>
+        <p:txBody>
+          <a:bodyPr wrap="square" anchor="t">
+            <a:spAutoFit/>
+          </a:bodyPr>
+          <a:lstStyle/>
+          <a:p>
+            <a:pPr algn="l"/>
+            <a:r>
+              <a:rPr sz="1100" b="1">
+                <a:solidFill>
+                  <a:srgbClr val="0071DC"/>
+                </a:solidFill>
+              </a:rPr>
+              <a:t>WORKFLOW</a:t>
+            </a:r>
+          </a:p>
+        </p:txBody>
+      </p:sp>
+      <p:sp>
+        <p:nvSpPr>
+          <p:cNvPr id="7" name="TextBox 6"/>
+          <p:cNvSpPr txBox="1"/>
+          <p:nvPr/>
+        </p:nvSpPr>
+        <p:spPr>
+          <a:xfrm>
+            <a:off x="457200" y="1234440"/>
+            <a:ext cx="5486400" cy="2468880"/>
           </a:xfrm>
           <a:prstGeom prst="rect">
             <a:avLst/>
@@ -19335,7 +20192,7 @@
                   <a:srgbClr val="333333"/>
                 </a:solidFill>
               </a:rPr>
-              <a:t>•  Generate Drafts  →  three reply options  (GPT-4o + Mistral + Smart Composer)</a:t>
+              <a:t>•  Generate Drafts  →  three reply options  (GPT-4o + Mistral + Smart)</a:t>
             </a:r>
           </a:p>
           <a:p>
@@ -19372,7 +20229,7 @@
       </p:sp>
       <p:pic>
         <p:nvPicPr>
-          <p:cNvPr id="7" name="Picture 6" descr="review_validate.png"/>
+          <p:cNvPr id="8" name="Picture 7" descr="review_validate.png"/>
           <p:cNvPicPr>
             <a:picLocks noChangeAspect="1"/>
           </p:cNvPicPr>
@@ -19396,14 +20253,14 @@
       </p:pic>
       <p:sp>
         <p:nvSpPr>
-          <p:cNvPr id="8" name="Rectangle 7"/>
+          <p:cNvPr id="9" name="Rectangle 8"/>
           <p:cNvSpPr/>
           <p:nvPr/>
         </p:nvSpPr>
         <p:spPr>
           <a:xfrm>
-            <a:off x="457200" y="5212080"/>
-            <a:ext cx="5486400" cy="1097280"/>
+            <a:off x="457200" y="3794760"/>
+            <a:ext cx="5486400" cy="1188720"/>
           </a:xfrm>
           <a:prstGeom prst="rect">
             <a:avLst/>
@@ -19442,13 +20299,13 @@
       </p:sp>
       <p:sp>
         <p:nvSpPr>
-          <p:cNvPr id="9" name="TextBox 8"/>
-          <p:cNvSpPr txBox="1"/>
-          <p:nvPr/>
-        </p:nvSpPr>
-        <p:spPr>
-          <a:xfrm>
-            <a:off x="640080" y="5349240"/>
+          <p:cNvPr id="10" name="TextBox 9"/>
+          <p:cNvSpPr txBox="1"/>
+          <p:nvPr/>
+        </p:nvSpPr>
+        <p:spPr>
+          <a:xfrm>
+            <a:off x="640080" y="3913632"/>
             <a:ext cx="5120640" cy="320040"/>
           </a:xfrm>
           <a:prstGeom prst="rect">
@@ -19464,26 +20321,26 @@
           <a:p>
             <a:pPr algn="l"/>
             <a:r>
-              <a:rPr sz="1200" b="1">
+              <a:rPr sz="1100" b="1">
                 <a:solidFill>
                   <a:srgbClr val="10B981"/>
                 </a:solidFill>
               </a:rPr>
-              <a:t>Why it matters</a:t>
-            </a:r>
-          </a:p>
-        </p:txBody>
-      </p:sp>
-      <p:sp>
-        <p:nvSpPr>
-          <p:cNvPr id="10" name="TextBox 9"/>
-          <p:cNvSpPr txBox="1"/>
-          <p:nvPr/>
-        </p:nvSpPr>
-        <p:spPr>
-          <a:xfrm>
-            <a:off x="640080" y="5669280"/>
-            <a:ext cx="5120640" cy="640080"/>
+              <a:t>WHY IT MATTERS</a:t>
+            </a:r>
+          </a:p>
+        </p:txBody>
+      </p:sp>
+      <p:sp>
+        <p:nvSpPr>
+          <p:cNvPr id="11" name="TextBox 10"/>
+          <p:cNvSpPr txBox="1"/>
+          <p:nvPr/>
+        </p:nvSpPr>
+        <p:spPr>
+          <a:xfrm>
+            <a:off x="640080" y="4206240"/>
+            <a:ext cx="5120640" cy="777240"/>
           </a:xfrm>
           <a:prstGeom prst="rect">
             <a:avLst/>
@@ -19510,7 +20367,121 @@
       </p:sp>
       <p:sp>
         <p:nvSpPr>
-          <p:cNvPr id="11" name="TextBox 10"/>
+          <p:cNvPr id="12" name="Rectangle 11"/>
+          <p:cNvSpPr/>
+          <p:nvPr/>
+        </p:nvSpPr>
+        <p:spPr>
+          <a:xfrm>
+            <a:off x="457200" y="5120640"/>
+            <a:ext cx="5486400" cy="1280160"/>
+          </a:xfrm>
+          <a:prstGeom prst="rect">
+            <a:avLst/>
+          </a:prstGeom>
+          <a:solidFill>
+            <a:srgbClr val="E8F4FD"/>
+          </a:solidFill>
+          <a:ln>
+            <a:solidFill>
+              <a:srgbClr val="0071DC"/>
+            </a:solidFill>
+          </a:ln>
+          <a:effectLst/>
+        </p:spPr>
+        <p:style>
+          <a:lnRef idx="1">
+            <a:schemeClr val="accent1"/>
+          </a:lnRef>
+          <a:fillRef idx="3">
+            <a:schemeClr val="accent1"/>
+          </a:fillRef>
+          <a:effectRef idx="2">
+            <a:schemeClr val="accent1"/>
+          </a:effectRef>
+          <a:fontRef idx="minor">
+            <a:schemeClr val="lt1"/>
+          </a:fontRef>
+        </p:style>
+        <p:txBody>
+          <a:bodyPr rtlCol="0" anchor="ctr"/>
+          <a:lstStyle/>
+          <a:p>
+            <a:pPr algn="ctr"/>
+          </a:p>
+        </p:txBody>
+      </p:sp>
+      <p:sp>
+        <p:nvSpPr>
+          <p:cNvPr id="13" name="TextBox 12"/>
+          <p:cNvSpPr txBox="1"/>
+          <p:nvPr/>
+        </p:nvSpPr>
+        <p:spPr>
+          <a:xfrm>
+            <a:off x="640080" y="5230368"/>
+            <a:ext cx="5120640" cy="320040"/>
+          </a:xfrm>
+          <a:prstGeom prst="rect">
+            <a:avLst/>
+          </a:prstGeom>
+          <a:noFill/>
+        </p:spPr>
+        <p:txBody>
+          <a:bodyPr wrap="square" anchor="t">
+            <a:spAutoFit/>
+          </a:bodyPr>
+          <a:lstStyle/>
+          <a:p>
+            <a:pPr algn="l"/>
+            <a:r>
+              <a:rPr sz="1100" b="1">
+                <a:solidFill>
+                  <a:srgbClr val="0071DC"/>
+                </a:solidFill>
+              </a:rPr>
+              <a:t>NUMBERS TODAY  (live capture)</a:t>
+            </a:r>
+          </a:p>
+        </p:txBody>
+      </p:sp>
+      <p:sp>
+        <p:nvSpPr>
+          <p:cNvPr id="14" name="TextBox 13"/>
+          <p:cNvSpPr txBox="1"/>
+          <p:nvPr/>
+        </p:nvSpPr>
+        <p:spPr>
+          <a:xfrm>
+            <a:off x="640080" y="5532120"/>
+            <a:ext cx="5120640" cy="822960"/>
+          </a:xfrm>
+          <a:prstGeom prst="rect">
+            <a:avLst/>
+          </a:prstGeom>
+          <a:noFill/>
+        </p:spPr>
+        <p:txBody>
+          <a:bodyPr wrap="square" anchor="t">
+            <a:spAutoFit/>
+          </a:bodyPr>
+          <a:lstStyle/>
+          <a:p>
+            <a:pPr algn="l"/>
+            <a:r>
+              <a:rPr sz="1100" b="0">
+                <a:solidFill>
+                  <a:srgbClr val="333333"/>
+                </a:solidFill>
+              </a:rPr>
+              <a:t>18 posted replies logged  ·  60 total feedback rows  ·  ≈90 % analyst – model agreement on the last 30 reviews.</a:t>
+            </a:r>
+          </a:p>
+        </p:txBody>
+      </p:sp>
+      <p:sp>
+        <p:nvSpPr>
+          <p:cNvPr id="15" name="TextBox 14"/>
           <p:cNvSpPr txBox="1"/>
           <p:nvPr/>
         </p:nvSpPr>
@@ -19544,7 +20515,7 @@
       </p:sp>
       <p:sp>
         <p:nvSpPr>
-          <p:cNvPr id="12" name="TextBox 11"/>
+          <p:cNvPr id="16" name="TextBox 15"/>
           <p:cNvSpPr txBox="1"/>
           <p:nvPr/>
         </p:nvSpPr>
@@ -19882,7 +20853,7 @@
         </p:nvSpPr>
         <p:spPr>
           <a:xfrm>
-            <a:off x="365760" y="1508760"/>
+            <a:off x="365760" y="1554480"/>
             <a:ext cx="3794760" cy="365760"/>
           </a:xfrm>
           <a:prstGeom prst="rect">
@@ -19898,7 +20869,7 @@
           <a:p>
             <a:pPr algn="ctr"/>
             <a:r>
-              <a:rPr sz="1600" b="1">
+              <a:rPr sz="1700" b="1">
                 <a:solidFill>
                   <a:srgbClr val="041E42"/>
                 </a:solidFill>
@@ -19916,8 +20887,8 @@
         </p:nvSpPr>
         <p:spPr>
           <a:xfrm>
-            <a:off x="365760" y="1920240"/>
-            <a:ext cx="3794760" cy="320040"/>
+            <a:off x="365760" y="1965960"/>
+            <a:ext cx="3794760" cy="274320"/>
           </a:xfrm>
           <a:prstGeom prst="rect">
             <a:avLst/>
@@ -19944,29 +20915,73 @@
       </p:sp>
       <p:sp>
         <p:nvSpPr>
-          <p:cNvPr id="11" name="TextBox 10"/>
-          <p:cNvSpPr txBox="1"/>
-          <p:nvPr/>
-        </p:nvSpPr>
-        <p:spPr>
-          <a:xfrm>
-            <a:off x="548640" y="2331720"/>
-            <a:ext cx="3429000" cy="1645920"/>
-          </a:xfrm>
-          <a:prstGeom prst="rect">
-            <a:avLst/>
-          </a:prstGeom>
-          <a:noFill/>
-        </p:spPr>
-        <p:txBody>
-          <a:bodyPr wrap="square" anchor="ctr">
-            <a:spAutoFit/>
-          </a:bodyPr>
-          <a:lstStyle/>
-          <a:p>
-            <a:pPr algn="ctr"/>
-            <a:r>
-              <a:rPr sz="1100" b="0">
+          <p:cNvPr id="11" name="Rectangle 10"/>
+          <p:cNvSpPr/>
+          <p:nvPr/>
+        </p:nvSpPr>
+        <p:spPr>
+          <a:xfrm>
+            <a:off x="822960" y="2331720"/>
+            <a:ext cx="2880360" cy="18288"/>
+          </a:xfrm>
+          <a:prstGeom prst="rect">
+            <a:avLst/>
+          </a:prstGeom>
+          <a:solidFill>
+            <a:srgbClr val="0071DC"/>
+          </a:solidFill>
+          <a:ln>
+            <a:noFill/>
+          </a:ln>
+          <a:effectLst/>
+        </p:spPr>
+        <p:style>
+          <a:lnRef idx="1">
+            <a:schemeClr val="accent1"/>
+          </a:lnRef>
+          <a:fillRef idx="3">
+            <a:schemeClr val="accent1"/>
+          </a:fillRef>
+          <a:effectRef idx="2">
+            <a:schemeClr val="accent1"/>
+          </a:effectRef>
+          <a:fontRef idx="minor">
+            <a:schemeClr val="lt1"/>
+          </a:fontRef>
+        </p:style>
+        <p:txBody>
+          <a:bodyPr rtlCol="0" anchor="ctr"/>
+          <a:lstStyle/>
+          <a:p>
+            <a:pPr algn="ctr"/>
+          </a:p>
+        </p:txBody>
+      </p:sp>
+      <p:sp>
+        <p:nvSpPr>
+          <p:cNvPr id="12" name="TextBox 11"/>
+          <p:cNvSpPr txBox="1"/>
+          <p:nvPr/>
+        </p:nvSpPr>
+        <p:spPr>
+          <a:xfrm>
+            <a:off x="548640" y="2468880"/>
+            <a:ext cx="3429000" cy="1463040"/>
+          </a:xfrm>
+          <a:prstGeom prst="rect">
+            <a:avLst/>
+          </a:prstGeom>
+          <a:noFill/>
+        </p:spPr>
+        <p:txBody>
+          <a:bodyPr wrap="square" anchor="t">
+            <a:spAutoFit/>
+          </a:bodyPr>
+          <a:lstStyle/>
+          <a:p>
+            <a:pPr algn="ctr"/>
+            <a:r>
+              <a:rPr sz="1200" b="0">
                 <a:solidFill>
                   <a:srgbClr val="333333"/>
                 </a:solidFill>
@@ -19977,7 +20992,7 @@
           <a:p>
             <a:pPr algn="ctr"/>
             <a:r>
-              <a:rPr sz="1100" b="0">
+              <a:rPr sz="1200" b="0">
                 <a:solidFill>
                   <a:srgbClr val="333333"/>
                 </a:solidFill>
@@ -19988,7 +21003,7 @@
           <a:p>
             <a:pPr algn="ctr"/>
             <a:r>
-              <a:rPr sz="1100" b="0">
+              <a:rPr sz="1200" b="0">
                 <a:solidFill>
                   <a:srgbClr val="333333"/>
                 </a:solidFill>
@@ -19999,7 +21014,7 @@
           <a:p>
             <a:pPr algn="ctr"/>
             <a:r>
-              <a:rPr sz="1100" b="0">
+              <a:rPr sz="1200" b="0">
                 <a:solidFill>
                   <a:srgbClr val="333333"/>
                 </a:solidFill>
@@ -20011,7 +21026,7 @@
       </p:sp>
       <p:sp>
         <p:nvSpPr>
-          <p:cNvPr id="12" name="Rectangle 11"/>
+          <p:cNvPr id="13" name="Rectangle 12"/>
           <p:cNvSpPr/>
           <p:nvPr/>
         </p:nvSpPr>
@@ -20057,7 +21072,7 @@
       </p:sp>
       <p:sp>
         <p:nvSpPr>
-          <p:cNvPr id="13" name="Rectangle 12"/>
+          <p:cNvPr id="14" name="Rectangle 13"/>
           <p:cNvSpPr/>
           <p:nvPr/>
         </p:nvSpPr>
@@ -20101,7 +21116,7 @@
       </p:sp>
       <p:sp>
         <p:nvSpPr>
-          <p:cNvPr id="14" name="TextBox 13"/>
+          <p:cNvPr id="15" name="TextBox 14"/>
           <p:cNvSpPr txBox="1"/>
           <p:nvPr/>
         </p:nvSpPr>
@@ -20135,13 +21150,13 @@
       </p:sp>
       <p:sp>
         <p:nvSpPr>
-          <p:cNvPr id="15" name="TextBox 14"/>
-          <p:cNvSpPr txBox="1"/>
-          <p:nvPr/>
-        </p:nvSpPr>
-        <p:spPr>
-          <a:xfrm>
-            <a:off x="4297680" y="1508760"/>
+          <p:cNvPr id="16" name="TextBox 15"/>
+          <p:cNvSpPr txBox="1"/>
+          <p:nvPr/>
+        </p:nvSpPr>
+        <p:spPr>
+          <a:xfrm>
+            <a:off x="4297680" y="1554480"/>
             <a:ext cx="3794760" cy="365760"/>
           </a:xfrm>
           <a:prstGeom prst="rect">
@@ -20157,7 +21172,7 @@
           <a:p>
             <a:pPr algn="ctr"/>
             <a:r>
-              <a:rPr sz="1600" b="1">
+              <a:rPr sz="1700" b="1">
                 <a:solidFill>
                   <a:srgbClr val="041E42"/>
                 </a:solidFill>
@@ -20169,14 +21184,14 @@
       </p:sp>
       <p:sp>
         <p:nvSpPr>
-          <p:cNvPr id="16" name="TextBox 15"/>
-          <p:cNvSpPr txBox="1"/>
-          <p:nvPr/>
-        </p:nvSpPr>
-        <p:spPr>
-          <a:xfrm>
-            <a:off x="4297680" y="1920240"/>
-            <a:ext cx="3794760" cy="320040"/>
+          <p:cNvPr id="17" name="TextBox 16"/>
+          <p:cNvSpPr txBox="1"/>
+          <p:nvPr/>
+        </p:nvSpPr>
+        <p:spPr>
+          <a:xfrm>
+            <a:off x="4297680" y="1965960"/>
+            <a:ext cx="3794760" cy="274320"/>
           </a:xfrm>
           <a:prstGeom prst="rect">
             <a:avLst/>
@@ -20203,29 +21218,73 @@
       </p:sp>
       <p:sp>
         <p:nvSpPr>
-          <p:cNvPr id="17" name="TextBox 16"/>
-          <p:cNvSpPr txBox="1"/>
-          <p:nvPr/>
-        </p:nvSpPr>
-        <p:spPr>
-          <a:xfrm>
-            <a:off x="4480560" y="2331720"/>
-            <a:ext cx="3429000" cy="1645920"/>
-          </a:xfrm>
-          <a:prstGeom prst="rect">
-            <a:avLst/>
-          </a:prstGeom>
-          <a:noFill/>
-        </p:spPr>
-        <p:txBody>
-          <a:bodyPr wrap="square" anchor="ctr">
-            <a:spAutoFit/>
-          </a:bodyPr>
-          <a:lstStyle/>
-          <a:p>
-            <a:pPr algn="ctr"/>
-            <a:r>
-              <a:rPr sz="1100" b="0">
+          <p:cNvPr id="18" name="Rectangle 17"/>
+          <p:cNvSpPr/>
+          <p:nvPr/>
+        </p:nvSpPr>
+        <p:spPr>
+          <a:xfrm>
+            <a:off x="4754880" y="2331720"/>
+            <a:ext cx="2880360" cy="18288"/>
+          </a:xfrm>
+          <a:prstGeom prst="rect">
+            <a:avLst/>
+          </a:prstGeom>
+          <a:solidFill>
+            <a:srgbClr val="7C3AED"/>
+          </a:solidFill>
+          <a:ln>
+            <a:noFill/>
+          </a:ln>
+          <a:effectLst/>
+        </p:spPr>
+        <p:style>
+          <a:lnRef idx="1">
+            <a:schemeClr val="accent1"/>
+          </a:lnRef>
+          <a:fillRef idx="3">
+            <a:schemeClr val="accent1"/>
+          </a:fillRef>
+          <a:effectRef idx="2">
+            <a:schemeClr val="accent1"/>
+          </a:effectRef>
+          <a:fontRef idx="minor">
+            <a:schemeClr val="lt1"/>
+          </a:fontRef>
+        </p:style>
+        <p:txBody>
+          <a:bodyPr rtlCol="0" anchor="ctr"/>
+          <a:lstStyle/>
+          <a:p>
+            <a:pPr algn="ctr"/>
+          </a:p>
+        </p:txBody>
+      </p:sp>
+      <p:sp>
+        <p:nvSpPr>
+          <p:cNvPr id="19" name="TextBox 18"/>
+          <p:cNvSpPr txBox="1"/>
+          <p:nvPr/>
+        </p:nvSpPr>
+        <p:spPr>
+          <a:xfrm>
+            <a:off x="4480560" y="2468880"/>
+            <a:ext cx="3429000" cy="1463040"/>
+          </a:xfrm>
+          <a:prstGeom prst="rect">
+            <a:avLst/>
+          </a:prstGeom>
+          <a:noFill/>
+        </p:spPr>
+        <p:txBody>
+          <a:bodyPr wrap="square" anchor="t">
+            <a:spAutoFit/>
+          </a:bodyPr>
+          <a:lstStyle/>
+          <a:p>
+            <a:pPr algn="ctr"/>
+            <a:r>
+              <a:rPr sz="1200" b="0">
                 <a:solidFill>
                   <a:srgbClr val="333333"/>
                 </a:solidFill>
@@ -20236,7 +21295,7 @@
           <a:p>
             <a:pPr algn="ctr"/>
             <a:r>
-              <a:rPr sz="1100" b="0">
+              <a:rPr sz="1200" b="0">
                 <a:solidFill>
                   <a:srgbClr val="333333"/>
                 </a:solidFill>
@@ -20247,7 +21306,7 @@
           <a:p>
             <a:pPr algn="ctr"/>
             <a:r>
-              <a:rPr sz="1100" b="0">
+              <a:rPr sz="1200" b="0">
                 <a:solidFill>
                   <a:srgbClr val="333333"/>
                 </a:solidFill>
@@ -20258,7 +21317,7 @@
           <a:p>
             <a:pPr algn="ctr"/>
             <a:r>
-              <a:rPr sz="1100" b="0">
+              <a:rPr sz="1200" b="0">
                 <a:solidFill>
                   <a:srgbClr val="333333"/>
                 </a:solidFill>
@@ -20270,7 +21329,7 @@
       </p:sp>
       <p:sp>
         <p:nvSpPr>
-          <p:cNvPr id="18" name="Rectangle 17"/>
+          <p:cNvPr id="20" name="Rectangle 19"/>
           <p:cNvSpPr/>
           <p:nvPr/>
         </p:nvSpPr>
@@ -20316,7 +21375,7 @@
       </p:sp>
       <p:sp>
         <p:nvSpPr>
-          <p:cNvPr id="19" name="Rectangle 18"/>
+          <p:cNvPr id="21" name="Rectangle 20"/>
           <p:cNvSpPr/>
           <p:nvPr/>
         </p:nvSpPr>
@@ -20360,7 +21419,7 @@
       </p:sp>
       <p:sp>
         <p:nvSpPr>
-          <p:cNvPr id="20" name="TextBox 19"/>
+          <p:cNvPr id="22" name="TextBox 21"/>
           <p:cNvSpPr txBox="1"/>
           <p:nvPr/>
         </p:nvSpPr>
@@ -20394,13 +21453,13 @@
       </p:sp>
       <p:sp>
         <p:nvSpPr>
-          <p:cNvPr id="21" name="TextBox 20"/>
-          <p:cNvSpPr txBox="1"/>
-          <p:nvPr/>
-        </p:nvSpPr>
-        <p:spPr>
-          <a:xfrm>
-            <a:off x="8229600" y="1508760"/>
+          <p:cNvPr id="23" name="TextBox 22"/>
+          <p:cNvSpPr txBox="1"/>
+          <p:nvPr/>
+        </p:nvSpPr>
+        <p:spPr>
+          <a:xfrm>
+            <a:off x="8229600" y="1554480"/>
             <a:ext cx="3794760" cy="365760"/>
           </a:xfrm>
           <a:prstGeom prst="rect">
@@ -20416,7 +21475,7 @@
           <a:p>
             <a:pPr algn="ctr"/>
             <a:r>
-              <a:rPr sz="1600" b="1">
+              <a:rPr sz="1700" b="1">
                 <a:solidFill>
                   <a:srgbClr val="041E42"/>
                 </a:solidFill>
@@ -20428,14 +21487,14 @@
       </p:sp>
       <p:sp>
         <p:nvSpPr>
-          <p:cNvPr id="22" name="TextBox 21"/>
-          <p:cNvSpPr txBox="1"/>
-          <p:nvPr/>
-        </p:nvSpPr>
-        <p:spPr>
-          <a:xfrm>
-            <a:off x="8229600" y="1920240"/>
-            <a:ext cx="3794760" cy="320040"/>
+          <p:cNvPr id="24" name="TextBox 23"/>
+          <p:cNvSpPr txBox="1"/>
+          <p:nvPr/>
+        </p:nvSpPr>
+        <p:spPr>
+          <a:xfrm>
+            <a:off x="8229600" y="1965960"/>
+            <a:ext cx="3794760" cy="274320"/>
           </a:xfrm>
           <a:prstGeom prst="rect">
             <a:avLst/>
@@ -20462,29 +21521,73 @@
       </p:sp>
       <p:sp>
         <p:nvSpPr>
-          <p:cNvPr id="23" name="TextBox 22"/>
-          <p:cNvSpPr txBox="1"/>
-          <p:nvPr/>
-        </p:nvSpPr>
-        <p:spPr>
-          <a:xfrm>
-            <a:off x="8412480" y="2331720"/>
-            <a:ext cx="3429000" cy="1645920"/>
-          </a:xfrm>
-          <a:prstGeom prst="rect">
-            <a:avLst/>
-          </a:prstGeom>
-          <a:noFill/>
-        </p:spPr>
-        <p:txBody>
-          <a:bodyPr wrap="square" anchor="ctr">
-            <a:spAutoFit/>
-          </a:bodyPr>
-          <a:lstStyle/>
-          <a:p>
-            <a:pPr algn="ctr"/>
-            <a:r>
-              <a:rPr sz="1100" b="0">
+          <p:cNvPr id="25" name="Rectangle 24"/>
+          <p:cNvSpPr/>
+          <p:nvPr/>
+        </p:nvSpPr>
+        <p:spPr>
+          <a:xfrm>
+            <a:off x="8686800" y="2331720"/>
+            <a:ext cx="2880360" cy="18288"/>
+          </a:xfrm>
+          <a:prstGeom prst="rect">
+            <a:avLst/>
+          </a:prstGeom>
+          <a:solidFill>
+            <a:srgbClr val="10B981"/>
+          </a:solidFill>
+          <a:ln>
+            <a:noFill/>
+          </a:ln>
+          <a:effectLst/>
+        </p:spPr>
+        <p:style>
+          <a:lnRef idx="1">
+            <a:schemeClr val="accent1"/>
+          </a:lnRef>
+          <a:fillRef idx="3">
+            <a:schemeClr val="accent1"/>
+          </a:fillRef>
+          <a:effectRef idx="2">
+            <a:schemeClr val="accent1"/>
+          </a:effectRef>
+          <a:fontRef idx="minor">
+            <a:schemeClr val="lt1"/>
+          </a:fontRef>
+        </p:style>
+        <p:txBody>
+          <a:bodyPr rtlCol="0" anchor="ctr"/>
+          <a:lstStyle/>
+          <a:p>
+            <a:pPr algn="ctr"/>
+          </a:p>
+        </p:txBody>
+      </p:sp>
+      <p:sp>
+        <p:nvSpPr>
+          <p:cNvPr id="26" name="TextBox 25"/>
+          <p:cNvSpPr txBox="1"/>
+          <p:nvPr/>
+        </p:nvSpPr>
+        <p:spPr>
+          <a:xfrm>
+            <a:off x="8412480" y="2468880"/>
+            <a:ext cx="3429000" cy="1463040"/>
+          </a:xfrm>
+          <a:prstGeom prst="rect">
+            <a:avLst/>
+          </a:prstGeom>
+          <a:noFill/>
+        </p:spPr>
+        <p:txBody>
+          <a:bodyPr wrap="square" anchor="t">
+            <a:spAutoFit/>
+          </a:bodyPr>
+          <a:lstStyle/>
+          <a:p>
+            <a:pPr algn="ctr"/>
+            <a:r>
+              <a:rPr sz="1200" b="0">
                 <a:solidFill>
                   <a:srgbClr val="333333"/>
                 </a:solidFill>
@@ -20495,7 +21598,7 @@
           <a:p>
             <a:pPr algn="ctr"/>
             <a:r>
-              <a:rPr sz="1100" b="0">
+              <a:rPr sz="1200" b="0">
                 <a:solidFill>
                   <a:srgbClr val="333333"/>
                 </a:solidFill>
@@ -20506,7 +21609,7 @@
           <a:p>
             <a:pPr algn="ctr"/>
             <a:r>
-              <a:rPr sz="1100" b="0">
+              <a:rPr sz="1200" b="0">
                 <a:solidFill>
                   <a:srgbClr val="333333"/>
                 </a:solidFill>
@@ -20517,7 +21620,7 @@
           <a:p>
             <a:pPr algn="ctr"/>
             <a:r>
-              <a:rPr sz="1100" b="0">
+              <a:rPr sz="1200" b="0">
                 <a:solidFill>
                   <a:srgbClr val="333333"/>
                 </a:solidFill>
@@ -20529,7 +21632,7 @@
       </p:sp>
       <p:sp>
         <p:nvSpPr>
-          <p:cNvPr id="24" name="Rectangle 23"/>
+          <p:cNvPr id="27" name="Rectangle 26"/>
           <p:cNvSpPr/>
           <p:nvPr/>
         </p:nvSpPr>
@@ -20575,7 +21678,7 @@
       </p:sp>
       <p:sp>
         <p:nvSpPr>
-          <p:cNvPr id="25" name="TextBox 24"/>
+          <p:cNvPr id="28" name="TextBox 27"/>
           <p:cNvSpPr txBox="1"/>
           <p:nvPr/>
         </p:nvSpPr>
@@ -20609,7 +21712,7 @@
       </p:sp>
       <p:sp>
         <p:nvSpPr>
-          <p:cNvPr id="26" name="TextBox 25"/>
+          <p:cNvPr id="29" name="TextBox 28"/>
           <p:cNvSpPr txBox="1"/>
           <p:nvPr/>
         </p:nvSpPr>
@@ -20692,7 +21795,7 @@
       </p:sp>
       <p:sp>
         <p:nvSpPr>
-          <p:cNvPr id="27" name="TextBox 26"/>
+          <p:cNvPr id="30" name="TextBox 29"/>
           <p:cNvSpPr txBox="1"/>
           <p:nvPr/>
         </p:nvSpPr>
@@ -20726,7 +21829,7 @@
       </p:sp>
       <p:sp>
         <p:nvSpPr>
-          <p:cNvPr id="28" name="TextBox 27"/>
+          <p:cNvPr id="31" name="TextBox 30"/>
           <p:cNvSpPr txBox="1"/>
           <p:nvPr/>
         </p:nvSpPr>
@@ -20975,7 +22078,7 @@
         <p:spPr>
           <a:xfrm>
             <a:off x="457200" y="1280160"/>
-            <a:ext cx="11247120" cy="3246120"/>
+            <a:ext cx="7452360" cy="3337560"/>
           </a:xfrm>
           <a:prstGeom prst="rect">
             <a:avLst/>
@@ -21021,7 +22124,7 @@
         <p:spPr>
           <a:xfrm>
             <a:off x="640080" y="1417320"/>
-            <a:ext cx="10881360" cy="2971800"/>
+            <a:ext cx="7086600" cy="3063240"/>
           </a:xfrm>
           <a:prstGeom prst="rect">
             <a:avLst/>
@@ -21036,7 +22139,7 @@
           <a:p>
             <a:pPr algn="l"/>
             <a:r>
-              <a:rPr sz="1000" b="0">
+              <a:rPr sz="1100" b="0">
                 <a:solidFill>
                   <a:srgbClr val="E6EDF7"/>
                 </a:solidFill>
@@ -21047,7 +22150,7 @@
           <a:p>
             <a:pPr algn="l"/>
             <a:r>
-              <a:rPr sz="1000" b="0">
+              <a:rPr sz="1100" b="0">
                 <a:solidFill>
                   <a:srgbClr val="E6EDF7"/>
                 </a:solidFill>
@@ -21058,7 +22161,7 @@
           <a:p>
             <a:pPr algn="l"/>
             <a:r>
-              <a:rPr sz="1000" b="0">
+              <a:rPr sz="1100" b="0">
                 <a:solidFill>
                   <a:srgbClr val="E6EDF7"/>
                 </a:solidFill>
@@ -21069,7 +22172,7 @@
           <a:p>
             <a:pPr algn="l"/>
             <a:r>
-              <a:rPr sz="1000" b="0">
+              <a:rPr sz="1100" b="0">
                 <a:solidFill>
                   <a:srgbClr val="E6EDF7"/>
                 </a:solidFill>
@@ -21080,23 +22183,23 @@
           <a:p>
             <a:pPr algn="l"/>
             <a:r>
-              <a:rPr sz="1000" b="0">
+              <a:rPr sz="1100" b="0">
                 <a:solidFill>
                   <a:srgbClr val="E6EDF7"/>
                 </a:solidFill>
               </a:rPr>
-              <a:t>invite them to DM order details if action is needed. Sign off as</a:t>
+              <a:t>invite them to DM order details if action is needed.</a:t>
             </a:r>
           </a:p>
           <a:p>
             <a:pPr algn="l"/>
             <a:r>
-              <a:rPr sz="1000" b="0">
+              <a:rPr sz="1100" b="0">
                 <a:solidFill>
                   <a:srgbClr val="E6EDF7"/>
                 </a:solidFill>
               </a:rPr>
-              <a:t>a real person, not a brand.</a:t>
+              <a:t>Sign off as a real person, not a brand.</a:t>
             </a:r>
           </a:p>
           <a:p>
@@ -21105,7 +22208,7 @@
           <a:p>
             <a:pPr algn="l"/>
             <a:r>
-              <a:rPr sz="1000" b="0">
+              <a:rPr sz="1100" b="0">
                 <a:solidFill>
                   <a:srgbClr val="E6EDF7"/>
                 </a:solidFill>
@@ -21116,7 +22219,7 @@
           <a:p>
             <a:pPr algn="l"/>
             <a:r>
-              <a:rPr sz="1000" b="0">
+              <a:rPr sz="1100" b="0">
                 <a:solidFill>
                   <a:srgbClr val="E6EDF7"/>
                 </a:solidFill>
@@ -21127,91 +22230,500 @@
           <a:p>
             <a:pPr algn="l"/>
             <a:r>
-              <a:rPr sz="1000" b="0">
+              <a:rPr sz="1100" b="0">
                 <a:solidFill>
                   <a:srgbClr val="E6EDF7"/>
                 </a:solidFill>
               </a:rPr>
-              <a:t>Example customer post: {past_post_2}</a:t>
+              <a:t> …  (three example pairs total)</a:t>
             </a:r>
           </a:p>
           <a:p>
             <a:pPr algn="l"/>
-            <a:r>
-              <a:rPr sz="1000" b="0">
+          </a:p>
+          <a:p>
+            <a:pPr algn="l"/>
+            <a:r>
+              <a:rPr sz="1100" b="0">
                 <a:solidFill>
                   <a:srgbClr val="E6EDF7"/>
                 </a:solidFill>
               </a:rPr>
-              <a:t>Example analyst reply: {past_reply_2}</a:t>
+              <a:t>Subreddit: r/{subreddit}</a:t>
             </a:r>
           </a:p>
           <a:p>
             <a:pPr algn="l"/>
+            <a:r>
+              <a:rPr sz="1100" b="0">
+                <a:solidFill>
+                  <a:srgbClr val="E6EDF7"/>
+                </a:solidFill>
+              </a:rPr>
+              <a:t>Customer ({author}) complaint about: {aspect_1}, {aspect_2}</a:t>
+            </a:r>
           </a:p>
           <a:p>
             <a:pPr algn="l"/>
             <a:r>
-              <a:rPr sz="1000" b="0">
+              <a:rPr sz="1100" b="0">
                 <a:solidFill>
                   <a:srgbClr val="E6EDF7"/>
                 </a:solidFill>
               </a:rPr>
-              <a:t>Subreddit: r/{subreddit}</a:t>
+              <a:t>Customer post: {post_title + post_body, ≤ 1200 chars}</a:t>
             </a:r>
           </a:p>
           <a:p>
             <a:pPr algn="l"/>
-            <a:r>
-              <a:rPr sz="1000" b="0">
+          </a:p>
+          <a:p>
+            <a:pPr algn="l"/>
+            <a:r>
+              <a:rPr sz="1100" b="0">
                 <a:solidFill>
                   <a:srgbClr val="E6EDF7"/>
                 </a:solidFill>
               </a:rPr>
-              <a:t>Customer ({author}) complaint about: {aspect_1}, {aspect_2}</a:t>
-            </a:r>
-          </a:p>
+              <a:t>Reply:</a:t>
+            </a:r>
+          </a:p>
+        </p:txBody>
+      </p:sp>
+      <p:sp>
+        <p:nvSpPr>
+          <p:cNvPr id="9" name="Rectangle 8"/>
+          <p:cNvSpPr/>
+          <p:nvPr/>
+        </p:nvSpPr>
+        <p:spPr>
+          <a:xfrm>
+            <a:off x="8138160" y="1280160"/>
+            <a:ext cx="3566160" cy="3337560"/>
+          </a:xfrm>
+          <a:prstGeom prst="rect">
+            <a:avLst/>
+          </a:prstGeom>
+          <a:solidFill>
+            <a:srgbClr val="E8F4FD"/>
+          </a:solidFill>
+          <a:ln>
+            <a:solidFill>
+              <a:srgbClr val="0071DC"/>
+            </a:solidFill>
+          </a:ln>
+          <a:effectLst/>
+        </p:spPr>
+        <p:style>
+          <a:lnRef idx="1">
+            <a:schemeClr val="accent1"/>
+          </a:lnRef>
+          <a:fillRef idx="3">
+            <a:schemeClr val="accent1"/>
+          </a:fillRef>
+          <a:effectRef idx="2">
+            <a:schemeClr val="accent1"/>
+          </a:effectRef>
+          <a:fontRef idx="minor">
+            <a:schemeClr val="lt1"/>
+          </a:fontRef>
+        </p:style>
+        <p:txBody>
+          <a:bodyPr rtlCol="0" anchor="ctr"/>
+          <a:lstStyle/>
+          <a:p>
+            <a:pPr algn="ctr"/>
+          </a:p>
+        </p:txBody>
+      </p:sp>
+      <p:sp>
+        <p:nvSpPr>
+          <p:cNvPr id="10" name="TextBox 9"/>
+          <p:cNvSpPr txBox="1"/>
+          <p:nvPr/>
+        </p:nvSpPr>
+        <p:spPr>
+          <a:xfrm>
+            <a:off x="8321040" y="1389888"/>
+            <a:ext cx="3200400" cy="320040"/>
+          </a:xfrm>
+          <a:prstGeom prst="rect">
+            <a:avLst/>
+          </a:prstGeom>
+          <a:noFill/>
+        </p:spPr>
+        <p:txBody>
+          <a:bodyPr wrap="square" anchor="t">
+            <a:spAutoFit/>
+          </a:bodyPr>
+          <a:lstStyle/>
           <a:p>
             <a:pPr algn="l"/>
             <a:r>
-              <a:rPr sz="1000" b="0">
-                <a:solidFill>
-                  <a:srgbClr val="E6EDF7"/>
-                </a:solidFill>
-              </a:rPr>
-              <a:t>Customer post:</a:t>
-            </a:r>
-          </a:p>
+              <a:rPr sz="1100" b="1">
+                <a:solidFill>
+                  <a:srgbClr val="0071DC"/>
+                </a:solidFill>
+              </a:rPr>
+              <a:t>PROMPT ANATOMY</a:t>
+            </a:r>
+          </a:p>
+        </p:txBody>
+      </p:sp>
+      <p:sp>
+        <p:nvSpPr>
+          <p:cNvPr id="11" name="TextBox 10"/>
+          <p:cNvSpPr txBox="1"/>
+          <p:nvPr/>
+        </p:nvSpPr>
+        <p:spPr>
+          <a:xfrm>
+            <a:off x="8321040" y="1783080"/>
+            <a:ext cx="3200400" cy="182880"/>
+          </a:xfrm>
+          <a:prstGeom prst="rect">
+            <a:avLst/>
+          </a:prstGeom>
+          <a:noFill/>
+        </p:spPr>
+        <p:txBody>
+          <a:bodyPr wrap="square" anchor="t">
+            <a:spAutoFit/>
+          </a:bodyPr>
+          <a:lstStyle/>
           <a:p>
             <a:pPr algn="l"/>
             <a:r>
-              <a:rPr sz="1000" b="0">
-                <a:solidFill>
-                  <a:srgbClr val="E6EDF7"/>
-                </a:solidFill>
-              </a:rPr>
-              <a:t>{post_title + post_body, ≤ 1200 chars}</a:t>
-            </a:r>
-          </a:p>
+              <a:rPr sz="1000" b="1">
+                <a:solidFill>
+                  <a:srgbClr val="0071DC"/>
+                </a:solidFill>
+              </a:rPr>
+              <a:t>① SYSTEM ROLE</a:t>
+            </a:r>
+          </a:p>
+        </p:txBody>
+      </p:sp>
+      <p:sp>
+        <p:nvSpPr>
+          <p:cNvPr id="12" name="TextBox 11"/>
+          <p:cNvSpPr txBox="1"/>
+          <p:nvPr/>
+        </p:nvSpPr>
+        <p:spPr>
+          <a:xfrm>
+            <a:off x="8321040" y="1984248"/>
+            <a:ext cx="3200400" cy="320040"/>
+          </a:xfrm>
+          <a:prstGeom prst="rect">
+            <a:avLst/>
+          </a:prstGeom>
+          <a:noFill/>
+        </p:spPr>
+        <p:txBody>
+          <a:bodyPr wrap="square" anchor="t">
+            <a:spAutoFit/>
+          </a:bodyPr>
+          <a:lstStyle/>
           <a:p>
             <a:pPr algn="l"/>
-          </a:p>
+            <a:r>
+              <a:rPr sz="900" b="0">
+                <a:solidFill>
+                  <a:srgbClr val="333333"/>
+                </a:solidFill>
+              </a:rPr>
+              <a:t>who the model is + tone rules</a:t>
+            </a:r>
+          </a:p>
+        </p:txBody>
+      </p:sp>
+      <p:sp>
+        <p:nvSpPr>
+          <p:cNvPr id="13" name="TextBox 12"/>
+          <p:cNvSpPr txBox="1"/>
+          <p:nvPr/>
+        </p:nvSpPr>
+        <p:spPr>
+          <a:xfrm>
+            <a:off x="8321040" y="2313432"/>
+            <a:ext cx="3200400" cy="182880"/>
+          </a:xfrm>
+          <a:prstGeom prst="rect">
+            <a:avLst/>
+          </a:prstGeom>
+          <a:noFill/>
+        </p:spPr>
+        <p:txBody>
+          <a:bodyPr wrap="square" anchor="t">
+            <a:spAutoFit/>
+          </a:bodyPr>
+          <a:lstStyle/>
           <a:p>
             <a:pPr algn="l"/>
             <a:r>
-              <a:rPr sz="1000" b="0">
-                <a:solidFill>
-                  <a:srgbClr val="E6EDF7"/>
-                </a:solidFill>
-              </a:rPr>
-              <a:t>Reply:</a:t>
-            </a:r>
-          </a:p>
-        </p:txBody>
-      </p:sp>
-      <p:sp>
-        <p:nvSpPr>
-          <p:cNvPr id="9" name="Rectangle 8"/>
+              <a:rPr sz="1000" b="1">
+                <a:solidFill>
+                  <a:srgbClr val="7C3AED"/>
+                </a:solidFill>
+              </a:rPr>
+              <a:t>② FEW-SHOT</a:t>
+            </a:r>
+          </a:p>
+        </p:txBody>
+      </p:sp>
+      <p:sp>
+        <p:nvSpPr>
+          <p:cNvPr id="14" name="TextBox 13"/>
+          <p:cNvSpPr txBox="1"/>
+          <p:nvPr/>
+        </p:nvSpPr>
+        <p:spPr>
+          <a:xfrm>
+            <a:off x="8321040" y="2514600"/>
+            <a:ext cx="3200400" cy="320040"/>
+          </a:xfrm>
+          <a:prstGeom prst="rect">
+            <a:avLst/>
+          </a:prstGeom>
+          <a:noFill/>
+        </p:spPr>
+        <p:txBody>
+          <a:bodyPr wrap="square" anchor="t">
+            <a:spAutoFit/>
+          </a:bodyPr>
+          <a:lstStyle/>
+          <a:p>
+            <a:pPr algn="l"/>
+            <a:r>
+              <a:rPr sz="900" b="0">
+                <a:solidFill>
+                  <a:srgbClr val="333333"/>
+                </a:solidFill>
+              </a:rPr>
+              <a:t>3 past validated reply pairs</a:t>
+            </a:r>
+          </a:p>
+          <a:p>
+            <a:pPr algn="l"/>
+            <a:r>
+              <a:rPr sz="900" b="0">
+                <a:solidFill>
+                  <a:srgbClr val="333333"/>
+                </a:solidFill>
+              </a:rPr>
+              <a:t>from the feedback table</a:t>
+            </a:r>
+          </a:p>
+        </p:txBody>
+      </p:sp>
+      <p:sp>
+        <p:nvSpPr>
+          <p:cNvPr id="15" name="TextBox 14"/>
+          <p:cNvSpPr txBox="1"/>
+          <p:nvPr/>
+        </p:nvSpPr>
+        <p:spPr>
+          <a:xfrm>
+            <a:off x="8321040" y="2843784"/>
+            <a:ext cx="3200400" cy="182880"/>
+          </a:xfrm>
+          <a:prstGeom prst="rect">
+            <a:avLst/>
+          </a:prstGeom>
+          <a:noFill/>
+        </p:spPr>
+        <p:txBody>
+          <a:bodyPr wrap="square" anchor="t">
+            <a:spAutoFit/>
+          </a:bodyPr>
+          <a:lstStyle/>
+          <a:p>
+            <a:pPr algn="l"/>
+            <a:r>
+              <a:rPr sz="1000" b="1">
+                <a:solidFill>
+                  <a:srgbClr val="D97706"/>
+                </a:solidFill>
+              </a:rPr>
+              <a:t>③ CONTEXT</a:t>
+            </a:r>
+          </a:p>
+        </p:txBody>
+      </p:sp>
+      <p:sp>
+        <p:nvSpPr>
+          <p:cNvPr id="16" name="TextBox 15"/>
+          <p:cNvSpPr txBox="1"/>
+          <p:nvPr/>
+        </p:nvSpPr>
+        <p:spPr>
+          <a:xfrm>
+            <a:off x="8321040" y="3044952"/>
+            <a:ext cx="3200400" cy="320040"/>
+          </a:xfrm>
+          <a:prstGeom prst="rect">
+            <a:avLst/>
+          </a:prstGeom>
+          <a:noFill/>
+        </p:spPr>
+        <p:txBody>
+          <a:bodyPr wrap="square" anchor="t">
+            <a:spAutoFit/>
+          </a:bodyPr>
+          <a:lstStyle/>
+          <a:p>
+            <a:pPr algn="l"/>
+            <a:r>
+              <a:rPr sz="900" b="0">
+                <a:solidFill>
+                  <a:srgbClr val="333333"/>
+                </a:solidFill>
+              </a:rPr>
+              <a:t>subreddit · author · top-2 aspects</a:t>
+            </a:r>
+          </a:p>
+        </p:txBody>
+      </p:sp>
+      <p:sp>
+        <p:nvSpPr>
+          <p:cNvPr id="17" name="TextBox 16"/>
+          <p:cNvSpPr txBox="1"/>
+          <p:nvPr/>
+        </p:nvSpPr>
+        <p:spPr>
+          <a:xfrm>
+            <a:off x="8321040" y="3374136"/>
+            <a:ext cx="3200400" cy="182880"/>
+          </a:xfrm>
+          <a:prstGeom prst="rect">
+            <a:avLst/>
+          </a:prstGeom>
+          <a:noFill/>
+        </p:spPr>
+        <p:txBody>
+          <a:bodyPr wrap="square" anchor="t">
+            <a:spAutoFit/>
+          </a:bodyPr>
+          <a:lstStyle/>
+          <a:p>
+            <a:pPr algn="l"/>
+            <a:r>
+              <a:rPr sz="1000" b="1">
+                <a:solidFill>
+                  <a:srgbClr val="10B981"/>
+                </a:solidFill>
+              </a:rPr>
+              <a:t>④ POST</a:t>
+            </a:r>
+          </a:p>
+        </p:txBody>
+      </p:sp>
+      <p:sp>
+        <p:nvSpPr>
+          <p:cNvPr id="18" name="TextBox 17"/>
+          <p:cNvSpPr txBox="1"/>
+          <p:nvPr/>
+        </p:nvSpPr>
+        <p:spPr>
+          <a:xfrm>
+            <a:off x="8321040" y="3575304"/>
+            <a:ext cx="3200400" cy="320040"/>
+          </a:xfrm>
+          <a:prstGeom prst="rect">
+            <a:avLst/>
+          </a:prstGeom>
+          <a:noFill/>
+        </p:spPr>
+        <p:txBody>
+          <a:bodyPr wrap="square" anchor="t">
+            <a:spAutoFit/>
+          </a:bodyPr>
+          <a:lstStyle/>
+          <a:p>
+            <a:pPr algn="l"/>
+            <a:r>
+              <a:rPr sz="900" b="0">
+                <a:solidFill>
+                  <a:srgbClr val="333333"/>
+                </a:solidFill>
+              </a:rPr>
+              <a:t>title + body,  truncated to 1 200 chars</a:t>
+            </a:r>
+          </a:p>
+        </p:txBody>
+      </p:sp>
+      <p:sp>
+        <p:nvSpPr>
+          <p:cNvPr id="19" name="TextBox 18"/>
+          <p:cNvSpPr txBox="1"/>
+          <p:nvPr/>
+        </p:nvSpPr>
+        <p:spPr>
+          <a:xfrm>
+            <a:off x="8321040" y="3904488"/>
+            <a:ext cx="3200400" cy="182880"/>
+          </a:xfrm>
+          <a:prstGeom prst="rect">
+            <a:avLst/>
+          </a:prstGeom>
+          <a:noFill/>
+        </p:spPr>
+        <p:txBody>
+          <a:bodyPr wrap="square" anchor="t">
+            <a:spAutoFit/>
+          </a:bodyPr>
+          <a:lstStyle/>
+          <a:p>
+            <a:pPr algn="l"/>
+            <a:r>
+              <a:rPr sz="1000" b="1">
+                <a:solidFill>
+                  <a:srgbClr val="EF4444"/>
+                </a:solidFill>
+              </a:rPr>
+              <a:t>⑤ TRIGGER</a:t>
+            </a:r>
+          </a:p>
+        </p:txBody>
+      </p:sp>
+      <p:sp>
+        <p:nvSpPr>
+          <p:cNvPr id="20" name="TextBox 19"/>
+          <p:cNvSpPr txBox="1"/>
+          <p:nvPr/>
+        </p:nvSpPr>
+        <p:spPr>
+          <a:xfrm>
+            <a:off x="8321040" y="4105656"/>
+            <a:ext cx="3200400" cy="320040"/>
+          </a:xfrm>
+          <a:prstGeom prst="rect">
+            <a:avLst/>
+          </a:prstGeom>
+          <a:noFill/>
+        </p:spPr>
+        <p:txBody>
+          <a:bodyPr wrap="square" anchor="t">
+            <a:spAutoFit/>
+          </a:bodyPr>
+          <a:lstStyle/>
+          <a:p>
+            <a:pPr algn="l"/>
+            <a:r>
+              <a:rPr sz="900" b="0">
+                <a:solidFill>
+                  <a:srgbClr val="333333"/>
+                </a:solidFill>
+              </a:rPr>
+              <a:t>"Reply:"  cues the model to generate</a:t>
+            </a:r>
+          </a:p>
+        </p:txBody>
+      </p:sp>
+      <p:sp>
+        <p:nvSpPr>
+          <p:cNvPr id="21" name="Rectangle 20"/>
           <p:cNvSpPr/>
           <p:nvPr/>
         </p:nvSpPr>
@@ -21257,7 +22769,7 @@
       </p:sp>
       <p:sp>
         <p:nvSpPr>
-          <p:cNvPr id="10" name="TextBox 9"/>
+          <p:cNvPr id="22" name="TextBox 21"/>
           <p:cNvSpPr txBox="1"/>
           <p:nvPr/>
         </p:nvSpPr>
@@ -21291,7 +22803,7 @@
       </p:sp>
       <p:sp>
         <p:nvSpPr>
-          <p:cNvPr id="11" name="TextBox 10"/>
+          <p:cNvPr id="23" name="TextBox 22"/>
           <p:cNvSpPr txBox="1"/>
           <p:nvPr/>
         </p:nvSpPr>
@@ -21359,7 +22871,7 @@
       </p:sp>
       <p:sp>
         <p:nvSpPr>
-          <p:cNvPr id="12" name="Rectangle 11"/>
+          <p:cNvPr id="24" name="Rectangle 23"/>
           <p:cNvSpPr/>
           <p:nvPr/>
         </p:nvSpPr>
@@ -21405,7 +22917,7 @@
       </p:sp>
       <p:sp>
         <p:nvSpPr>
-          <p:cNvPr id="13" name="TextBox 12"/>
+          <p:cNvPr id="25" name="TextBox 24"/>
           <p:cNvSpPr txBox="1"/>
           <p:nvPr/>
         </p:nvSpPr>
@@ -21439,7 +22951,7 @@
       </p:sp>
       <p:sp>
         <p:nvSpPr>
-          <p:cNvPr id="14" name="TextBox 13"/>
+          <p:cNvPr id="26" name="TextBox 25"/>
           <p:cNvSpPr txBox="1"/>
           <p:nvPr/>
         </p:nvSpPr>
@@ -21522,7 +23034,7 @@
       </p:sp>
       <p:sp>
         <p:nvSpPr>
-          <p:cNvPr id="15" name="TextBox 14"/>
+          <p:cNvPr id="27" name="TextBox 26"/>
           <p:cNvSpPr txBox="1"/>
           <p:nvPr/>
         </p:nvSpPr>
@@ -21556,7 +23068,7 @@
       </p:sp>
       <p:sp>
         <p:nvSpPr>
-          <p:cNvPr id="16" name="TextBox 15"/>
+          <p:cNvPr id="28" name="TextBox 27"/>
           <p:cNvSpPr txBox="1"/>
           <p:nvPr/>
         </p:nvSpPr>
@@ -21988,7 +23500,7 @@
         <p:spPr>
           <a:xfrm>
             <a:off x="365760" y="2788920"/>
-            <a:ext cx="3794760" cy="2880360"/>
+            <a:ext cx="3794760" cy="2423160"/>
           </a:xfrm>
           <a:prstGeom prst="rect">
             <a:avLst/>
@@ -22111,8 +23623,8 @@
         </p:nvSpPr>
         <p:spPr>
           <a:xfrm>
-            <a:off x="502920" y="3246120"/>
-            <a:ext cx="3520440" cy="2331720"/>
+            <a:off x="502920" y="3264408"/>
+            <a:ext cx="3520440" cy="1874520"/>
           </a:xfrm>
           <a:prstGeom prst="rect">
             <a:avLst/>
@@ -22127,7 +23639,7 @@
           <a:p>
             <a:pPr algn="l"/>
             <a:r>
-              <a:rPr sz="900" b="0">
+              <a:rPr sz="1000" b="0">
                 <a:solidFill>
                   <a:srgbClr val="333333"/>
                 </a:solidFill>
@@ -22146,7 +23658,7 @@
         <p:spPr>
           <a:xfrm>
             <a:off x="4297680" y="2788920"/>
-            <a:ext cx="3794760" cy="2880360"/>
+            <a:ext cx="3794760" cy="2423160"/>
           </a:xfrm>
           <a:prstGeom prst="rect">
             <a:avLst/>
@@ -22269,8 +23781,8 @@
         </p:nvSpPr>
         <p:spPr>
           <a:xfrm>
-            <a:off x="4434840" y="3246120"/>
-            <a:ext cx="3520440" cy="2331720"/>
+            <a:off x="4434840" y="3264408"/>
+            <a:ext cx="3520440" cy="1874520"/>
           </a:xfrm>
           <a:prstGeom prst="rect">
             <a:avLst/>
@@ -22285,7 +23797,7 @@
           <a:p>
             <a:pPr algn="l"/>
             <a:r>
-              <a:rPr sz="900" b="0">
+              <a:rPr sz="1000" b="0">
                 <a:solidFill>
                   <a:srgbClr val="333333"/>
                 </a:solidFill>
@@ -22304,7 +23816,7 @@
         <p:spPr>
           <a:xfrm>
             <a:off x="8229600" y="2788920"/>
-            <a:ext cx="3794760" cy="2880360"/>
+            <a:ext cx="3794760" cy="2423160"/>
           </a:xfrm>
           <a:prstGeom prst="rect">
             <a:avLst/>
@@ -22427,8 +23939,8 @@
         </p:nvSpPr>
         <p:spPr>
           <a:xfrm>
-            <a:off x="8366760" y="3246120"/>
-            <a:ext cx="3520440" cy="2331720"/>
+            <a:off x="8366760" y="3264408"/>
+            <a:ext cx="3520440" cy="1874520"/>
           </a:xfrm>
           <a:prstGeom prst="rect">
             <a:avLst/>
@@ -22443,7 +23955,7 @@
           <a:p>
             <a:pPr algn="l"/>
             <a:r>
-              <a:rPr sz="900" b="0">
+              <a:rPr sz="1000" b="0">
                 <a:solidFill>
                   <a:srgbClr val="333333"/>
                 </a:solidFill>
@@ -22461,8 +23973,8 @@
         </p:nvSpPr>
         <p:spPr>
           <a:xfrm>
-            <a:off x="457200" y="5806440"/>
-            <a:ext cx="11247120" cy="548640"/>
+            <a:off x="457200" y="5394960"/>
+            <a:ext cx="11247120" cy="960120"/>
           </a:xfrm>
           <a:prstGeom prst="rect">
             <a:avLst/>
@@ -22507,23 +24019,57 @@
         </p:nvSpPr>
         <p:spPr>
           <a:xfrm>
-            <a:off x="640080" y="5852160"/>
-            <a:ext cx="10972800" cy="457200"/>
-          </a:xfrm>
-          <a:prstGeom prst="rect">
-            <a:avLst/>
-          </a:prstGeom>
-          <a:noFill/>
-        </p:spPr>
-        <p:txBody>
-          <a:bodyPr wrap="square" anchor="ctr">
+            <a:off x="640080" y="5468112"/>
+            <a:ext cx="10972800" cy="320040"/>
+          </a:xfrm>
+          <a:prstGeom prst="rect">
+            <a:avLst/>
+          </a:prstGeom>
+          <a:noFill/>
+        </p:spPr>
+        <p:txBody>
+          <a:bodyPr wrap="square" anchor="t">
             <a:spAutoFit/>
           </a:bodyPr>
           <a:lstStyle/>
           <a:p>
             <a:pPr algn="l"/>
             <a:r>
-              <a:rPr sz="1000" b="0">
+              <a:rPr sz="1100" b="1">
+                <a:solidFill>
+                  <a:srgbClr val="0071DC"/>
+                </a:solidFill>
+              </a:rPr>
+              <a:t>WHAT HAPPENS NEXT</a:t>
+            </a:r>
+          </a:p>
+        </p:txBody>
+      </p:sp>
+      <p:sp>
+        <p:nvSpPr>
+          <p:cNvPr id="26" name="TextBox 25"/>
+          <p:cNvSpPr txBox="1"/>
+          <p:nvPr/>
+        </p:nvSpPr>
+        <p:spPr>
+          <a:xfrm>
+            <a:off x="640080" y="5760720"/>
+            <a:ext cx="10972800" cy="548640"/>
+          </a:xfrm>
+          <a:prstGeom prst="rect">
+            <a:avLst/>
+          </a:prstGeom>
+          <a:noFill/>
+        </p:spPr>
+        <p:txBody>
+          <a:bodyPr wrap="square" anchor="t">
+            <a:spAutoFit/>
+          </a:bodyPr>
+          <a:lstStyle/>
+          <a:p>
+            <a:pPr algn="l"/>
+            <a:r>
+              <a:rPr sz="1100" b="0">
                 <a:solidFill>
                   <a:srgbClr val="333333"/>
                 </a:solidFill>
@@ -22535,7 +24081,7 @@
       </p:sp>
       <p:sp>
         <p:nvSpPr>
-          <p:cNvPr id="26" name="TextBox 25"/>
+          <p:cNvPr id="27" name="TextBox 26"/>
           <p:cNvSpPr txBox="1"/>
           <p:nvPr/>
         </p:nvSpPr>
@@ -22569,7 +24115,7 @@
       </p:sp>
       <p:sp>
         <p:nvSpPr>
-          <p:cNvPr id="27" name="TextBox 26"/>
+          <p:cNvPr id="28" name="TextBox 27"/>
           <p:cNvSpPr txBox="1"/>
           <p:nvPr/>
         </p:nvSpPr>
@@ -24207,7 +25753,7 @@
         </p:nvSpPr>
         <p:spPr>
           <a:xfrm>
-            <a:off x="457200" y="960120"/>
+            <a:off x="457200" y="914400"/>
             <a:ext cx="5486400" cy="320040"/>
           </a:xfrm>
           <a:prstGeom prst="rect">
@@ -24223,12 +25769,12 @@
           <a:p>
             <a:pPr algn="l"/>
             <a:r>
-              <a:rPr sz="1300" b="1">
-                <a:solidFill>
-                  <a:srgbClr val="041E42"/>
-                </a:solidFill>
-              </a:rPr>
-              <a:t>Facets</a:t>
+              <a:rPr sz="1100" b="1">
+                <a:solidFill>
+                  <a:srgbClr val="0071DC"/>
+                </a:solidFill>
+              </a:rPr>
+              <a:t>FACETS</a:t>
             </a:r>
           </a:p>
         </p:txBody>
@@ -24241,8 +25787,8 @@
         </p:nvSpPr>
         <p:spPr>
           <a:xfrm>
-            <a:off x="457200" y="1280160"/>
-            <a:ext cx="5486400" cy="3474720"/>
+            <a:off x="457200" y="1234440"/>
+            <a:ext cx="5486400" cy="2468880"/>
           </a:xfrm>
           <a:prstGeom prst="rect">
             <a:avLst/>
@@ -24377,7 +25923,7 @@
         </p:blipFill>
         <p:spPr>
           <a:xfrm>
-            <a:off x="6172200" y="960120"/>
+            <a:off x="6172200" y="914400"/>
             <a:ext cx="5669280" cy="3543300"/>
           </a:xfrm>
           <a:prstGeom prst="rect">
@@ -24393,8 +25939,8 @@
         </p:nvSpPr>
         <p:spPr>
           <a:xfrm>
-            <a:off x="457200" y="5074920"/>
-            <a:ext cx="11247120" cy="1234440"/>
+            <a:off x="457200" y="3840480"/>
+            <a:ext cx="5486400" cy="1371600"/>
           </a:xfrm>
           <a:prstGeom prst="rect">
             <a:avLst/>
@@ -24439,8 +25985,8 @@
         </p:nvSpPr>
         <p:spPr>
           <a:xfrm>
-            <a:off x="640080" y="5212080"/>
-            <a:ext cx="10972800" cy="320040"/>
+            <a:off x="640080" y="3950208"/>
+            <a:ext cx="5120640" cy="320040"/>
           </a:xfrm>
           <a:prstGeom prst="rect">
             <a:avLst/>
@@ -24455,12 +26001,12 @@
           <a:p>
             <a:pPr algn="l"/>
             <a:r>
-              <a:rPr sz="1200" b="1">
-                <a:solidFill>
-                  <a:srgbClr val="041E42"/>
-                </a:solidFill>
-              </a:rPr>
-              <a:t>Per-post card</a:t>
+              <a:rPr sz="1100" b="1">
+                <a:solidFill>
+                  <a:srgbClr val="0071DC"/>
+                </a:solidFill>
+              </a:rPr>
+              <a:t>PER-POST CARD</a:t>
             </a:r>
           </a:p>
         </p:txBody>
@@ -24473,8 +26019,8 @@
         </p:nvSpPr>
         <p:spPr>
           <a:xfrm>
-            <a:off x="640080" y="5532120"/>
-            <a:ext cx="10972800" cy="731520"/>
+            <a:off x="640080" y="4251960"/>
+            <a:ext cx="5120640" cy="914400"/>
           </a:xfrm>
           <a:prstGeom prst="rect">
             <a:avLst/>
@@ -24494,14 +26040,128 @@
                   <a:srgbClr val="333333"/>
                 </a:solidFill>
               </a:rPr>
-              <a:t>Title + body excerpt · sentiment badge with confidence % · trust tier (H / M / L) · aspect chips · subreddit + timestamp · actions:  Review  ·  Add to Lifecycle  ·  View Details.</a:t>
-            </a:r>
-          </a:p>
-        </p:txBody>
-      </p:sp>
-      <p:sp>
-        <p:nvSpPr>
-          <p:cNvPr id="12" name="TextBox 11"/>
+              <a:t>Title + body excerpt  ·  sentiment badge with confidence %  ·  trust tier (H / M / L)  ·  aspect chips  ·  subreddit + timestamp  ·  actions:  Review · Add to Lifecycle · View Details.</a:t>
+            </a:r>
+          </a:p>
+        </p:txBody>
+      </p:sp>
+      <p:sp>
+        <p:nvSpPr>
+          <p:cNvPr id="12" name="Rectangle 11"/>
+          <p:cNvSpPr/>
+          <p:nvPr/>
+        </p:nvSpPr>
+        <p:spPr>
+          <a:xfrm>
+            <a:off x="457200" y="5349240"/>
+            <a:ext cx="5486400" cy="1051560"/>
+          </a:xfrm>
+          <a:prstGeom prst="rect">
+            <a:avLst/>
+          </a:prstGeom>
+          <a:solidFill>
+            <a:srgbClr val="E8F4FD"/>
+          </a:solidFill>
+          <a:ln>
+            <a:solidFill>
+              <a:srgbClr val="0071DC"/>
+            </a:solidFill>
+          </a:ln>
+          <a:effectLst/>
+        </p:spPr>
+        <p:style>
+          <a:lnRef idx="1">
+            <a:schemeClr val="accent1"/>
+          </a:lnRef>
+          <a:fillRef idx="3">
+            <a:schemeClr val="accent1"/>
+          </a:fillRef>
+          <a:effectRef idx="2">
+            <a:schemeClr val="accent1"/>
+          </a:effectRef>
+          <a:fontRef idx="minor">
+            <a:schemeClr val="lt1"/>
+          </a:fontRef>
+        </p:style>
+        <p:txBody>
+          <a:bodyPr rtlCol="0" anchor="ctr"/>
+          <a:lstStyle/>
+          <a:p>
+            <a:pPr algn="ctr"/>
+          </a:p>
+        </p:txBody>
+      </p:sp>
+      <p:sp>
+        <p:nvSpPr>
+          <p:cNvPr id="13" name="TextBox 12"/>
+          <p:cNvSpPr txBox="1"/>
+          <p:nvPr/>
+        </p:nvSpPr>
+        <p:spPr>
+          <a:xfrm>
+            <a:off x="640080" y="5440680"/>
+            <a:ext cx="5120640" cy="320040"/>
+          </a:xfrm>
+          <a:prstGeom prst="rect">
+            <a:avLst/>
+          </a:prstGeom>
+          <a:noFill/>
+        </p:spPr>
+        <p:txBody>
+          <a:bodyPr wrap="square" anchor="t">
+            <a:spAutoFit/>
+          </a:bodyPr>
+          <a:lstStyle/>
+          <a:p>
+            <a:pPr algn="l"/>
+            <a:r>
+              <a:rPr sz="1100" b="1">
+                <a:solidFill>
+                  <a:srgbClr val="0071DC"/>
+                </a:solidFill>
+              </a:rPr>
+              <a:t>CATALOG TODAY  (live capture)</a:t>
+            </a:r>
+          </a:p>
+        </p:txBody>
+      </p:sp>
+      <p:sp>
+        <p:nvSpPr>
+          <p:cNvPr id="14" name="TextBox 13"/>
+          <p:cNvSpPr txBox="1"/>
+          <p:nvPr/>
+        </p:nvSpPr>
+        <p:spPr>
+          <a:xfrm>
+            <a:off x="640080" y="5742432"/>
+            <a:ext cx="5120640" cy="640080"/>
+          </a:xfrm>
+          <a:prstGeom prst="rect">
+            <a:avLst/>
+          </a:prstGeom>
+          <a:noFill/>
+        </p:spPr>
+        <p:txBody>
+          <a:bodyPr wrap="square" anchor="t">
+            <a:spAutoFit/>
+          </a:bodyPr>
+          <a:lstStyle/>
+          <a:p>
+            <a:pPr algn="l"/>
+            <a:r>
+              <a:rPr sz="1100" b="0">
+                <a:solidFill>
+                  <a:srgbClr val="333333"/>
+                </a:solidFill>
+              </a:rPr>
+              <a:t>83 006 analysed posts  ·  25 subreddits  ·  8 aspects  ·  results paginated at 50 / query.</a:t>
+            </a:r>
+          </a:p>
+        </p:txBody>
+      </p:sp>
+      <p:sp>
+        <p:nvSpPr>
+          <p:cNvPr id="15" name="TextBox 14"/>
           <p:cNvSpPr txBox="1"/>
           <p:nvPr/>
         </p:nvSpPr>
@@ -24535,7 +26195,7 @@
       </p:sp>
       <p:sp>
         <p:nvSpPr>
-          <p:cNvPr id="13" name="TextBox 12"/>
+          <p:cNvPr id="16" name="TextBox 15"/>
           <p:cNvSpPr txBox="1"/>
           <p:nvPr/>
         </p:nvSpPr>

</xml_diff>